<commit_message>
Add market examples and practical fold/material slides to template deck
Co-Authored-By: Claude Opus 5.5 <noreply@anthropic.com>
Claude-Session: https://claude.ai/code/session_01AHTaFDu9kUfR2hK38q6H2d
</commit_message>
<xml_diff>
--- a/lecture-from-cube-to-box-template.pptx
+++ b/lecture-from-cube-to-box-template.pptx
@@ -39,6 +39,12 @@
     <p:sldId id="281" r:id="rId33"/>
     <p:sldId id="282" r:id="rId34"/>
     <p:sldId id="283" r:id="rId35"/>
+    <p:sldId id="284" r:id="rId36"/>
+    <p:sldId id="285" r:id="rId37"/>
+    <p:sldId id="286" r:id="rId38"/>
+    <p:sldId id="287" r:id="rId39"/>
+    <p:sldId id="288" r:id="rId40"/>
+    <p:sldId id="289" r:id="rId41"/>
   </p:sldIdLst>
   <p:sldSz cx="12192000" cy="6858000"/>
   <p:notesSz cx="6858000" cy="9144000"/>
@@ -801,6 +807,286 @@
           <a:lstStyle/>
           <a:p>
             <a:r>
+              <a:t>ليّ الوجهين المتقابلين (Twisting Opposite Faces): يُلوى الوجهان العلوي والسفلي ليًّا خفيفًا في اتجاهين متعاكسين، فتتحوّل الجوانب إلى متوازيات أضلاع. وزاوية الميل المثلى ٨٠°، والزوايا الأقل من ٧٠° نادرًا ما تنجح.</a:t>
+            </a:r>
+          </a:p>
+        </p:txBody>
+      </p:sp>
+      <p:sp>
+        <p:nvSpPr>
+          <p:cNvPr id="4" name="Slide Number Placeholder 3"/>
+          <p:cNvSpPr>
+            <a:spLocks noGrp="1"/>
+          </p:cNvSpPr>
+          <p:nvPr>
+            <p:ph type="sldNum" idx="5" sz="quarter"/>
+          </p:nvPr>
+        </p:nvSpPr>
+        <p:spPr/>
+      </p:sp>
+    </p:spTree>
+  </p:cSld>
+  <p:clrMapOvr>
+    <a:masterClrMapping/>
+  </p:clrMapOvr>
+</p:notes>
+</file>
+
+<file path=ppt/notesSlides/notesSlide11.xml><?xml version="1.0" encoding="utf-8"?>
+<p:notes xmlns:a="http://schemas.openxmlformats.org/drawingml/2006/main" xmlns:p="http://schemas.openxmlformats.org/presentationml/2006/main" xmlns:r="http://schemas.openxmlformats.org/officeDocument/2006/relationships">
+  <p:cSld>
+    <p:spTree>
+      <p:nvGrpSpPr>
+        <p:cNvPr id="1" name=""/>
+        <p:cNvGrpSpPr/>
+        <p:nvPr/>
+      </p:nvGrpSpPr>
+      <p:grpSpPr>
+        <a:xfrm>
+          <a:off x="0" y="0"/>
+          <a:ext cx="0" cy="0"/>
+          <a:chOff x="0" y="0"/>
+          <a:chExt cx="0" cy="0"/>
+        </a:xfrm>
+      </p:grpSpPr>
+      <p:sp>
+        <p:nvSpPr>
+          <p:cNvPr id="2" name="Slide Image Placeholder 1"/>
+          <p:cNvSpPr>
+            <a:spLocks noGrp="1"/>
+          </p:cNvSpPr>
+          <p:nvPr>
+            <p:ph type="sldImg" idx="2"/>
+          </p:nvPr>
+        </p:nvSpPr>
+        <p:spPr/>
+      </p:sp>
+      <p:sp>
+        <p:nvSpPr>
+          <p:cNvPr id="3" name="Notes Placeholder 2"/>
+          <p:cNvSpPr>
+            <a:spLocks noGrp="1"/>
+          </p:cNvSpPr>
+          <p:nvPr>
+            <p:ph type="body" idx="3" sz="quarter"/>
+          </p:nvPr>
+        </p:nvSpPr>
+        <p:spPr/>
+        <p:txBody>
+          <a:bodyPr/>
+          <a:lstStyle/>
+          <a:p>
+            <a:r>
+              <a:t>الليّ: النسخة المُضلَّعة (Twisting: Faceted Version): يُزاد الليّ حتى تقع أركان المربع العلوي فوق منتصفات حواف المربع السفلي، ثم تُوصل الأركان الثمانية بخطوط طي.</a:t>
+            </a:r>
+          </a:p>
+        </p:txBody>
+      </p:sp>
+      <p:sp>
+        <p:nvSpPr>
+          <p:cNvPr id="4" name="Slide Number Placeholder 3"/>
+          <p:cNvSpPr>
+            <a:spLocks noGrp="1"/>
+          </p:cNvSpPr>
+          <p:nvPr>
+            <p:ph type="sldNum" idx="5" sz="quarter"/>
+          </p:nvPr>
+        </p:nvSpPr>
+        <p:spPr/>
+      </p:sp>
+    </p:spTree>
+  </p:cSld>
+  <p:clrMapOvr>
+    <a:masterClrMapping/>
+  </p:clrMapOvr>
+</p:notes>
+</file>
+
+<file path=ppt/notesSlides/notesSlide12.xml><?xml version="1.0" encoding="utf-8"?>
+<p:notes xmlns:a="http://schemas.openxmlformats.org/drawingml/2006/main" xmlns:p="http://schemas.openxmlformats.org/presentationml/2006/main" xmlns:r="http://schemas.openxmlformats.org/officeDocument/2006/relationships">
+  <p:cSld>
+    <p:spTree>
+      <p:nvGrpSpPr>
+        <p:cNvPr id="1" name=""/>
+        <p:cNvGrpSpPr/>
+        <p:nvPr/>
+      </p:nvGrpSpPr>
+      <p:grpSpPr>
+        <a:xfrm>
+          <a:off x="0" y="0"/>
+          <a:ext cx="0" cy="0"/>
+          <a:chOff x="0" y="0"/>
+          <a:chExt cx="0" cy="0"/>
+        </a:xfrm>
+      </p:grpSpPr>
+      <p:sp>
+        <p:nvSpPr>
+          <p:cNvPr id="2" name="Slide Image Placeholder 1"/>
+          <p:cNvSpPr>
+            <a:spLocks noGrp="1"/>
+          </p:cNvSpPr>
+          <p:nvPr>
+            <p:ph type="sldImg" idx="2"/>
+          </p:nvPr>
+        </p:nvSpPr>
+        <p:spPr/>
+      </p:sp>
+      <p:sp>
+        <p:nvSpPr>
+          <p:cNvPr id="3" name="Notes Placeholder 2"/>
+          <p:cNvSpPr>
+            <a:spLocks noGrp="1"/>
+          </p:cNvSpPr>
+          <p:nvPr>
+            <p:ph type="body" idx="3" sz="quarter"/>
+          </p:nvPr>
+        </p:nvSpPr>
+        <p:spPr/>
+        <p:txBody>
+          <a:bodyPr/>
+          <a:lstStyle/>
+          <a:p>
+            <a:r>
+              <a:t>الضغط من وجه إلى وجه (Compressing Face-to-face): يُضغط وجهان متقابلان باتجاه بعضهما، والشكل المعروض تبسيط تصميمي (Stylization) لشكل هلامي منحنٍ أكثر تعقيدًا. ورغم مظهره المضغوط تساوي مساحة الورق مساحة المكعّب الأصلي.</a:t>
+            </a:r>
+          </a:p>
+        </p:txBody>
+      </p:sp>
+      <p:sp>
+        <p:nvSpPr>
+          <p:cNvPr id="4" name="Slide Number Placeholder 3"/>
+          <p:cNvSpPr>
+            <a:spLocks noGrp="1"/>
+          </p:cNvSpPr>
+          <p:nvPr>
+            <p:ph type="sldNum" idx="5" sz="quarter"/>
+          </p:nvPr>
+        </p:nvSpPr>
+        <p:spPr/>
+      </p:sp>
+    </p:spTree>
+  </p:cSld>
+  <p:clrMapOvr>
+    <a:masterClrMapping/>
+  </p:clrMapOvr>
+</p:notes>
+</file>
+
+<file path=ppt/notesSlides/notesSlide13.xml><?xml version="1.0" encoding="utf-8"?>
+<p:notes xmlns:a="http://schemas.openxmlformats.org/drawingml/2006/main" xmlns:p="http://schemas.openxmlformats.org/presentationml/2006/main" xmlns:r="http://schemas.openxmlformats.org/officeDocument/2006/relationships">
+  <p:cSld>
+    <p:spTree>
+      <p:nvGrpSpPr>
+        <p:cNvPr id="1" name=""/>
+        <p:cNvGrpSpPr/>
+        <p:nvPr/>
+      </p:nvGrpSpPr>
+      <p:grpSpPr>
+        <a:xfrm>
+          <a:off x="0" y="0"/>
+          <a:ext cx="0" cy="0"/>
+          <a:chOff x="0" y="0"/>
+          <a:chExt cx="0" cy="0"/>
+        </a:xfrm>
+      </p:grpSpPr>
+      <p:sp>
+        <p:nvSpPr>
+          <p:cNvPr id="2" name="Slide Image Placeholder 1"/>
+          <p:cNvSpPr>
+            <a:spLocks noGrp="1"/>
+          </p:cNvSpPr>
+          <p:nvPr>
+            <p:ph type="sldImg" idx="2"/>
+          </p:nvPr>
+        </p:nvSpPr>
+        <p:spPr/>
+      </p:sp>
+      <p:sp>
+        <p:nvSpPr>
+          <p:cNvPr id="3" name="Notes Placeholder 2"/>
+          <p:cNvSpPr>
+            <a:spLocks noGrp="1"/>
+          </p:cNvSpPr>
+          <p:nvPr>
+            <p:ph type="body" idx="3" sz="quarter"/>
+          </p:nvPr>
+        </p:nvSpPr>
+        <p:spPr/>
+        <p:txBody>
+          <a:bodyPr/>
+          <a:lstStyle/>
+          <a:p>
+            <a:r>
+              <a:t>يمكن عرض العبوات الحقيقية في القاعة إن توفرت، وسؤال الطلاب: أي تقنية من تقنيات المحاضرة تفسّر هذا الشكل؟</a:t>
+            </a:r>
+          </a:p>
+        </p:txBody>
+      </p:sp>
+      <p:sp>
+        <p:nvSpPr>
+          <p:cNvPr id="4" name="Slide Number Placeholder 3"/>
+          <p:cNvSpPr>
+            <a:spLocks noGrp="1"/>
+          </p:cNvSpPr>
+          <p:nvPr>
+            <p:ph type="sldNum" idx="5" sz="quarter"/>
+          </p:nvPr>
+        </p:nvSpPr>
+        <p:spPr/>
+      </p:sp>
+    </p:spTree>
+  </p:cSld>
+  <p:clrMapOvr>
+    <a:masterClrMapping/>
+  </p:clrMapOvr>
+</p:notes>
+</file>
+
+<file path=ppt/notesSlides/notesSlide14.xml><?xml version="1.0" encoding="utf-8"?>
+<p:notes xmlns:a="http://schemas.openxmlformats.org/drawingml/2006/main" xmlns:p="http://schemas.openxmlformats.org/presentationml/2006/main" xmlns:r="http://schemas.openxmlformats.org/officeDocument/2006/relationships">
+  <p:cSld>
+    <p:spTree>
+      <p:nvGrpSpPr>
+        <p:cNvPr id="1" name=""/>
+        <p:cNvGrpSpPr/>
+        <p:nvPr/>
+      </p:nvGrpSpPr>
+      <p:grpSpPr>
+        <a:xfrm>
+          <a:off x="0" y="0"/>
+          <a:ext cx="0" cy="0"/>
+          <a:chOff x="0" y="0"/>
+          <a:chExt cx="0" cy="0"/>
+        </a:xfrm>
+      </p:grpSpPr>
+      <p:sp>
+        <p:nvSpPr>
+          <p:cNvPr id="2" name="Slide Image Placeholder 1"/>
+          <p:cNvSpPr>
+            <a:spLocks noGrp="1"/>
+          </p:cNvSpPr>
+          <p:nvPr>
+            <p:ph type="sldImg" idx="2"/>
+          </p:nvPr>
+        </p:nvSpPr>
+        <p:spPr/>
+      </p:sp>
+      <p:sp>
+        <p:nvSpPr>
+          <p:cNvPr id="3" name="Notes Placeholder 2"/>
+          <p:cNvSpPr>
+            <a:spLocks noGrp="1"/>
+          </p:cNvSpPr>
+          <p:nvPr>
+            <p:ph type="body" idx="3" sz="quarter"/>
+          </p:nvPr>
+        </p:nvSpPr>
+        <p:spPr/>
+        <p:txBody>
+          <a:bodyPr/>
+          <a:lstStyle/>
+          <a:p>
+            <a:r>
               <a:t>الإجابات: ١) ضغط الخط بأداة طي لا قطعه. ٢) فوق الرسم كي تتجه الشفرة إن انزلقت نحو الورق الزائد. ٣) سبعة أوجه. ٤) ٨٠°، ولا يُنصح بما دون ٧٠°. ٥) ١٢٫٦ سم. ٦) لأنها تعمل في أزواج متعاكسة.</a:t>
             </a:r>
           </a:p>
@@ -871,7 +1157,7 @@
           <a:lstStyle/>
           <a:p>
             <a:r>
-              <a:t>كشط وجه (Shaving a Face): يُكشط أحد الأوجه بزاوية مائلة فينتج سطح منحدر، ويمكن التحكم في درجة الميل أو إمالته إلى الأمام أو الخلف.</a:t>
+              <a:t>اختبار الاتجاه: تُثنى قطعة صغيرة من الورق في الاتجاهين؛ الاتجاه الأسهل انثناءً هو اتجاه الألياف. أو تُمزَّق القطعة: التمزق مع الألياف أكثر استقامة.</a:t>
             </a:r>
           </a:p>
         </p:txBody>
@@ -941,7 +1227,7 @@
           <a:lstStyle/>
           <a:p>
             <a:r>
-              <a:t>كشط حافة (Shaving an Edge): تُكشط إحدى الحواف فينشأ مكانها وجه جديد، ويمكن التحكم في مقدار الكشط واتجاه ميله.</a:t>
+              <a:t>قاعدة عملية: كلما زادت سماكة الورق زادت الحاجة إلى التعويض. ويُختبر المِفرَد دائمًا بنموذج أولي قبل اعتماده.</a:t>
             </a:r>
           </a:p>
         </p:txBody>
@@ -1011,7 +1297,7 @@
           <a:lstStyle/>
           <a:p>
             <a:r>
-              <a:t>كشط ركن (Shaving a Corner): يُكشط أحد الأركان فينشأ وجه على هيئة مثلث متساوي الأضلاع (زواياه ٦٠°)، لأن القطع يمر بثلاث حواف متساوية؛ وباختلاف مسافات القطع ينتج مثلث مختلف الأضلاع.</a:t>
+              <a:t>في تقنية الضغط (٤.٨) يُطوى خط المنتصف الأفقي باتجاه معاكس لخطوط الطي العمودية، وهذا ما يجعل الجدار ينثني.</a:t>
             </a:r>
           </a:p>
         </p:txBody>
@@ -1081,7 +1367,7 @@
           <a:lstStyle/>
           <a:p>
             <a:r>
-              <a:t>المطّ من حافة إلى حافة (Stretching Edge-to-edge): تُشدّ حافتان متقابلتان في اتجاهين متعاكسين، فينتج صندوق مائل (Leaning Box).</a:t>
+              <a:t>كشط وجه (Shaving a Face): يُكشط أحد الأوجه بزاوية مائلة فينتج سطح منحدر، ويمكن التحكم في درجة الميل أو إمالته إلى الأمام أو الخلف.</a:t>
             </a:r>
           </a:p>
         </p:txBody>
@@ -1151,7 +1437,7 @@
           <a:lstStyle/>
           <a:p>
             <a:r>
-              <a:t>المطّ من ركن إلى ركن (Stretching Corner-to-corner): يُشدّ ركنان متقابلان فينتج شكل معيّني يُعرف بمتوازي السطوح المعيّني (Rhombohedron).</a:t>
+              <a:t>كشط حافة (Shaving an Edge): تُكشط إحدى الحواف فينشأ مكانها وجه جديد، ويمكن التحكم في مقدار الكشط واتجاه ميله.</a:t>
             </a:r>
           </a:p>
         </p:txBody>
@@ -1221,7 +1507,7 @@
           <a:lstStyle/>
           <a:p>
             <a:r>
-              <a:t>ليّ الوجهين المتقابلين (Twisting Opposite Faces): يُلوى الوجهان العلوي والسفلي ليًّا خفيفًا في اتجاهين متعاكسين، فتتحوّل الجوانب إلى متوازيات أضلاع. وزاوية الميل المثلى ٨٠°، والزوايا الأقل من ٧٠° نادرًا ما تنجح.</a:t>
+              <a:t>كشط ركن (Shaving a Corner): يُكشط أحد الأركان فينشأ وجه على هيئة مثلث متساوي الأضلاع (زواياه ٦٠°)، لأن القطع يمر بثلاث حواف متساوية؛ وباختلاف مسافات القطع ينتج مثلث مختلف الأضلاع.</a:t>
             </a:r>
           </a:p>
         </p:txBody>
@@ -1291,7 +1577,7 @@
           <a:lstStyle/>
           <a:p>
             <a:r>
-              <a:t>الليّ: النسخة المُضلَّعة (Twisting: Faceted Version): يُزاد الليّ حتى تقع أركان المربع العلوي فوق منتصفات حواف المربع السفلي، ثم تُوصل الأركان الثمانية بخطوط طي.</a:t>
+              <a:t>المطّ من حافة إلى حافة (Stretching Edge-to-edge): تُشدّ حافتان متقابلتان في اتجاهين متعاكسين، فينتج صندوق مائل (Leaning Box).</a:t>
             </a:r>
           </a:p>
         </p:txBody>
@@ -1361,7 +1647,7 @@
           <a:lstStyle/>
           <a:p>
             <a:r>
-              <a:t>الضغط من وجه إلى وجه (Compressing Face-to-face): يُضغط وجهان متقابلان باتجاه بعضهما، والشكل المعروض تبسيط تصميمي (Stylization) لشكل هلامي منحنٍ أكثر تعقيدًا. ورغم مظهره المضغوط تساوي مساحة الورق مساحة المكعّب الأصلي.</a:t>
+              <a:t>المطّ من ركن إلى ركن (Stretching Corner-to-corner): يُشدّ ركنان متقابلان فينتج شكل معيّني يُعرف بمتوازي السطوح المعيّني (Rhombohedron).</a:t>
             </a:r>
           </a:p>
         </p:txBody>
@@ -5495,7 +5781,7 @@
             </a:pPr>
             <a:r>
               <a:rPr lang="ar-SA" sz="2000" b="1"/>
-              <a:t>كشط وجه (Shaving a Face):</a:t>
+              <a:t>عناصر المكعّب الثلاثة:</a:t>
             </a:r>
           </a:p>
           <a:p>
@@ -5503,51 +5789,41 @@
               <a:buNone/>
             </a:pPr>
             <a:r>
-              <a:rPr lang="ar-SA" sz="2000" b="1"/>
-              <a:t>الاستراتيجية وعدد الأوجه: </a:t>
-            </a:r>
-            <a:r>
-              <a:rPr lang="ar-SA" sz="2000"/>
-              <a:t>النحت، ٦ أوجه</a:t>
-            </a:r>
-          </a:p>
-          <a:p>
-            <a:pPr marL="0" indent="0">
-              <a:buNone/>
-            </a:pPr>
-            <a:r>
-              <a:rPr lang="ar-SA" sz="2000" b="1"/>
-              <a:t>المفهوم: </a:t>
-            </a:r>
-            <a:r>
-              <a:rPr lang="ar-SA" sz="2000"/>
-              <a:t>يُكشط أحد الأوجه بزاوية مائلة فينتج سطح منحدر، ويمكن التحكم في درجة الميل أو إمالته إلى الأمام أو الخلف.</a:t>
-            </a:r>
-          </a:p>
-          <a:p>
-            <a:pPr marL="0" indent="0">
-              <a:buNone/>
-            </a:pPr>
-            <a:r>
-              <a:rPr lang="ar-SA" sz="2000" b="1"/>
-              <a:t>التحليل الشكلي: </a:t>
-            </a:r>
-            <a:r>
-              <a:rPr lang="ar-SA" sz="2000"/>
-              <a:t>يتحوّل الوجهان الجانبيان إلى شبهي منحرف، ويصبح الوجه العلوي مستطيلًا مائلًا أطول من القاعدة.</a:t>
-            </a:r>
-          </a:p>
-          <a:p>
-            <a:pPr marL="0" indent="0">
-              <a:buNone/>
-            </a:pPr>
-            <a:r>
-              <a:rPr lang="ar-SA" sz="2000" b="1"/>
-              <a:t>التوظيف في التغليف: </a:t>
-            </a:r>
-            <a:r>
-              <a:rPr lang="ar-SA" sz="2000"/>
-              <a:t>يؤدي السطح المائل دور واجهة عرض للشعار أو المنتج، تُقرأ بسهولة من زاوية نظر المستهلك أمام الرف.</a:t>
+              <a:rPr lang="ar-SA" sz="2000"/>
+              <a:t>يتكوّن المكعّب، شأنه شأن معظم تصاميم التغليف الإنشائي، من ثلاثة عناصر، وكل تشويه للمكعّب تعديل على عنصر منها أو أكثر:</a:t>
+            </a:r>
+          </a:p>
+          <a:p>
+            <a:pPr/>
+            <a:r>
+              <a:rPr lang="ar-SA" sz="2000" b="1"/>
+              <a:t>الأوجه (Faces): </a:t>
+            </a:r>
+            <a:r>
+              <a:rPr lang="ar-SA" sz="2000"/>
+              <a:t>الأسطح المستوية، وتمثّل مساحات الطباعة والهوية البصرية.</a:t>
+            </a:r>
+          </a:p>
+          <a:p>
+            <a:pPr/>
+            <a:r>
+              <a:rPr lang="ar-SA" sz="2000" b="1"/>
+              <a:t>الحواف (Edges): </a:t>
+            </a:r>
+            <a:r>
+              <a:rPr lang="ar-SA" sz="2000"/>
+              <a:t>خطوط التقاء وجهين، وتمثّل خطوط الطي.</a:t>
+            </a:r>
+          </a:p>
+          <a:p>
+            <a:pPr/>
+            <a:r>
+              <a:rPr lang="ar-SA" sz="2000" b="1"/>
+              <a:t>الأركان (Corners): </a:t>
+            </a:r>
+            <a:r>
+              <a:rPr lang="ar-SA" sz="2000"/>
+              <a:t>نقاط التقاء الحواف، وهي أكثر مواضع العبوة عرضة للتلف.</a:t>
             </a:r>
           </a:p>
         </p:txBody>
@@ -5588,22 +5864,22 @@
       </p:sp>
       <p:pic>
         <p:nvPicPr>
-          <p:cNvPr id="16" name="Picture 15" descr="face.png"/>
+          <p:cNvPr id="16" name="Picture 15" descr="cover.png"/>
           <p:cNvPicPr>
             <a:picLocks noChangeAspect="1"/>
           </p:cNvPicPr>
           <p:nvPr/>
         </p:nvPicPr>
         <p:blipFill>
-          <a:blip r:embed="rId3"/>
+          <a:blip r:embed="rId2"/>
           <a:stretch>
             <a:fillRect/>
           </a:stretch>
         </p:blipFill>
         <p:spPr>
           <a:xfrm>
-            <a:off x="935439" y="1600200"/>
-            <a:ext cx="3981281" cy="4389120"/>
+            <a:off x="457200" y="2220096"/>
+            <a:ext cx="4937760" cy="3149327"/>
           </a:xfrm>
           <a:prstGeom prst="rect">
             <a:avLst/>
@@ -5655,7 +5931,7 @@
             </a:pPr>
             <a:r>
               <a:rPr lang="ar-SA" sz="2000" b="1"/>
-              <a:t>كشط حافة (Shaving an Edge):</a:t>
+              <a:t>المِفرَد (Net):</a:t>
             </a:r>
           </a:p>
           <a:p>
@@ -5663,12 +5939,41 @@
               <a:buNone/>
             </a:pPr>
             <a:r>
-              <a:rPr lang="ar-SA" sz="2000" b="1"/>
-              <a:t>الاستراتيجية وعدد الأوجه: </a:t>
-            </a:r>
-            <a:r>
-              <a:rPr lang="ar-SA" sz="2000"/>
-              <a:t>النحت، ٧ أوجه</a:t>
+              <a:rPr lang="ar-SA" sz="2000"/>
+              <a:t>المِفرَد هو الصورة المسطحة للعبوة قبل طيّها، ويتطلب تصميمه مراعاة ما يلي:</a:t>
+            </a:r>
+          </a:p>
+          <a:p>
+            <a:pPr/>
+            <a:r>
+              <a:rPr lang="ar-SA" sz="2000" b="1"/>
+              <a:t>ترتيب الأوجه: </a:t>
+            </a:r>
+            <a:r>
+              <a:rPr lang="ar-SA" sz="2000"/>
+              <a:t>بما يضمن انغلاق الشكل انغلاقًا صحيحًا.</a:t>
+            </a:r>
+          </a:p>
+          <a:p>
+            <a:pPr/>
+            <a:r>
+              <a:rPr lang="ar-SA" sz="2000" b="1"/>
+              <a:t>الألسنة (Tabs): </a:t>
+            </a:r>
+            <a:r>
+              <a:rPr lang="ar-SA" sz="2000"/>
+              <a:t>أشكالها ومواضعها، لأنها أداة الربط بين الأوجه.</a:t>
+            </a:r>
+          </a:p>
+          <a:p>
+            <a:pPr/>
+            <a:r>
+              <a:rPr lang="ar-SA" sz="2000" b="1"/>
+              <a:t>آلية الإغلاق: </a:t>
+            </a:r>
+            <a:r>
+              <a:rPr lang="ar-SA" sz="2000"/>
+              <a:t>لسان اللصق (Glue Tab) للإغلاق الدائم، وقفل النقر (Click Lock) للإغلاق السريع، وقفل اللسان (Tongue Lock) للفتح والإغلاق المتكرر.</a:t>
             </a:r>
           </a:p>
           <a:p>
@@ -5677,37 +5982,11 @@
             </a:pPr>
             <a:r>
               <a:rPr lang="ar-SA" sz="2000" b="1"/>
-              <a:t>المفهوم: </a:t>
-            </a:r>
-            <a:r>
-              <a:rPr lang="ar-SA" sz="2000"/>
-              <a:t>تُكشط إحدى الحواف فينشأ مكانها وجه جديد، ويمكن التحكم في مقدار الكشط واتجاه ميله.</a:t>
-            </a:r>
-          </a:p>
-          <a:p>
-            <a:pPr marL="0" indent="0">
-              <a:buNone/>
-            </a:pPr>
-            <a:r>
-              <a:rPr lang="ar-SA" sz="2000" b="1"/>
-              <a:t>التحليل الشكلي: </a:t>
-            </a:r>
-            <a:r>
-              <a:rPr lang="ar-SA" sz="2000"/>
-              <a:t>يزيد عدد الأوجه وجهًا واحدًا، ويتحوّل الوجهان الجانبيان إلى شكلين خماسيين.</a:t>
-            </a:r>
-          </a:p>
-          <a:p>
-            <a:pPr marL="0" indent="0">
-              <a:buNone/>
-            </a:pPr>
-            <a:r>
-              <a:rPr lang="ar-SA" sz="2000" b="1"/>
-              <a:t>التوظيف في التغليف: </a:t>
-            </a:r>
-            <a:r>
-              <a:rPr lang="ar-SA" sz="2000"/>
-              <a:t>يوفّر الوجه الإضافي مساحة لمعلومة أو عنصر بصري، ويمنح العبوة طابعًا أنعم يلائم علب الهدايا والعطور.</a:t>
+              <a:t>موضع الغطاء: </a:t>
+            </a:r>
+            <a:r>
+              <a:rPr lang="ar-SA" sz="2000"/>
+              <a:t>غير ثابت؛ يمكن وضعه على أي وجه وبأي اتجاه وفق طريقة عرض المنتج واستخدامه.</a:t>
             </a:r>
           </a:p>
         </p:txBody>
@@ -5748,22 +6027,22 @@
       </p:sp>
       <p:pic>
         <p:nvPicPr>
-          <p:cNvPr id="16" name="Picture 15" descr="edge.png"/>
+          <p:cNvPr id="16" name="Picture 15" descr="dc1.png"/>
           <p:cNvPicPr>
             <a:picLocks noChangeAspect="1"/>
           </p:cNvPicPr>
           <p:nvPr/>
         </p:nvPicPr>
         <p:blipFill>
-          <a:blip r:embed="rId3"/>
+          <a:blip r:embed="rId2"/>
           <a:stretch>
             <a:fillRect/>
           </a:stretch>
         </p:blipFill>
         <p:spPr>
           <a:xfrm>
-            <a:off x="894997" y="1600200"/>
-            <a:ext cx="4062165" cy="4389120"/>
+            <a:off x="457200" y="1726320"/>
+            <a:ext cx="4937760" cy="4136879"/>
           </a:xfrm>
           <a:prstGeom prst="rect">
             <a:avLst/>
@@ -5815,7 +6094,7 @@
             </a:pPr>
             <a:r>
               <a:rPr lang="ar-SA" sz="2000" b="1"/>
-              <a:t>كشط ركن (Shaving a Corner):</a:t>
+              <a:t>استراتيجيات تشويه المكعّب:</a:t>
             </a:r>
           </a:p>
           <a:p>
@@ -5824,11 +6103,11 @@
             </a:pPr>
             <a:r>
               <a:rPr lang="ar-SA" sz="2000" b="1"/>
-              <a:t>الاستراتيجية وعدد الأوجه: </a:t>
-            </a:r>
-            <a:r>
-              <a:rPr lang="ar-SA" sz="2000"/>
-              <a:t>النحت، ٧ أوجه</a:t>
+              <a:t>١. النحت: </a:t>
+            </a:r>
+            <a:r>
+              <a:rPr lang="ar-SA" sz="2000"/>
+              <a:t>يُتخيّل المكعّب كتلة صلبة يُكشط منها جزء من وجه أو حافة أو ركن، بمقدار قليل أو كبير، بصورة متماثلة أو غير متماثلة.</a:t>
             </a:r>
           </a:p>
           <a:p>
@@ -5837,11 +6116,11 @@
             </a:pPr>
             <a:r>
               <a:rPr lang="ar-SA" sz="2000" b="1"/>
-              <a:t>المفهوم: </a:t>
-            </a:r>
-            <a:r>
-              <a:rPr lang="ar-SA" sz="2000"/>
-              <a:t>يُكشط أحد الأركان فينشأ وجه على هيئة مثلث متساوي الأضلاع (زواياه ٦٠°)، لأن القطع يمر بثلاث حواف متساوية؛ وباختلاف مسافات القطع ينتج مثلث مختلف الأضلاع.</a:t>
+              <a:t>٢. المرونة: </a:t>
+            </a:r>
+            <a:r>
+              <a:rPr lang="ar-SA" sz="2000"/>
+              <a:t>يُتخيّل المكعّب كتلة مطاطية تُشدّ أو تُضغط أو تُلوى على محاور تصل بين أوجه أو حواف أو أركان متقابلة.</a:t>
             </a:r>
           </a:p>
           <a:p>
@@ -5850,11 +6129,11 @@
             </a:pPr>
             <a:r>
               <a:rPr lang="ar-SA" sz="2000" b="1"/>
-              <a:t>التحليل الشكلي: </a:t>
-            </a:r>
-            <a:r>
-              <a:rPr lang="ar-SA" sz="2000"/>
-              <a:t>تتحوّل الأوجه الثلاثة الملتقية عند الركن إلى أشكال خماسية.</a:t>
+              <a:t>٣. التقويس: </a:t>
+            </a:r>
+            <a:r>
+              <a:rPr lang="ar-SA" sz="2000"/>
+              <a:t>تُستبدل الحواف المستقيمة بحواف منحنية، فتتقوّس الأوجه المستوية.</a:t>
             </a:r>
           </a:p>
           <a:p>
@@ -5862,12 +6141,8 @@
               <a:buNone/>
             </a:pPr>
             <a:r>
-              <a:rPr lang="ar-SA" sz="2000" b="1"/>
-              <a:t>التوظيف في التغليف: </a:t>
-            </a:r>
-            <a:r>
-              <a:rPr lang="ar-SA" sz="2000"/>
-              <a:t>المثلث موضع مميز للشعار، وإيقاف العبوة عليه يمنحها أثرًا نحتيًا يلائم الإصدارات الخاصة.</a:t>
+              <a:rPr lang="ar-SA" sz="2000"/>
+              <a:t>ومتى استوعب المصمم هذه الاستراتيجيات، أصبح ابتكار أشكال تغليف جديدة ميسورًا حتى مع معرفة محدودة بالهندسة الفراغية.</a:t>
             </a:r>
           </a:p>
         </p:txBody>
@@ -5908,7 +6183,31 @@
       </p:sp>
       <p:pic>
         <p:nvPicPr>
-          <p:cNvPr id="16" name="Picture 15" descr="corner.png"/>
+          <p:cNvPr id="16" name="Picture 15" descr="face.png"/>
+          <p:cNvPicPr>
+            <a:picLocks noChangeAspect="1"/>
+          </p:cNvPicPr>
+          <p:nvPr/>
+        </p:nvPicPr>
+        <p:blipFill>
+          <a:blip r:embed="rId2"/>
+          <a:stretch>
+            <a:fillRect/>
+          </a:stretch>
+        </p:blipFill>
+        <p:spPr>
+          <a:xfrm>
+            <a:off x="1872699" y="1600200"/>
+            <a:ext cx="2106761" cy="2322576"/>
+          </a:xfrm>
+          <a:prstGeom prst="rect">
+            <a:avLst/>
+          </a:prstGeom>
+        </p:spPr>
+      </p:pic>
+      <p:pic>
+        <p:nvPicPr>
+          <p:cNvPr id="17" name="Picture 16" descr="stretch-edge.png"/>
           <p:cNvPicPr>
             <a:picLocks noChangeAspect="1"/>
           </p:cNvPicPr>
@@ -5922,8 +6221,32 @@
         </p:blipFill>
         <p:spPr>
           <a:xfrm>
-            <a:off x="457200" y="1834710"/>
-            <a:ext cx="4937760" cy="3920099"/>
+            <a:off x="783975" y="4105656"/>
+            <a:ext cx="1723888" cy="1883664"/>
+          </a:xfrm>
+          <a:prstGeom prst="rect">
+            <a:avLst/>
+          </a:prstGeom>
+        </p:spPr>
+      </p:pic>
+      <p:pic>
+        <p:nvPicPr>
+          <p:cNvPr id="18" name="Picture 17" descr="single.png"/>
+          <p:cNvPicPr>
+            <a:picLocks noChangeAspect="1"/>
+          </p:cNvPicPr>
+          <p:nvPr/>
+        </p:nvPicPr>
+        <p:blipFill>
+          <a:blip r:embed="rId4"/>
+          <a:stretch>
+            <a:fillRect/>
+          </a:stretch>
+        </p:blipFill>
+        <p:spPr>
+          <a:xfrm>
+            <a:off x="3017520" y="4108109"/>
+            <a:ext cx="2377440" cy="1878757"/>
           </a:xfrm>
           <a:prstGeom prst="rect">
             <a:avLst/>
@@ -5975,7 +6298,7 @@
             </a:pPr>
             <a:r>
               <a:rPr lang="ar-SA" sz="2000" b="1"/>
-              <a:t>المطّ من حافة إلى حافة (Stretching Edge-to-edge):</a:t>
+              <a:t>كشط وجه (Shaving a Face):</a:t>
             </a:r>
           </a:p>
           <a:p>
@@ -5988,7 +6311,7 @@
             </a:r>
             <a:r>
               <a:rPr lang="ar-SA" sz="2000"/>
-              <a:t>المرونة، ٦ أوجه</a:t>
+              <a:t>النحت، ٦ أوجه</a:t>
             </a:r>
           </a:p>
           <a:p>
@@ -6001,7 +6324,7 @@
             </a:r>
             <a:r>
               <a:rPr lang="ar-SA" sz="2000"/>
-              <a:t>تُشدّ حافتان متقابلتان في اتجاهين متعاكسين، فينتج صندوق مائل (Leaning Box).</a:t>
+              <a:t>يُكشط أحد الأوجه بزاوية مائلة فينتج سطح منحدر، ويمكن التحكم في درجة الميل أو إمالته إلى الأمام أو الخلف.</a:t>
             </a:r>
           </a:p>
           <a:p>
@@ -6014,7 +6337,7 @@
             </a:r>
             <a:r>
               <a:rPr lang="ar-SA" sz="2000"/>
-              <a:t>يتحوّل وجهان متقابلان إلى متوازيي أضلاع، وتبقى الأوجه الأربعة الأخرى مستطيلات.</a:t>
+              <a:t>يتحوّل الوجهان الجانبيان إلى شبهي منحرف، ويصبح الوجه العلوي مستطيلًا مائلًا أطول من القاعدة.</a:t>
             </a:r>
           </a:p>
           <a:p>
@@ -6027,7 +6350,7 @@
             </a:r>
             <a:r>
               <a:rPr lang="ar-SA" sz="2000"/>
-              <a:t>يوحي الشكل بالحركة والديناميكية، ويلائم المنتجات الشبابية والرياضية.</a:t>
+              <a:t>يؤدي السطح المائل دور واجهة عرض للشعار أو المنتج، تُقرأ بسهولة من زاوية نظر المستهلك أمام الرف.</a:t>
             </a:r>
           </a:p>
         </p:txBody>
@@ -6068,7 +6391,7 @@
       </p:sp>
       <p:pic>
         <p:nvPicPr>
-          <p:cNvPr id="16" name="Picture 15" descr="stretch-edge.png"/>
+          <p:cNvPr id="16" name="Picture 15" descr="face.png"/>
           <p:cNvPicPr>
             <a:picLocks noChangeAspect="1"/>
           </p:cNvPicPr>
@@ -6082,8 +6405,8 @@
         </p:blipFill>
         <p:spPr>
           <a:xfrm>
-            <a:off x="917665" y="1600200"/>
-            <a:ext cx="4016828" cy="4389120"/>
+            <a:off x="935439" y="1600200"/>
+            <a:ext cx="3981281" cy="4389120"/>
           </a:xfrm>
           <a:prstGeom prst="rect">
             <a:avLst/>
@@ -6135,7 +6458,7 @@
             </a:pPr>
             <a:r>
               <a:rPr lang="ar-SA" sz="2000" b="1"/>
-              <a:t>المطّ من ركن إلى ركن (Stretching Corner-to-corner):</a:t>
+              <a:t>كشط حافة (Shaving an Edge):</a:t>
             </a:r>
           </a:p>
           <a:p>
@@ -6148,7 +6471,7 @@
             </a:r>
             <a:r>
               <a:rPr lang="ar-SA" sz="2000"/>
-              <a:t>المرونة، ٦ أوجه</a:t>
+              <a:t>النحت، ٧ أوجه</a:t>
             </a:r>
           </a:p>
           <a:p>
@@ -6161,7 +6484,7 @@
             </a:r>
             <a:r>
               <a:rPr lang="ar-SA" sz="2000"/>
-              <a:t>يُشدّ ركنان متقابلان فينتج شكل معيّني يُعرف بمتوازي السطوح المعيّني (Rhombohedron).</a:t>
+              <a:t>تُكشط إحدى الحواف فينشأ مكانها وجه جديد، ويمكن التحكم في مقدار الكشط واتجاه ميله.</a:t>
             </a:r>
           </a:p>
           <a:p>
@@ -6174,7 +6497,7 @@
             </a:r>
             <a:r>
               <a:rPr lang="ar-SA" sz="2000"/>
-              <a:t>تتحوّل الأوجه الستة جميعها إلى معيّنات، ولا تبقى أي زاوية قائمة.</a:t>
+              <a:t>يزيد عدد الأوجه وجهًا واحدًا، ويتحوّل الوجهان الجانبيان إلى شكلين خماسيين.</a:t>
             </a:r>
           </a:p>
           <a:p>
@@ -6187,7 +6510,7 @@
             </a:r>
             <a:r>
               <a:rPr lang="ar-SA" sz="2000"/>
-              <a:t>يبدو الشكل كأنه يخالف قوانين المنظور لغياب الزوايا القائمة، فيلائم المنتجات الفاخرة والفنية.</a:t>
+              <a:t>يوفّر الوجه الإضافي مساحة لمعلومة أو عنصر بصري، ويمنح العبوة طابعًا أنعم يلائم علب الهدايا والعطور.</a:t>
             </a:r>
           </a:p>
         </p:txBody>
@@ -6228,7 +6551,7 @@
       </p:sp>
       <p:pic>
         <p:nvPicPr>
-          <p:cNvPr id="16" name="Picture 15" descr="stretch-corner.png"/>
+          <p:cNvPr id="16" name="Picture 15" descr="edge.png"/>
           <p:cNvPicPr>
             <a:picLocks noChangeAspect="1"/>
           </p:cNvPicPr>
@@ -6242,8 +6565,8 @@
         </p:blipFill>
         <p:spPr>
           <a:xfrm>
-            <a:off x="457200" y="1605887"/>
-            <a:ext cx="4937760" cy="4377745"/>
+            <a:off x="894997" y="1600200"/>
+            <a:ext cx="4062165" cy="4389120"/>
           </a:xfrm>
           <a:prstGeom prst="rect">
             <a:avLst/>
@@ -6295,7 +6618,7 @@
             </a:pPr>
             <a:r>
               <a:rPr lang="ar-SA" sz="2000" b="1"/>
-              <a:t>ليّ الوجهين المتقابلين (Twisting Opposite Faces):</a:t>
+              <a:t>كشط ركن (Shaving a Corner):</a:t>
             </a:r>
           </a:p>
           <a:p>
@@ -6308,7 +6631,7 @@
             </a:r>
             <a:r>
               <a:rPr lang="ar-SA" sz="2000"/>
-              <a:t>المرونة، ٦ أوجه</a:t>
+              <a:t>النحت، ٧ أوجه</a:t>
             </a:r>
           </a:p>
           <a:p>
@@ -6321,7 +6644,7 @@
             </a:r>
             <a:r>
               <a:rPr lang="ar-SA" sz="2000"/>
-              <a:t>يُلوى الوجهان العلوي والسفلي ليًّا خفيفًا في اتجاهين متعاكسين، فتتحوّل الجوانب إلى متوازيات أضلاع. وزاوية الميل المثلى ٨٠°، والزوايا الأقل من ٧٠° نادرًا ما تنجح.</a:t>
+              <a:t>يُكشط أحد الأركان فينشأ وجه على هيئة مثلث متساوي الأضلاع (زواياه ٦٠°)، لأن القطع يمر بثلاث حواف متساوية؛ وباختلاف مسافات القطع ينتج مثلث مختلف الأضلاع.</a:t>
             </a:r>
           </a:p>
           <a:p>
@@ -6334,7 +6657,7 @@
             </a:r>
             <a:r>
               <a:rPr lang="ar-SA" sz="2000"/>
-              <a:t>يبقى الوجهان العلوي والسفلي مربعين، وتميل الأوجه الجانبية الأربعة في الاتجاه نفسه.</a:t>
+              <a:t>تتحوّل الأوجه الثلاثة الملتقية عند الركن إلى أشكال خماسية.</a:t>
             </a:r>
           </a:p>
           <a:p>
@@ -6347,7 +6670,7 @@
             </a:r>
             <a:r>
               <a:rPr lang="ar-SA" sz="2000"/>
-              <a:t>تشويه دقيق لا يُلحظ من النظرة الأولى ثم يكتشفه المستهلك عند التأمل، فيلائم العلامات الراقية.</a:t>
+              <a:t>المثلث موضع مميز للشعار، وإيقاف العبوة عليه يمنحها أثرًا نحتيًا يلائم الإصدارات الخاصة.</a:t>
             </a:r>
           </a:p>
         </p:txBody>
@@ -6388,7 +6711,7 @@
       </p:sp>
       <p:pic>
         <p:nvPicPr>
-          <p:cNvPr id="16" name="Picture 15" descr="twist.png"/>
+          <p:cNvPr id="16" name="Picture 15" descr="corner.png"/>
           <p:cNvPicPr>
             <a:picLocks noChangeAspect="1"/>
           </p:cNvPicPr>
@@ -6402,8 +6725,8 @@
         </p:blipFill>
         <p:spPr>
           <a:xfrm>
-            <a:off x="712624" y="1600200"/>
-            <a:ext cx="4426910" cy="4389120"/>
+            <a:off x="457200" y="1834710"/>
+            <a:ext cx="4937760" cy="3920099"/>
           </a:xfrm>
           <a:prstGeom prst="rect">
             <a:avLst/>
@@ -6455,7 +6778,7 @@
             </a:pPr>
             <a:r>
               <a:rPr lang="ar-SA" sz="2000" b="1"/>
-              <a:t>الليّ: النسخة المُضلَّعة (Twisting: Faceted Version):</a:t>
+              <a:t>المطّ من حافة إلى حافة (Stretching Edge-to-edge):</a:t>
             </a:r>
           </a:p>
           <a:p>
@@ -6468,7 +6791,7 @@
             </a:r>
             <a:r>
               <a:rPr lang="ar-SA" sz="2000"/>
-              <a:t>المرونة، ١٠ أوجه</a:t>
+              <a:t>المرونة، ٦ أوجه</a:t>
             </a:r>
           </a:p>
           <a:p>
@@ -6481,7 +6804,7 @@
             </a:r>
             <a:r>
               <a:rPr lang="ar-SA" sz="2000"/>
-              <a:t>يُزاد الليّ حتى تقع أركان المربع العلوي فوق منتصفات حواف المربع السفلي، ثم تُوصل الأركان الثمانية بخطوط طي.</a:t>
+              <a:t>تُشدّ حافتان متقابلتان في اتجاهين متعاكسين، فينتج صندوق مائل (Leaning Box).</a:t>
             </a:r>
           </a:p>
           <a:p>
@@ -6494,7 +6817,7 @@
             </a:r>
             <a:r>
               <a:rPr lang="ar-SA" sz="2000"/>
-              <a:t>مربعان وثمانية مثلثات متساوية الساقين (Antiprism)، ويتطلب ألسنة ذات حافة مثنية (Flanged Tabs).</a:t>
+              <a:t>يتحوّل وجهان متقابلان إلى متوازيي أضلاع، وتبقى الأوجه الأربعة الأخرى مستطيلات.</a:t>
             </a:r>
           </a:p>
           <a:p>
@@ -6507,7 +6830,7 @@
             </a:r>
             <a:r>
               <a:rPr lang="ar-SA" sz="2000"/>
-              <a:t>شكل بلوري يحاكي الأحجار الكريمة، يلائم المجوهرات والشوكولاتة الفاخرة والشموع.</a:t>
+              <a:t>يوحي الشكل بالحركة والديناميكية، ويلائم المنتجات الشبابية والرياضية.</a:t>
             </a:r>
           </a:p>
         </p:txBody>
@@ -6548,7 +6871,7 @@
       </p:sp>
       <p:pic>
         <p:nvPicPr>
-          <p:cNvPr id="16" name="Picture 15" descr="twist-facet.png"/>
+          <p:cNvPr id="16" name="Picture 15" descr="stretch-edge.png"/>
           <p:cNvPicPr>
             <a:picLocks noChangeAspect="1"/>
           </p:cNvPicPr>
@@ -6562,8 +6885,8 @@
         </p:blipFill>
         <p:spPr>
           <a:xfrm>
-            <a:off x="457200" y="1732341"/>
-            <a:ext cx="4937760" cy="4124836"/>
+            <a:off x="917665" y="1600200"/>
+            <a:ext cx="4016828" cy="4389120"/>
           </a:xfrm>
           <a:prstGeom prst="rect">
             <a:avLst/>
@@ -6615,7 +6938,7 @@
             </a:pPr>
             <a:r>
               <a:rPr lang="ar-SA" sz="2000" b="1"/>
-              <a:t>الضغط من وجه إلى وجه (Compressing Face-to-face):</a:t>
+              <a:t>المطّ من ركن إلى ركن (Stretching Corner-to-corner):</a:t>
             </a:r>
           </a:p>
           <a:p>
@@ -6641,7 +6964,7 @@
             </a:r>
             <a:r>
               <a:rPr lang="ar-SA" sz="2000"/>
-              <a:t>يُضغط وجهان متقابلان باتجاه بعضهما، والشكل المعروض تبسيط تصميمي (Stylization) لشكل هلامي منحنٍ أكثر تعقيدًا. ورغم مظهره المضغوط تساوي مساحة الورق مساحة المكعّب الأصلي.</a:t>
+              <a:t>يُشدّ ركنان متقابلان فينتج شكل معيّني يُعرف بمتوازي السطوح المعيّني (Rhombohedron).</a:t>
             </a:r>
           </a:p>
           <a:p>
@@ -6654,7 +6977,7 @@
             </a:r>
             <a:r>
               <a:rPr lang="ar-SA" sz="2000"/>
-              <a:t>ينقسم كل جدار بخط طي أفقي في منتصفه فينثني عنده.</a:t>
+              <a:t>تتحوّل الأوجه الستة جميعها إلى معيّنات، ولا تبقى أي زاوية قائمة.</a:t>
             </a:r>
           </a:p>
           <a:p>
@@ -6667,7 +6990,7 @@
             </a:r>
             <a:r>
               <a:rPr lang="ar-SA" sz="2000"/>
-              <a:t>شكل يوحي بالمرونة والطرافة، ويلائم المنتجات اللينة ومنتجات الأطفال.</a:t>
+              <a:t>يبدو الشكل كأنه يخالف قوانين المنظور لغياب الزوايا القائمة، فيلائم المنتجات الفاخرة والفنية.</a:t>
             </a:r>
           </a:p>
         </p:txBody>
@@ -6708,7 +7031,7 @@
       </p:sp>
       <p:pic>
         <p:nvPicPr>
-          <p:cNvPr id="16" name="Picture 15" descr="compress.png"/>
+          <p:cNvPr id="16" name="Picture 15" descr="stretch-corner.png"/>
           <p:cNvPicPr>
             <a:picLocks noChangeAspect="1"/>
           </p:cNvPicPr>
@@ -6722,8 +7045,8 @@
         </p:blipFill>
         <p:spPr>
           <a:xfrm>
-            <a:off x="720762" y="1600200"/>
-            <a:ext cx="4410635" cy="4389120"/>
+            <a:off x="457200" y="1605887"/>
+            <a:ext cx="4937760" cy="4377745"/>
           </a:xfrm>
           <a:prstGeom prst="rect">
             <a:avLst/>
@@ -6760,8 +7083,8 @@
         </p:nvSpPr>
         <p:spPr>
           <a:xfrm>
-            <a:off x="1005840" y="1600200"/>
-            <a:ext cx="10149840" cy="4389120"/>
+            <a:off x="5669280" y="1600200"/>
+            <a:ext cx="5852160" cy="4389120"/>
           </a:xfrm>
         </p:spPr>
         <p:txBody>
@@ -6775,95 +7098,59 @@
             </a:pPr>
             <a:r>
               <a:rPr lang="ar-SA" sz="2000" b="1"/>
-              <a:t>مقارنة شاملة بين التقنيات:</a:t>
-            </a:r>
-          </a:p>
-          <a:p>
-            <a:pPr/>
-            <a:r>
-              <a:rPr lang="ar-SA" sz="2000" b="1"/>
-              <a:t>كشط وجه (النحت، ٦ أوجه): </a:t>
-            </a:r>
-            <a:r>
-              <a:rPr lang="ar-SA" sz="2000"/>
-              <a:t>سطح علوي منحدر، وجانبان شبه منحرفين.</a:t>
-            </a:r>
-          </a:p>
-          <a:p>
-            <a:pPr/>
-            <a:r>
-              <a:rPr lang="ar-SA" sz="2000" b="1"/>
-              <a:t>كشط حافة (النحت، ٧ أوجه): </a:t>
-            </a:r>
-            <a:r>
-              <a:rPr lang="ar-SA" sz="2000"/>
-              <a:t>وجه مستطيل جديد، وجانبان خماسيان.</a:t>
-            </a:r>
-          </a:p>
-          <a:p>
-            <a:pPr/>
-            <a:r>
-              <a:rPr lang="ar-SA" sz="2000" b="1"/>
-              <a:t>كشط ركن (النحت، ٧ أوجه): </a:t>
-            </a:r>
-            <a:r>
-              <a:rPr lang="ar-SA" sz="2000"/>
-              <a:t>وجه مثلث جديد، وثلاثة أوجه خماسية.</a:t>
-            </a:r>
-          </a:p>
-          <a:p>
-            <a:pPr/>
-            <a:r>
-              <a:rPr lang="ar-SA" sz="2000" b="1"/>
-              <a:t>مطّ حافة لحافة (المرونة، ٦ أوجه): </a:t>
-            </a:r>
-            <a:r>
-              <a:rPr lang="ar-SA" sz="2000"/>
-              <a:t>وجهان متوازيا أضلاع، وصندوق مائل.</a:t>
-            </a:r>
-          </a:p>
-          <a:p>
-            <a:pPr/>
-            <a:r>
-              <a:rPr lang="ar-SA" sz="2000" b="1"/>
-              <a:t>مطّ ركن لركن (المرونة، ٦ أوجه): </a:t>
-            </a:r>
-            <a:r>
-              <a:rPr lang="ar-SA" sz="2000"/>
-              <a:t>جميع الأوجه معيّنات.</a:t>
-            </a:r>
-          </a:p>
-          <a:p>
-            <a:pPr/>
-            <a:r>
-              <a:rPr lang="ar-SA" sz="2000" b="1"/>
-              <a:t>ليّ بسيط (المرونة، ٦ أوجه): </a:t>
-            </a:r>
-            <a:r>
-              <a:rPr lang="ar-SA" sz="2000"/>
-              <a:t>جوانب متوازيات أضلاع بزاوية ٨٠°.</a:t>
-            </a:r>
-          </a:p>
-          <a:p>
-            <a:pPr/>
-            <a:r>
-              <a:rPr lang="ar-SA" sz="2000" b="1"/>
-              <a:t>ليّ مُضلَّع (المرونة، ١٠ أوجه): </a:t>
-            </a:r>
-            <a:r>
-              <a:rPr lang="ar-SA" sz="2000"/>
-              <a:t>مربعان وثمانية مثلثات.</a:t>
-            </a:r>
-          </a:p>
-          <a:p>
-            <a:pPr/>
-            <a:r>
-              <a:rPr lang="ar-SA" sz="2000" b="1"/>
-              <a:t>ضغط وجه لوجه (المرونة، ٦ أوجه): </a:t>
-            </a:r>
-            <a:r>
-              <a:rPr lang="ar-SA" sz="2000"/>
-              <a:t>جدران منثنية عند منتصفها.</a:t>
+              <a:t>ليّ الوجهين المتقابلين (Twisting Opposite Faces):</a:t>
+            </a:r>
+          </a:p>
+          <a:p>
+            <a:pPr marL="0" indent="0">
+              <a:buNone/>
+            </a:pPr>
+            <a:r>
+              <a:rPr lang="ar-SA" sz="2000" b="1"/>
+              <a:t>الاستراتيجية وعدد الأوجه: </a:t>
+            </a:r>
+            <a:r>
+              <a:rPr lang="ar-SA" sz="2000"/>
+              <a:t>المرونة، ٦ أوجه</a:t>
+            </a:r>
+          </a:p>
+          <a:p>
+            <a:pPr marL="0" indent="0">
+              <a:buNone/>
+            </a:pPr>
+            <a:r>
+              <a:rPr lang="ar-SA" sz="2000" b="1"/>
+              <a:t>المفهوم: </a:t>
+            </a:r>
+            <a:r>
+              <a:rPr lang="ar-SA" sz="2000"/>
+              <a:t>يُلوى الوجهان العلوي والسفلي ليًّا خفيفًا في اتجاهين متعاكسين، فتتحوّل الجوانب إلى متوازيات أضلاع. وزاوية الميل المثلى ٨٠°، والزوايا الأقل من ٧٠° نادرًا ما تنجح.</a:t>
+            </a:r>
+          </a:p>
+          <a:p>
+            <a:pPr marL="0" indent="0">
+              <a:buNone/>
+            </a:pPr>
+            <a:r>
+              <a:rPr lang="ar-SA" sz="2000" b="1"/>
+              <a:t>التحليل الشكلي: </a:t>
+            </a:r>
+            <a:r>
+              <a:rPr lang="ar-SA" sz="2000"/>
+              <a:t>يبقى الوجهان العلوي والسفلي مربعين، وتميل الأوجه الجانبية الأربعة في الاتجاه نفسه.</a:t>
+            </a:r>
+          </a:p>
+          <a:p>
+            <a:pPr marL="0" indent="0">
+              <a:buNone/>
+            </a:pPr>
+            <a:r>
+              <a:rPr lang="ar-SA" sz="2000" b="1"/>
+              <a:t>التوظيف في التغليف: </a:t>
+            </a:r>
+            <a:r>
+              <a:rPr lang="ar-SA" sz="2000"/>
+              <a:t>تشويه دقيق لا يُلحظ من النظرة الأولى ثم يكتشفه المستهلك عند التأمل، فيلائم العلامات الراقية.</a:t>
             </a:r>
           </a:p>
         </p:txBody>
@@ -6902,6 +7189,30 @@
           </a:p>
         </p:txBody>
       </p:sp>
+      <p:pic>
+        <p:nvPicPr>
+          <p:cNvPr id="16" name="Picture 15" descr="twist.png"/>
+          <p:cNvPicPr>
+            <a:picLocks noChangeAspect="1"/>
+          </p:cNvPicPr>
+          <p:nvPr/>
+        </p:nvPicPr>
+        <p:blipFill>
+          <a:blip r:embed="rId3"/>
+          <a:stretch>
+            <a:fillRect/>
+          </a:stretch>
+        </p:blipFill>
+        <p:spPr>
+          <a:xfrm>
+            <a:off x="712624" y="1600200"/>
+            <a:ext cx="4426910" cy="4389120"/>
+          </a:xfrm>
+          <a:prstGeom prst="rect">
+            <a:avLst/>
+          </a:prstGeom>
+        </p:spPr>
+      </p:pic>
     </p:spTree>
   </p:cSld>
   <p:clrMapOvr>
@@ -6947,7 +7258,7 @@
             </a:pPr>
             <a:r>
               <a:rPr lang="ar-SA" sz="2000" b="1"/>
-              <a:t>استراتيجية التقويس: المنحنيات المزدوجة (Double Curves):</a:t>
+              <a:t>الليّ: النسخة المُضلَّعة (Twisting: Faceted Version):</a:t>
             </a:r>
           </a:p>
           <a:p>
@@ -6955,8 +7266,12 @@
               <a:buNone/>
             </a:pPr>
             <a:r>
-              <a:rPr lang="ar-SA" sz="2000"/>
-              <a:t>يمكن استبدال أي حافة طي مستقيمة تقريبًا بمنحنى مزدوج، فتتحول العبوة الحادة إلى عبوة أنعم وأكثر زخرفة. ولأنها تتطلب دقة عالية تُرسم وفق الخطوات الآتية:</a:t>
+              <a:rPr lang="ar-SA" sz="2000" b="1"/>
+              <a:t>الاستراتيجية وعدد الأوجه: </a:t>
+            </a:r>
+            <a:r>
+              <a:rPr lang="ar-SA" sz="2000"/>
+              <a:t>المرونة، ١٠ أوجه</a:t>
             </a:r>
           </a:p>
           <a:p>
@@ -6965,11 +7280,11 @@
             </a:pPr>
             <a:r>
               <a:rPr lang="ar-SA" sz="2000" b="1"/>
-              <a:t>١. إعداد المِفرَد: </a:t>
-            </a:r>
-            <a:r>
-              <a:rPr lang="ar-SA" sz="2000"/>
-              <a:t>يُرسم مِفرَد قياسي بألسنته، وتُضاف خطوط إنشاء تمر بمراكز المربعات: خطّان طويلان وخطّان قصيران.</a:t>
+              <a:t>المفهوم: </a:t>
+            </a:r>
+            <a:r>
+              <a:rPr lang="ar-SA" sz="2000"/>
+              <a:t>يُزاد الليّ حتى تقع أركان المربع العلوي فوق منتصفات حواف المربع السفلي، ثم تُوصل الأركان الثمانية بخطوط طي.</a:t>
             </a:r>
           </a:p>
           <a:p>
@@ -6978,11 +7293,11 @@
             </a:pPr>
             <a:r>
               <a:rPr lang="ar-SA" sz="2000" b="1"/>
-              <a:t>٢. القوس الأول: </a:t>
-            </a:r>
-            <a:r>
-              <a:rPr lang="ar-SA" sz="2000"/>
-              <a:t>يُقاس طول الحافة ويُضاف إليه ٥٪ ليكون نصف القطر، ويُرسم قوس يمر بطرفي الحافة ومركزه على خط الإنشاء يمينها.</a:t>
+              <a:t>التحليل الشكلي: </a:t>
+            </a:r>
+            <a:r>
+              <a:rPr lang="ar-SA" sz="2000"/>
+              <a:t>مربعان وثمانية مثلثات متساوية الساقين (Antiprism)، ويتطلب ألسنة ذات حافة مثنية (Flanged Tabs).</a:t>
             </a:r>
           </a:p>
           <a:p>
@@ -6991,11 +7306,11 @@
             </a:pPr>
             <a:r>
               <a:rPr lang="ar-SA" sz="2000" b="1"/>
-              <a:t>٣. القوس الثاني: </a:t>
-            </a:r>
-            <a:r>
-              <a:rPr lang="ar-SA" sz="2000"/>
-              <a:t>تُكرَّر الخطوة السابقة على أن يقع المركز يسار الحافة.</a:t>
+              <a:t>التوظيف في التغليف: </a:t>
+            </a:r>
+            <a:r>
+              <a:rPr lang="ar-SA" sz="2000"/>
+              <a:t>شكل بلوري يحاكي الأحجار الكريمة، يلائم المجوهرات والشوكولاتة الفاخرة والشموع.</a:t>
             </a:r>
           </a:p>
         </p:txBody>
@@ -7036,31 +7351,7 @@
       </p:sp>
       <p:pic>
         <p:nvPicPr>
-          <p:cNvPr id="16" name="Picture 15" descr="dc2.png"/>
-          <p:cNvPicPr>
-            <a:picLocks noChangeAspect="1"/>
-          </p:cNvPicPr>
-          <p:nvPr/>
-        </p:nvPicPr>
-        <p:blipFill>
-          <a:blip r:embed="rId2"/>
-          <a:stretch>
-            <a:fillRect/>
-          </a:stretch>
-        </p:blipFill>
-        <p:spPr>
-          <a:xfrm>
-            <a:off x="1696009" y="1600200"/>
-            <a:ext cx="2460140" cy="2103120"/>
-          </a:xfrm>
-          <a:prstGeom prst="rect">
-            <a:avLst/>
-          </a:prstGeom>
-        </p:spPr>
-      </p:pic>
-      <p:pic>
-        <p:nvPicPr>
-          <p:cNvPr id="17" name="Picture 16" descr="dc3.png"/>
+          <p:cNvPr id="16" name="Picture 15" descr="twist-facet.png"/>
           <p:cNvPicPr>
             <a:picLocks noChangeAspect="1"/>
           </p:cNvPicPr>
@@ -7074,8 +7365,8 @@
         </p:blipFill>
         <p:spPr>
           <a:xfrm>
-            <a:off x="1514821" y="3886200"/>
-            <a:ext cx="2822517" cy="2103120"/>
+            <a:off x="457200" y="1732341"/>
+            <a:ext cx="4937760" cy="4124836"/>
           </a:xfrm>
           <a:prstGeom prst="rect">
             <a:avLst/>
@@ -7238,7 +7529,7 @@
             </a:pPr>
             <a:r>
               <a:rPr lang="ar-SA" sz="2000" b="1"/>
-              <a:t>المنحنيات المزدوجة: استكمال الخطوات</a:t>
+              <a:t>الضغط من وجه إلى وجه (Compressing Face-to-face):</a:t>
             </a:r>
           </a:p>
           <a:p>
@@ -7247,11 +7538,11 @@
             </a:pPr>
             <a:r>
               <a:rPr lang="ar-SA" sz="2000" b="1"/>
-              <a:t>٤. اكتمال المنحنى: </a:t>
-            </a:r>
-            <a:r>
-              <a:rPr lang="ar-SA" sz="2000"/>
-              <a:t>يلتقي القوسان عند طرفي الحافة ويشكّلان هيئة عدسية، هي المنحنى المزدوج.</a:t>
+              <a:t>الاستراتيجية وعدد الأوجه: </a:t>
+            </a:r>
+            <a:r>
+              <a:rPr lang="ar-SA" sz="2000"/>
+              <a:t>المرونة، ٦ أوجه</a:t>
             </a:r>
           </a:p>
           <a:p>
@@ -7260,11 +7551,11 @@
             </a:pPr>
             <a:r>
               <a:rPr lang="ar-SA" sz="2000" b="1"/>
-              <a:t>٥. تعميم المنحنيات: </a:t>
-            </a:r>
-            <a:r>
-              <a:rPr lang="ar-SA" sz="2000"/>
-              <a:t>تُضاف ثلاثة منحنيات أخرى بخطوط الإنشاء الطويلة، وتُرسم منحنيات مفردة قصيرة على الألسنة الأربعة بالخطوط القصيرة.</a:t>
+              <a:t>المفهوم: </a:t>
+            </a:r>
+            <a:r>
+              <a:rPr lang="ar-SA" sz="2000"/>
+              <a:t>يُضغط وجهان متقابلان باتجاه بعضهما، والشكل المعروض تبسيط تصميمي (Stylization) لشكل هلامي منحنٍ أكثر تعقيدًا. ورغم مظهره المضغوط تساوي مساحة الورق مساحة المكعّب الأصلي.</a:t>
             </a:r>
           </a:p>
           <a:p>
@@ -7273,11 +7564,24 @@
             </a:pPr>
             <a:r>
               <a:rPr lang="ar-SA" sz="2000" b="1"/>
-              <a:t>٦. الشكل النهائي: </a:t>
-            </a:r>
-            <a:r>
-              <a:rPr lang="ar-SA" sz="2000"/>
-              <a:t>مكعّب تبدو حواف وجهه العلوي مقعّرة ولينة.</a:t>
+              <a:t>التحليل الشكلي: </a:t>
+            </a:r>
+            <a:r>
+              <a:rPr lang="ar-SA" sz="2000"/>
+              <a:t>ينقسم كل جدار بخط طي أفقي في منتصفه فينثني عنده.</a:t>
+            </a:r>
+          </a:p>
+          <a:p>
+            <a:pPr marL="0" indent="0">
+              <a:buNone/>
+            </a:pPr>
+            <a:r>
+              <a:rPr lang="ar-SA" sz="2000" b="1"/>
+              <a:t>التوظيف في التغليف: </a:t>
+            </a:r>
+            <a:r>
+              <a:rPr lang="ar-SA" sz="2000"/>
+              <a:t>شكل يوحي بالمرونة والطرافة، ويلائم المنتجات اللينة ومنتجات الأطفال.</a:t>
             </a:r>
           </a:p>
         </p:txBody>
@@ -7318,31 +7622,7 @@
       </p:sp>
       <p:pic>
         <p:nvPicPr>
-          <p:cNvPr id="16" name="Picture 15" descr="dc4b.png"/>
-          <p:cNvPicPr>
-            <a:picLocks noChangeAspect="1"/>
-          </p:cNvPicPr>
-          <p:nvPr/>
-        </p:nvPicPr>
-        <p:blipFill>
-          <a:blip r:embed="rId2"/>
-          <a:stretch>
-            <a:fillRect/>
-          </a:stretch>
-        </p:blipFill>
-        <p:spPr>
-          <a:xfrm>
-            <a:off x="457200" y="1658186"/>
-            <a:ext cx="4937760" cy="1987147"/>
-          </a:xfrm>
-          <a:prstGeom prst="rect">
-            <a:avLst/>
-          </a:prstGeom>
-        </p:spPr>
-      </p:pic>
-      <p:pic>
-        <p:nvPicPr>
-          <p:cNvPr id="17" name="Picture 16" descr="dc5.png"/>
+          <p:cNvPr id="16" name="Picture 15" descr="compress.png"/>
           <p:cNvPicPr>
             <a:picLocks noChangeAspect="1"/>
           </p:cNvPicPr>
@@ -7356,8 +7636,8 @@
         </p:blipFill>
         <p:spPr>
           <a:xfrm>
-            <a:off x="1871639" y="3886200"/>
-            <a:ext cx="2108881" cy="2103120"/>
+            <a:off x="720762" y="1600200"/>
+            <a:ext cx="4410635" cy="4389120"/>
           </a:xfrm>
           <a:prstGeom prst="rect">
             <a:avLst/>
@@ -7394,8 +7674,8 @@
         </p:nvSpPr>
         <p:spPr>
           <a:xfrm>
-            <a:off x="5669280" y="1600200"/>
-            <a:ext cx="5852160" cy="4389120"/>
+            <a:off x="1005840" y="1600200"/>
+            <a:ext cx="10149840" cy="4389120"/>
           </a:xfrm>
         </p:spPr>
         <p:txBody>
@@ -7409,54 +7689,95 @@
             </a:pPr>
             <a:r>
               <a:rPr lang="ar-SA" sz="2000" b="1"/>
-              <a:t>حساب نصف قطر المنحنى:</a:t>
-            </a:r>
-          </a:p>
-          <a:p>
-            <a:pPr marL="0" indent="0">
-              <a:buNone/>
-            </a:pPr>
-            <a:r>
-              <a:rPr lang="ar-SA" sz="2000" b="1"/>
-              <a:t>القاعدة: </a:t>
-            </a:r>
-            <a:r>
-              <a:rPr lang="ar-SA" sz="2000"/>
-              <a:t>نصف القطر = طول الحافة + ٥٪</a:t>
+              <a:t>مقارنة شاملة بين التقنيات:</a:t>
             </a:r>
           </a:p>
           <a:p>
             <a:pPr/>
             <a:r>
-              <a:rPr lang="ar-SA" sz="2000"/>
-              <a:t>حافة طولها ١٠ سم ← نصف القطر ١٠٫٥ سم.</a:t>
+              <a:rPr lang="ar-SA" sz="2000" b="1"/>
+              <a:t>كشط وجه (النحت، ٦ أوجه): </a:t>
+            </a:r>
+            <a:r>
+              <a:rPr lang="ar-SA" sz="2000"/>
+              <a:t>سطح علوي منحدر، وجانبان شبه منحرفين.</a:t>
             </a:r>
           </a:p>
           <a:p>
             <a:pPr/>
             <a:r>
-              <a:rPr lang="ar-SA" sz="2000"/>
-              <a:t>حافة طولها ٨ سم ← نصف القطر ٨٫٤ سم.</a:t>
+              <a:rPr lang="ar-SA" sz="2000" b="1"/>
+              <a:t>كشط حافة (النحت، ٧ أوجه): </a:t>
+            </a:r>
+            <a:r>
+              <a:rPr lang="ar-SA" sz="2000"/>
+              <a:t>وجه مستطيل جديد، وجانبان خماسيان.</a:t>
             </a:r>
           </a:p>
           <a:p>
             <a:pPr/>
             <a:r>
-              <a:rPr lang="ar-SA" sz="2000"/>
-              <a:t>حافة طولها ١٢ سم ← نصف القطر ١٢٫٦ سم.</a:t>
-            </a:r>
-          </a:p>
-          <a:p>
-            <a:pPr marL="0" indent="0">
-              <a:buNone/>
-            </a:pPr>
-            <a:r>
-              <a:rPr lang="ar-SA" sz="2000" b="1"/>
-              <a:t>علّة النسبة: </a:t>
-            </a:r>
-            <a:r>
-              <a:rPr lang="ar-SA" sz="2000"/>
-              <a:t>نصف القطر الكبير نسبيًا يعطي قوسًا لطيف الانحناء يسهل طيّه، في حين يؤدي نصف القطر الصغير إلى منحنى حاد يصعب تنفيذه على الورق.</a:t>
+              <a:rPr lang="ar-SA" sz="2000" b="1"/>
+              <a:t>كشط ركن (النحت، ٧ أوجه): </a:t>
+            </a:r>
+            <a:r>
+              <a:rPr lang="ar-SA" sz="2000"/>
+              <a:t>وجه مثلث جديد، وثلاثة أوجه خماسية.</a:t>
+            </a:r>
+          </a:p>
+          <a:p>
+            <a:pPr/>
+            <a:r>
+              <a:rPr lang="ar-SA" sz="2000" b="1"/>
+              <a:t>مطّ حافة لحافة (المرونة، ٦ أوجه): </a:t>
+            </a:r>
+            <a:r>
+              <a:rPr lang="ar-SA" sz="2000"/>
+              <a:t>وجهان متوازيا أضلاع، وصندوق مائل.</a:t>
+            </a:r>
+          </a:p>
+          <a:p>
+            <a:pPr/>
+            <a:r>
+              <a:rPr lang="ar-SA" sz="2000" b="1"/>
+              <a:t>مطّ ركن لركن (المرونة، ٦ أوجه): </a:t>
+            </a:r>
+            <a:r>
+              <a:rPr lang="ar-SA" sz="2000"/>
+              <a:t>جميع الأوجه معيّنات.</a:t>
+            </a:r>
+          </a:p>
+          <a:p>
+            <a:pPr/>
+            <a:r>
+              <a:rPr lang="ar-SA" sz="2000" b="1"/>
+              <a:t>ليّ بسيط (المرونة، ٦ أوجه): </a:t>
+            </a:r>
+            <a:r>
+              <a:rPr lang="ar-SA" sz="2000"/>
+              <a:t>جوانب متوازيات أضلاع بزاوية ٨٠°.</a:t>
+            </a:r>
+          </a:p>
+          <a:p>
+            <a:pPr/>
+            <a:r>
+              <a:rPr lang="ar-SA" sz="2000" b="1"/>
+              <a:t>ليّ مُضلَّع (المرونة، ١٠ أوجه): </a:t>
+            </a:r>
+            <a:r>
+              <a:rPr lang="ar-SA" sz="2000"/>
+              <a:t>مربعان وثمانية مثلثات.</a:t>
+            </a:r>
+          </a:p>
+          <a:p>
+            <a:pPr/>
+            <a:r>
+              <a:rPr lang="ar-SA" sz="2000" b="1"/>
+              <a:t>ضغط وجه لوجه (المرونة، ٦ أوجه): </a:t>
+            </a:r>
+            <a:r>
+              <a:rPr lang="ar-SA" sz="2000"/>
+              <a:t>جدران منثنية عند منتصفها.</a:t>
             </a:r>
           </a:p>
         </p:txBody>
@@ -7495,30 +7816,6 @@
           </a:p>
         </p:txBody>
       </p:sp>
-      <p:pic>
-        <p:nvPicPr>
-          <p:cNvPr id="16" name="Picture 15" descr="dc2.png"/>
-          <p:cNvPicPr>
-            <a:picLocks noChangeAspect="1"/>
-          </p:cNvPicPr>
-          <p:nvPr/>
-        </p:nvPicPr>
-        <p:blipFill>
-          <a:blip r:embed="rId2"/>
-          <a:stretch>
-            <a:fillRect/>
-          </a:stretch>
-        </p:blipFill>
-        <p:spPr>
-          <a:xfrm>
-            <a:off x="457200" y="1684168"/>
-            <a:ext cx="4937760" cy="4221182"/>
-          </a:xfrm>
-          <a:prstGeom prst="rect">
-            <a:avLst/>
-          </a:prstGeom>
-        </p:spPr>
-      </p:pic>
     </p:spTree>
   </p:cSld>
   <p:clrMapOvr>
@@ -7564,7 +7861,7 @@
             </a:pPr>
             <a:r>
               <a:rPr lang="ar-SA" sz="2000" b="1"/>
-              <a:t>تنفيذ الطيات المنحنية بالقالب:</a:t>
+              <a:t>استراتيجية التقويس: المنحنيات المزدوجة (Double Curves):</a:t>
             </a:r>
           </a:p>
           <a:p>
@@ -7573,7 +7870,7 @@
             </a:pPr>
             <a:r>
               <a:rPr lang="ar-SA" sz="2000"/>
-              <a:t>يتعذّر تنفيذ طيّة منحنية دقيقة باليد الحرة، لأن أداة الطي تحتاج إلى دليل تسير عليه، والحل استخدام قالب:</a:t>
+              <a:t>يمكن استبدال أي حافة طي مستقيمة تقريبًا بمنحنى مزدوج، فتتحول العبوة الحادة إلى عبوة أنعم وأكثر زخرفة. ولأنها تتطلب دقة عالية تُرسم وفق الخطوات الآتية:</a:t>
             </a:r>
           </a:p>
           <a:p>
@@ -7582,11 +7879,11 @@
             </a:pPr>
             <a:r>
               <a:rPr lang="ar-SA" sz="2000" b="1"/>
-              <a:t>١. </a:t>
-            </a:r>
-            <a:r>
-              <a:rPr lang="ar-SA" sz="2000"/>
-              <a:t>يُرسم على ورق مقوّى زائد قطاع دائري يشبه «قطعة الفطيرة» بنصف قطر المنحنى المطلوب نفسه.</a:t>
+              <a:t>١. إعداد المِفرَد: </a:t>
+            </a:r>
+            <a:r>
+              <a:rPr lang="ar-SA" sz="2000"/>
+              <a:t>يُرسم مِفرَد قياسي بألسنته، وتُضاف خطوط إنشاء تمر بمراكز المربعات: خطّان طويلان وخطّان قصيران.</a:t>
             </a:r>
           </a:p>
           <a:p>
@@ -7595,11 +7892,11 @@
             </a:pPr>
             <a:r>
               <a:rPr lang="ar-SA" sz="2000" b="1"/>
-              <a:t>٢. </a:t>
-            </a:r>
-            <a:r>
-              <a:rPr lang="ar-SA" sz="2000"/>
-              <a:t>يُقص القالب بدقة عالية، لأن أي عيب في حافته ينتقل إلى الطيّة.</a:t>
+              <a:t>٢. القوس الأول: </a:t>
+            </a:r>
+            <a:r>
+              <a:rPr lang="ar-SA" sz="2000"/>
+              <a:t>يُقاس طول الحافة ويُضاف إليه ٥٪ ليكون نصف القطر، ويُرسم قوس يمر بطرفي الحافة ومركزه على خط الإنشاء يمينها.</a:t>
             </a:r>
           </a:p>
           <a:p>
@@ -7608,24 +7905,11 @@
             </a:pPr>
             <a:r>
               <a:rPr lang="ar-SA" sz="2000" b="1"/>
-              <a:t>٣. </a:t>
-            </a:r>
-            <a:r>
-              <a:rPr lang="ar-SA" sz="2000"/>
-              <a:t>يوضع القالب على المِفرَد في موضع المنحنى تمامًا.</a:t>
-            </a:r>
-          </a:p>
-          <a:p>
-            <a:pPr marL="0" indent="0">
-              <a:buNone/>
-            </a:pPr>
-            <a:r>
-              <a:rPr lang="ar-SA" sz="2000" b="1"/>
-              <a:t>٤. </a:t>
-            </a:r>
-            <a:r>
-              <a:rPr lang="ar-SA" sz="2000"/>
-              <a:t>تُنفّذ الطيّة باستخدام حافة القالب دليلًا لأداة الطي، ويُفضَّل استخدام الشفرة الكالّة المقلوبة.</a:t>
+              <a:t>٣. القوس الثاني: </a:t>
+            </a:r>
+            <a:r>
+              <a:rPr lang="ar-SA" sz="2000"/>
+              <a:t>تُكرَّر الخطوة السابقة على أن يقع المركز يسار الحافة.</a:t>
             </a:r>
           </a:p>
         </p:txBody>
@@ -7666,7 +7950,7 @@
       </p:sp>
       <p:pic>
         <p:nvPicPr>
-          <p:cNvPr id="16" name="Picture 15" descr="wedge.png"/>
+          <p:cNvPr id="16" name="Picture 15" descr="dc2.png"/>
           <p:cNvPicPr>
             <a:picLocks noChangeAspect="1"/>
           </p:cNvPicPr>
@@ -7680,8 +7964,32 @@
         </p:blipFill>
         <p:spPr>
           <a:xfrm>
-            <a:off x="575462" y="1600200"/>
-            <a:ext cx="4701235" cy="4389120"/>
+            <a:off x="1696009" y="1600200"/>
+            <a:ext cx="2460140" cy="2103120"/>
+          </a:xfrm>
+          <a:prstGeom prst="rect">
+            <a:avLst/>
+          </a:prstGeom>
+        </p:spPr>
+      </p:pic>
+      <p:pic>
+        <p:nvPicPr>
+          <p:cNvPr id="17" name="Picture 16" descr="dc3.png"/>
+          <p:cNvPicPr>
+            <a:picLocks noChangeAspect="1"/>
+          </p:cNvPicPr>
+          <p:nvPr/>
+        </p:nvPicPr>
+        <p:blipFill>
+          <a:blip r:embed="rId3"/>
+          <a:stretch>
+            <a:fillRect/>
+          </a:stretch>
+        </p:blipFill>
+        <p:spPr>
+          <a:xfrm>
+            <a:off x="1514821" y="3886200"/>
+            <a:ext cx="2822517" cy="2103120"/>
           </a:xfrm>
           <a:prstGeom prst="rect">
             <a:avLst/>
@@ -7733,6 +8041,501 @@
             </a:pPr>
             <a:r>
               <a:rPr lang="ar-SA" sz="2000" b="1"/>
+              <a:t>المنحنيات المزدوجة: استكمال الخطوات</a:t>
+            </a:r>
+          </a:p>
+          <a:p>
+            <a:pPr marL="0" indent="0">
+              <a:buNone/>
+            </a:pPr>
+            <a:r>
+              <a:rPr lang="ar-SA" sz="2000" b="1"/>
+              <a:t>٤. اكتمال المنحنى: </a:t>
+            </a:r>
+            <a:r>
+              <a:rPr lang="ar-SA" sz="2000"/>
+              <a:t>يلتقي القوسان عند طرفي الحافة ويشكّلان هيئة عدسية، هي المنحنى المزدوج.</a:t>
+            </a:r>
+          </a:p>
+          <a:p>
+            <a:pPr marL="0" indent="0">
+              <a:buNone/>
+            </a:pPr>
+            <a:r>
+              <a:rPr lang="ar-SA" sz="2000" b="1"/>
+              <a:t>٥. تعميم المنحنيات: </a:t>
+            </a:r>
+            <a:r>
+              <a:rPr lang="ar-SA" sz="2000"/>
+              <a:t>تُضاف ثلاثة منحنيات أخرى بخطوط الإنشاء الطويلة، وتُرسم منحنيات مفردة قصيرة على الألسنة الأربعة بالخطوط القصيرة.</a:t>
+            </a:r>
+          </a:p>
+          <a:p>
+            <a:pPr marL="0" indent="0">
+              <a:buNone/>
+            </a:pPr>
+            <a:r>
+              <a:rPr lang="ar-SA" sz="2000" b="1"/>
+              <a:t>٦. الشكل النهائي: </a:t>
+            </a:r>
+            <a:r>
+              <a:rPr lang="ar-SA" sz="2000"/>
+              <a:t>مكعّب تبدو حواف وجهه العلوي مقعّرة ولينة.</a:t>
+            </a:r>
+          </a:p>
+        </p:txBody>
+      </p:sp>
+      <p:sp>
+        <p:nvSpPr>
+          <p:cNvPr id="15" name="Footer Placeholder 3">
+            <a:extLst>
+              <a:ext uri="{FF2B5EF4-FFF2-40B4-BE49-F238E27FC236}">
+                <a16:creationId xmlns:a16="http://schemas.microsoft.com/office/drawing/2014/main" id="{CFE48E32-A7F6-E621-F2A2-8E8D30A65EAF}"/>
+              </a:ext>
+            </a:extLst>
+          </p:cNvPr>
+          <p:cNvSpPr>
+            <a:spLocks noGrp="1"/>
+          </p:cNvSpPr>
+          <p:nvPr>
+            <p:ph type="ftr" sz="quarter" idx="11"/>
+          </p:nvPr>
+        </p:nvSpPr>
+        <p:spPr>
+          <a:xfrm>
+            <a:off x="4038600" y="6356350"/>
+            <a:ext cx="4114800" cy="365125"/>
+          </a:xfrm>
+        </p:spPr>
+        <p:txBody>
+          <a:bodyPr/>
+          <a:lstStyle/>
+          <a:p>
+            <a:r>
+              <a:rPr lang="ar-SA" dirty="0"/>
+              <a:t>برنامج التصميم الجرافيكي - المستوى السادس</a:t>
+            </a:r>
+            <a:endParaRPr lang="en-US" dirty="0"/>
+          </a:p>
+        </p:txBody>
+      </p:sp>
+      <p:pic>
+        <p:nvPicPr>
+          <p:cNvPr id="16" name="Picture 15" descr="dc4b.png"/>
+          <p:cNvPicPr>
+            <a:picLocks noChangeAspect="1"/>
+          </p:cNvPicPr>
+          <p:nvPr/>
+        </p:nvPicPr>
+        <p:blipFill>
+          <a:blip r:embed="rId2"/>
+          <a:stretch>
+            <a:fillRect/>
+          </a:stretch>
+        </p:blipFill>
+        <p:spPr>
+          <a:xfrm>
+            <a:off x="457200" y="1658186"/>
+            <a:ext cx="4937760" cy="1987147"/>
+          </a:xfrm>
+          <a:prstGeom prst="rect">
+            <a:avLst/>
+          </a:prstGeom>
+        </p:spPr>
+      </p:pic>
+      <p:pic>
+        <p:nvPicPr>
+          <p:cNvPr id="17" name="Picture 16" descr="dc5.png"/>
+          <p:cNvPicPr>
+            <a:picLocks noChangeAspect="1"/>
+          </p:cNvPicPr>
+          <p:nvPr/>
+        </p:nvPicPr>
+        <p:blipFill>
+          <a:blip r:embed="rId3"/>
+          <a:stretch>
+            <a:fillRect/>
+          </a:stretch>
+        </p:blipFill>
+        <p:spPr>
+          <a:xfrm>
+            <a:off x="1871639" y="3886200"/>
+            <a:ext cx="2108881" cy="2103120"/>
+          </a:xfrm>
+          <a:prstGeom prst="rect">
+            <a:avLst/>
+          </a:prstGeom>
+        </p:spPr>
+      </p:pic>
+    </p:spTree>
+  </p:cSld>
+  <p:clrMapOvr>
+    <a:masterClrMapping/>
+  </p:clrMapOvr>
+</p:sld>
+</file>
+
+<file path=ppt/slides/slide24.xml><?xml version="1.0" encoding="utf-8"?>
+<p:sld xmlns:a="http://schemas.openxmlformats.org/drawingml/2006/main" xmlns:p="http://schemas.openxmlformats.org/presentationml/2006/main" xmlns:r="http://schemas.openxmlformats.org/officeDocument/2006/relationships">
+  <p:cSld>
+    <p:spTree>
+      <p:nvGrpSpPr>
+        <p:cNvPr id="1" name=""/>
+        <p:cNvGrpSpPr/>
+        <p:nvPr/>
+      </p:nvGrpSpPr>
+      <p:grpSpPr/>
+      <p:sp>
+        <p:nvSpPr>
+          <p:cNvPr id="3" name="Content Placeholder 2"/>
+          <p:cNvSpPr>
+            <a:spLocks noGrp="1"/>
+          </p:cNvSpPr>
+          <p:nvPr>
+            <p:ph idx="1"/>
+          </p:nvPr>
+        </p:nvSpPr>
+        <p:spPr>
+          <a:xfrm>
+            <a:off x="5669280" y="1600200"/>
+            <a:ext cx="5852160" cy="4389120"/>
+          </a:xfrm>
+        </p:spPr>
+        <p:txBody>
+          <a:bodyPr anchor="ctr">
+            <a:normAutofit/>
+          </a:bodyPr>
+          <a:lstStyle/>
+          <a:p>
+            <a:pPr marL="0" indent="0">
+              <a:buNone/>
+            </a:pPr>
+            <a:r>
+              <a:rPr lang="ar-SA" sz="2000" b="1"/>
+              <a:t>حساب نصف قطر المنحنى:</a:t>
+            </a:r>
+          </a:p>
+          <a:p>
+            <a:pPr marL="0" indent="0">
+              <a:buNone/>
+            </a:pPr>
+            <a:r>
+              <a:rPr lang="ar-SA" sz="2000" b="1"/>
+              <a:t>القاعدة: </a:t>
+            </a:r>
+            <a:r>
+              <a:rPr lang="ar-SA" sz="2000"/>
+              <a:t>نصف القطر = طول الحافة + ٥٪</a:t>
+            </a:r>
+          </a:p>
+          <a:p>
+            <a:pPr/>
+            <a:r>
+              <a:rPr lang="ar-SA" sz="2000"/>
+              <a:t>حافة طولها ١٠ سم ← نصف القطر ١٠٫٥ سم.</a:t>
+            </a:r>
+          </a:p>
+          <a:p>
+            <a:pPr/>
+            <a:r>
+              <a:rPr lang="ar-SA" sz="2000"/>
+              <a:t>حافة طولها ٨ سم ← نصف القطر ٨٫٤ سم.</a:t>
+            </a:r>
+          </a:p>
+          <a:p>
+            <a:pPr/>
+            <a:r>
+              <a:rPr lang="ar-SA" sz="2000"/>
+              <a:t>حافة طولها ١٢ سم ← نصف القطر ١٢٫٦ سم.</a:t>
+            </a:r>
+          </a:p>
+          <a:p>
+            <a:pPr marL="0" indent="0">
+              <a:buNone/>
+            </a:pPr>
+            <a:r>
+              <a:rPr lang="ar-SA" sz="2000" b="1"/>
+              <a:t>علّة النسبة: </a:t>
+            </a:r>
+            <a:r>
+              <a:rPr lang="ar-SA" sz="2000"/>
+              <a:t>نصف القطر الكبير نسبيًا يعطي قوسًا لطيف الانحناء يسهل طيّه، في حين يؤدي نصف القطر الصغير إلى منحنى حاد يصعب تنفيذه على الورق.</a:t>
+            </a:r>
+          </a:p>
+        </p:txBody>
+      </p:sp>
+      <p:sp>
+        <p:nvSpPr>
+          <p:cNvPr id="15" name="Footer Placeholder 3">
+            <a:extLst>
+              <a:ext uri="{FF2B5EF4-FFF2-40B4-BE49-F238E27FC236}">
+                <a16:creationId xmlns:a16="http://schemas.microsoft.com/office/drawing/2014/main" id="{CFE48E32-A7F6-E621-F2A2-8E8D30A65EAF}"/>
+              </a:ext>
+            </a:extLst>
+          </p:cNvPr>
+          <p:cNvSpPr>
+            <a:spLocks noGrp="1"/>
+          </p:cNvSpPr>
+          <p:nvPr>
+            <p:ph type="ftr" sz="quarter" idx="11"/>
+          </p:nvPr>
+        </p:nvSpPr>
+        <p:spPr>
+          <a:xfrm>
+            <a:off x="4038600" y="6356350"/>
+            <a:ext cx="4114800" cy="365125"/>
+          </a:xfrm>
+        </p:spPr>
+        <p:txBody>
+          <a:bodyPr/>
+          <a:lstStyle/>
+          <a:p>
+            <a:r>
+              <a:rPr lang="ar-SA" dirty="0"/>
+              <a:t>برنامج التصميم الجرافيكي - المستوى السادس</a:t>
+            </a:r>
+            <a:endParaRPr lang="en-US" dirty="0"/>
+          </a:p>
+        </p:txBody>
+      </p:sp>
+      <p:pic>
+        <p:nvPicPr>
+          <p:cNvPr id="16" name="Picture 15" descr="dc2.png"/>
+          <p:cNvPicPr>
+            <a:picLocks noChangeAspect="1"/>
+          </p:cNvPicPr>
+          <p:nvPr/>
+        </p:nvPicPr>
+        <p:blipFill>
+          <a:blip r:embed="rId2"/>
+          <a:stretch>
+            <a:fillRect/>
+          </a:stretch>
+        </p:blipFill>
+        <p:spPr>
+          <a:xfrm>
+            <a:off x="457200" y="1684168"/>
+            <a:ext cx="4937760" cy="4221182"/>
+          </a:xfrm>
+          <a:prstGeom prst="rect">
+            <a:avLst/>
+          </a:prstGeom>
+        </p:spPr>
+      </p:pic>
+    </p:spTree>
+  </p:cSld>
+  <p:clrMapOvr>
+    <a:masterClrMapping/>
+  </p:clrMapOvr>
+</p:sld>
+</file>
+
+<file path=ppt/slides/slide25.xml><?xml version="1.0" encoding="utf-8"?>
+<p:sld xmlns:a="http://schemas.openxmlformats.org/drawingml/2006/main" xmlns:p="http://schemas.openxmlformats.org/presentationml/2006/main" xmlns:r="http://schemas.openxmlformats.org/officeDocument/2006/relationships">
+  <p:cSld>
+    <p:spTree>
+      <p:nvGrpSpPr>
+        <p:cNvPr id="1" name=""/>
+        <p:cNvGrpSpPr/>
+        <p:nvPr/>
+      </p:nvGrpSpPr>
+      <p:grpSpPr/>
+      <p:sp>
+        <p:nvSpPr>
+          <p:cNvPr id="3" name="Content Placeholder 2"/>
+          <p:cNvSpPr>
+            <a:spLocks noGrp="1"/>
+          </p:cNvSpPr>
+          <p:nvPr>
+            <p:ph idx="1"/>
+          </p:nvPr>
+        </p:nvSpPr>
+        <p:spPr>
+          <a:xfrm>
+            <a:off x="5669280" y="1600200"/>
+            <a:ext cx="5852160" cy="4389120"/>
+          </a:xfrm>
+        </p:spPr>
+        <p:txBody>
+          <a:bodyPr anchor="ctr">
+            <a:normAutofit/>
+          </a:bodyPr>
+          <a:lstStyle/>
+          <a:p>
+            <a:pPr marL="0" indent="0">
+              <a:buNone/>
+            </a:pPr>
+            <a:r>
+              <a:rPr lang="ar-SA" sz="2000" b="1"/>
+              <a:t>تنفيذ الطيات المنحنية بالقالب:</a:t>
+            </a:r>
+          </a:p>
+          <a:p>
+            <a:pPr marL="0" indent="0">
+              <a:buNone/>
+            </a:pPr>
+            <a:r>
+              <a:rPr lang="ar-SA" sz="2000"/>
+              <a:t>يتعذّر تنفيذ طيّة منحنية دقيقة باليد الحرة، لأن أداة الطي تحتاج إلى دليل تسير عليه، والحل استخدام قالب:</a:t>
+            </a:r>
+          </a:p>
+          <a:p>
+            <a:pPr marL="0" indent="0">
+              <a:buNone/>
+            </a:pPr>
+            <a:r>
+              <a:rPr lang="ar-SA" sz="2000" b="1"/>
+              <a:t>١. </a:t>
+            </a:r>
+            <a:r>
+              <a:rPr lang="ar-SA" sz="2000"/>
+              <a:t>يُرسم على ورق مقوّى زائد قطاع دائري يشبه «قطعة الفطيرة» بنصف قطر المنحنى المطلوب نفسه.</a:t>
+            </a:r>
+          </a:p>
+          <a:p>
+            <a:pPr marL="0" indent="0">
+              <a:buNone/>
+            </a:pPr>
+            <a:r>
+              <a:rPr lang="ar-SA" sz="2000" b="1"/>
+              <a:t>٢. </a:t>
+            </a:r>
+            <a:r>
+              <a:rPr lang="ar-SA" sz="2000"/>
+              <a:t>يُقص القالب بدقة عالية، لأن أي عيب في حافته ينتقل إلى الطيّة.</a:t>
+            </a:r>
+          </a:p>
+          <a:p>
+            <a:pPr marL="0" indent="0">
+              <a:buNone/>
+            </a:pPr>
+            <a:r>
+              <a:rPr lang="ar-SA" sz="2000" b="1"/>
+              <a:t>٣. </a:t>
+            </a:r>
+            <a:r>
+              <a:rPr lang="ar-SA" sz="2000"/>
+              <a:t>يوضع القالب على المِفرَد في موضع المنحنى تمامًا.</a:t>
+            </a:r>
+          </a:p>
+          <a:p>
+            <a:pPr marL="0" indent="0">
+              <a:buNone/>
+            </a:pPr>
+            <a:r>
+              <a:rPr lang="ar-SA" sz="2000" b="1"/>
+              <a:t>٤. </a:t>
+            </a:r>
+            <a:r>
+              <a:rPr lang="ar-SA" sz="2000"/>
+              <a:t>تُنفّذ الطيّة باستخدام حافة القالب دليلًا لأداة الطي، ويُفضَّل استخدام الشفرة الكالّة المقلوبة.</a:t>
+            </a:r>
+          </a:p>
+        </p:txBody>
+      </p:sp>
+      <p:sp>
+        <p:nvSpPr>
+          <p:cNvPr id="15" name="Footer Placeholder 3">
+            <a:extLst>
+              <a:ext uri="{FF2B5EF4-FFF2-40B4-BE49-F238E27FC236}">
+                <a16:creationId xmlns:a16="http://schemas.microsoft.com/office/drawing/2014/main" id="{CFE48E32-A7F6-E621-F2A2-8E8D30A65EAF}"/>
+              </a:ext>
+            </a:extLst>
+          </p:cNvPr>
+          <p:cNvSpPr>
+            <a:spLocks noGrp="1"/>
+          </p:cNvSpPr>
+          <p:nvPr>
+            <p:ph type="ftr" sz="quarter" idx="11"/>
+          </p:nvPr>
+        </p:nvSpPr>
+        <p:spPr>
+          <a:xfrm>
+            <a:off x="4038600" y="6356350"/>
+            <a:ext cx="4114800" cy="365125"/>
+          </a:xfrm>
+        </p:spPr>
+        <p:txBody>
+          <a:bodyPr/>
+          <a:lstStyle/>
+          <a:p>
+            <a:r>
+              <a:rPr lang="ar-SA" dirty="0"/>
+              <a:t>برنامج التصميم الجرافيكي - المستوى السادس</a:t>
+            </a:r>
+            <a:endParaRPr lang="en-US" dirty="0"/>
+          </a:p>
+        </p:txBody>
+      </p:sp>
+      <p:pic>
+        <p:nvPicPr>
+          <p:cNvPr id="16" name="Picture 15" descr="wedge.png"/>
+          <p:cNvPicPr>
+            <a:picLocks noChangeAspect="1"/>
+          </p:cNvPicPr>
+          <p:nvPr/>
+        </p:nvPicPr>
+        <p:blipFill>
+          <a:blip r:embed="rId2"/>
+          <a:stretch>
+            <a:fillRect/>
+          </a:stretch>
+        </p:blipFill>
+        <p:spPr>
+          <a:xfrm>
+            <a:off x="575462" y="1600200"/>
+            <a:ext cx="4701235" cy="4389120"/>
+          </a:xfrm>
+          <a:prstGeom prst="rect">
+            <a:avLst/>
+          </a:prstGeom>
+        </p:spPr>
+      </p:pic>
+    </p:spTree>
+  </p:cSld>
+  <p:clrMapOvr>
+    <a:masterClrMapping/>
+  </p:clrMapOvr>
+</p:sld>
+</file>
+
+<file path=ppt/slides/slide26.xml><?xml version="1.0" encoding="utf-8"?>
+<p:sld xmlns:a="http://schemas.openxmlformats.org/drawingml/2006/main" xmlns:p="http://schemas.openxmlformats.org/presentationml/2006/main" xmlns:r="http://schemas.openxmlformats.org/officeDocument/2006/relationships">
+  <p:cSld>
+    <p:spTree>
+      <p:nvGrpSpPr>
+        <p:cNvPr id="1" name=""/>
+        <p:cNvGrpSpPr/>
+        <p:nvPr/>
+      </p:nvGrpSpPr>
+      <p:grpSpPr/>
+      <p:sp>
+        <p:nvSpPr>
+          <p:cNvPr id="3" name="Content Placeholder 2"/>
+          <p:cNvSpPr>
+            <a:spLocks noGrp="1"/>
+          </p:cNvSpPr>
+          <p:nvPr>
+            <p:ph idx="1"/>
+          </p:nvPr>
+        </p:nvSpPr>
+        <p:spPr>
+          <a:xfrm>
+            <a:off x="5669280" y="1600200"/>
+            <a:ext cx="5852160" cy="4389120"/>
+          </a:xfrm>
+        </p:spPr>
+        <p:txBody>
+          <a:bodyPr anchor="ctr">
+            <a:normAutofit/>
+          </a:bodyPr>
+          <a:lstStyle/>
+          <a:p>
+            <a:pPr marL="0" indent="0">
+              <a:buNone/>
+            </a:pPr>
+            <a:r>
+              <a:rPr lang="ar-SA" sz="2000" b="1"/>
               <a:t>المنحنيات المفردة (Single Curves):</a:t>
             </a:r>
           </a:p>
@@ -7870,7 +8673,1251 @@
 </p:sld>
 </file>
 
-<file path=ppt/slides/slide24.xml><?xml version="1.0" encoding="utf-8"?>
+<file path=ppt/slides/slide27.xml><?xml version="1.0" encoding="utf-8"?>
+<p:sld xmlns:a="http://schemas.openxmlformats.org/drawingml/2006/main" xmlns:p="http://schemas.openxmlformats.org/presentationml/2006/main" xmlns:r="http://schemas.openxmlformats.org/officeDocument/2006/relationships">
+  <p:cSld>
+    <p:spTree>
+      <p:nvGrpSpPr>
+        <p:cNvPr id="1" name=""/>
+        <p:cNvGrpSpPr/>
+        <p:nvPr/>
+      </p:nvGrpSpPr>
+      <p:grpSpPr/>
+      <p:sp>
+        <p:nvSpPr>
+          <p:cNvPr id="3" name="Content Placeholder 2"/>
+          <p:cNvSpPr>
+            <a:spLocks noGrp="1"/>
+          </p:cNvSpPr>
+          <p:nvPr>
+            <p:ph idx="1"/>
+          </p:nvPr>
+        </p:nvSpPr>
+        <p:spPr>
+          <a:xfrm>
+            <a:off x="5669280" y="1600200"/>
+            <a:ext cx="5852160" cy="4389120"/>
+          </a:xfrm>
+        </p:spPr>
+        <p:txBody>
+          <a:bodyPr anchor="ctr">
+            <a:normAutofit/>
+          </a:bodyPr>
+          <a:lstStyle/>
+          <a:p>
+            <a:pPr marL="0" indent="0">
+              <a:buNone/>
+            </a:pPr>
+            <a:r>
+              <a:rPr lang="ar-SA" sz="2000" b="1"/>
+              <a:t>عبوات من السوق: من المكعّب إلى الشكل المميز</a:t>
+            </a:r>
+          </a:p>
+          <a:p>
+            <a:pPr marL="0" indent="0">
+              <a:buNone/>
+            </a:pPr>
+            <a:r>
+              <a:rPr lang="ar-SA" sz="2000" b="1"/>
+              <a:t>توبليرون (Toblerone): </a:t>
+            </a:r>
+            <a:r>
+              <a:rPr lang="ar-SA" sz="2000"/>
+              <a:t>علبة على هيئة منشور ثلاثي بدل الصندوق المستطيل، وقد أصبح شكلها جزءًا من هوية العلامة يُعرف حتى دون قراءة الاسم؛ وهي تطبيق متطرف لفكرة كشط الحواف.</a:t>
+            </a:r>
+          </a:p>
+          <a:p>
+            <a:pPr marL="0" indent="0">
+              <a:buNone/>
+            </a:pPr>
+            <a:r>
+              <a:rPr lang="ar-SA" sz="2000" b="1"/>
+              <a:t>تترا باك الهرمية (Tetra Classic): </a:t>
+            </a:r>
+            <a:r>
+              <a:rPr lang="ar-SA" sz="2000"/>
+              <a:t>عبوة حليب رباعية الأوجه ظهرت في خمسينيات القرن العشرين، تُشكَّل من أنبوب ورقي يُغلق طرفاه في اتجاهين متعامدين، فتستهلك مادة أقل من الصندوق.</a:t>
+            </a:r>
+          </a:p>
+          <a:p>
+            <a:pPr marL="0" indent="0">
+              <a:buNone/>
+            </a:pPr>
+            <a:r>
+              <a:rPr lang="ar-SA" sz="2000" b="1"/>
+              <a:t>الدرس المستفاد: </a:t>
+            </a:r>
+            <a:r>
+              <a:rPr lang="ar-SA" sz="2000"/>
+              <a:t>تشويه الشكل الأساسي قد يحقق التميّز البصري والكفاءة في المادة معًا.</a:t>
+            </a:r>
+          </a:p>
+        </p:txBody>
+      </p:sp>
+      <p:sp>
+        <p:nvSpPr>
+          <p:cNvPr id="15" name="Footer Placeholder 3">
+            <a:extLst>
+              <a:ext uri="{FF2B5EF4-FFF2-40B4-BE49-F238E27FC236}">
+                <a16:creationId xmlns:a16="http://schemas.microsoft.com/office/drawing/2014/main" id="{CFE48E32-A7F6-E621-F2A2-8E8D30A65EAF}"/>
+              </a:ext>
+            </a:extLst>
+          </p:cNvPr>
+          <p:cNvSpPr>
+            <a:spLocks noGrp="1"/>
+          </p:cNvSpPr>
+          <p:nvPr>
+            <p:ph type="ftr" sz="quarter" idx="11"/>
+          </p:nvPr>
+        </p:nvSpPr>
+        <p:spPr>
+          <a:xfrm>
+            <a:off x="4038600" y="6356350"/>
+            <a:ext cx="4114800" cy="365125"/>
+          </a:xfrm>
+        </p:spPr>
+        <p:txBody>
+          <a:bodyPr/>
+          <a:lstStyle/>
+          <a:p>
+            <a:r>
+              <a:rPr lang="ar-SA" dirty="0"/>
+              <a:t>برنامج التصميم الجرافيكي - المستوى السادس</a:t>
+            </a:r>
+            <a:endParaRPr lang="en-US" dirty="0"/>
+          </a:p>
+        </p:txBody>
+      </p:sp>
+      <p:sp>
+        <p:nvSpPr>
+          <p:cNvPr id="16" name="Photo slot"/>
+          <p:cNvSpPr/>
+          <p:nvPr/>
+        </p:nvSpPr>
+        <p:spPr>
+          <a:xfrm>
+            <a:off x="457200" y="1600200"/>
+            <a:ext cx="4937760" cy="2322576"/>
+          </a:xfrm>
+          <a:prstGeom prst="rect">
+            <a:avLst/>
+          </a:prstGeom>
+          <a:solidFill>
+            <a:srgbClr val="F2F2F2"/>
+          </a:solidFill>
+          <a:ln w="12700">
+            <a:solidFill>
+              <a:srgbClr val="A6A6A6"/>
+            </a:solidFill>
+            <a:prstDash val="dash"/>
+          </a:ln>
+          <a:effectLst/>
+        </p:spPr>
+        <p:style>
+          <a:lnRef idx="1">
+            <a:schemeClr val="accent1"/>
+          </a:lnRef>
+          <a:fillRef idx="3">
+            <a:schemeClr val="accent1"/>
+          </a:fillRef>
+          <a:effectRef idx="2">
+            <a:schemeClr val="accent1"/>
+          </a:effectRef>
+          <a:fontRef idx="minor">
+            <a:schemeClr val="lt1"/>
+          </a:fontRef>
+        </p:style>
+        <p:txBody>
+          <a:bodyPr rtlCol="0" anchor="ctr"/>
+          <a:lstStyle/>
+          <a:p>
+            <a:pPr algn="ctr"/>
+          </a:p>
+        </p:txBody>
+      </p:sp>
+      <p:sp>
+        <p:nvSpPr>
+          <p:cNvPr id="17" name="TextBox 16"/>
+          <p:cNvSpPr txBox="1"/>
+          <p:nvPr/>
+        </p:nvSpPr>
+        <p:spPr>
+          <a:xfrm>
+            <a:off x="594360" y="1600200"/>
+            <a:ext cx="4663440" cy="2322576"/>
+          </a:xfrm>
+          <a:prstGeom prst="rect">
+            <a:avLst/>
+          </a:prstGeom>
+          <a:noFill/>
+        </p:spPr>
+        <p:txBody>
+          <a:bodyPr wrap="square" anchor="ctr">
+            <a:spAutoFit/>
+          </a:bodyPr>
+          <a:lstStyle/>
+          <a:p>
+            <a:pPr algn="ctr" rtl="1"/>
+            <a:r>
+              <a:rPr sz="1600" b="0" lang="ar-SA">
+                <a:solidFill>
+                  <a:srgbClr val="595959"/>
+                </a:solidFill>
+                <a:latin typeface="Sakkal Majalla"/>
+                <a:cs typeface="Sakkal Majalla"/>
+              </a:rPr>
+              <a:t>أدرج صورة: علبة شوكولاتة توبليرون</a:t>
+            </a:r>
+          </a:p>
+        </p:txBody>
+      </p:sp>
+      <p:sp>
+        <p:nvSpPr>
+          <p:cNvPr id="18" name="Photo slot"/>
+          <p:cNvSpPr/>
+          <p:nvPr/>
+        </p:nvSpPr>
+        <p:spPr>
+          <a:xfrm>
+            <a:off x="457200" y="4105656"/>
+            <a:ext cx="2377440" cy="1883664"/>
+          </a:xfrm>
+          <a:prstGeom prst="rect">
+            <a:avLst/>
+          </a:prstGeom>
+          <a:solidFill>
+            <a:srgbClr val="F2F2F2"/>
+          </a:solidFill>
+          <a:ln w="12700">
+            <a:solidFill>
+              <a:srgbClr val="A6A6A6"/>
+            </a:solidFill>
+            <a:prstDash val="dash"/>
+          </a:ln>
+          <a:effectLst/>
+        </p:spPr>
+        <p:style>
+          <a:lnRef idx="1">
+            <a:schemeClr val="accent1"/>
+          </a:lnRef>
+          <a:fillRef idx="3">
+            <a:schemeClr val="accent1"/>
+          </a:fillRef>
+          <a:effectRef idx="2">
+            <a:schemeClr val="accent1"/>
+          </a:effectRef>
+          <a:fontRef idx="minor">
+            <a:schemeClr val="lt1"/>
+          </a:fontRef>
+        </p:style>
+        <p:txBody>
+          <a:bodyPr rtlCol="0" anchor="ctr"/>
+          <a:lstStyle/>
+          <a:p>
+            <a:pPr algn="ctr"/>
+          </a:p>
+        </p:txBody>
+      </p:sp>
+      <p:sp>
+        <p:nvSpPr>
+          <p:cNvPr id="19" name="TextBox 18"/>
+          <p:cNvSpPr txBox="1"/>
+          <p:nvPr/>
+        </p:nvSpPr>
+        <p:spPr>
+          <a:xfrm>
+            <a:off x="594360" y="4105656"/>
+            <a:ext cx="2103120" cy="1883664"/>
+          </a:xfrm>
+          <a:prstGeom prst="rect">
+            <a:avLst/>
+          </a:prstGeom>
+          <a:noFill/>
+        </p:spPr>
+        <p:txBody>
+          <a:bodyPr wrap="square" anchor="ctr">
+            <a:spAutoFit/>
+          </a:bodyPr>
+          <a:lstStyle/>
+          <a:p>
+            <a:pPr algn="ctr" rtl="1"/>
+            <a:r>
+              <a:rPr sz="1600" b="0" lang="ar-SA">
+                <a:solidFill>
+                  <a:srgbClr val="595959"/>
+                </a:solidFill>
+                <a:latin typeface="Sakkal Majalla"/>
+                <a:cs typeface="Sakkal Majalla"/>
+              </a:rPr>
+              <a:t>أدرج صورة: عبوة تترا باك هرمية</a:t>
+            </a:r>
+          </a:p>
+        </p:txBody>
+      </p:sp>
+      <p:sp>
+        <p:nvSpPr>
+          <p:cNvPr id="20" name="Photo slot"/>
+          <p:cNvSpPr/>
+          <p:nvPr/>
+        </p:nvSpPr>
+        <p:spPr>
+          <a:xfrm>
+            <a:off x="3017520" y="4105656"/>
+            <a:ext cx="2377440" cy="1883664"/>
+          </a:xfrm>
+          <a:prstGeom prst="rect">
+            <a:avLst/>
+          </a:prstGeom>
+          <a:solidFill>
+            <a:srgbClr val="F2F2F2"/>
+          </a:solidFill>
+          <a:ln w="12700">
+            <a:solidFill>
+              <a:srgbClr val="A6A6A6"/>
+            </a:solidFill>
+            <a:prstDash val="dash"/>
+          </a:ln>
+          <a:effectLst/>
+        </p:spPr>
+        <p:style>
+          <a:lnRef idx="1">
+            <a:schemeClr val="accent1"/>
+          </a:lnRef>
+          <a:fillRef idx="3">
+            <a:schemeClr val="accent1"/>
+          </a:fillRef>
+          <a:effectRef idx="2">
+            <a:schemeClr val="accent1"/>
+          </a:effectRef>
+          <a:fontRef idx="minor">
+            <a:schemeClr val="lt1"/>
+          </a:fontRef>
+        </p:style>
+        <p:txBody>
+          <a:bodyPr rtlCol="0" anchor="ctr"/>
+          <a:lstStyle/>
+          <a:p>
+            <a:pPr algn="ctr"/>
+          </a:p>
+        </p:txBody>
+      </p:sp>
+      <p:sp>
+        <p:nvSpPr>
+          <p:cNvPr id="21" name="TextBox 20"/>
+          <p:cNvSpPr txBox="1"/>
+          <p:nvPr/>
+        </p:nvSpPr>
+        <p:spPr>
+          <a:xfrm>
+            <a:off x="3154680" y="4105656"/>
+            <a:ext cx="2103120" cy="1883664"/>
+          </a:xfrm>
+          <a:prstGeom prst="rect">
+            <a:avLst/>
+          </a:prstGeom>
+          <a:noFill/>
+        </p:spPr>
+        <p:txBody>
+          <a:bodyPr wrap="square" anchor="ctr">
+            <a:spAutoFit/>
+          </a:bodyPr>
+          <a:lstStyle/>
+          <a:p>
+            <a:pPr algn="ctr" rtl="1"/>
+            <a:r>
+              <a:rPr sz="1600" b="0" lang="ar-SA">
+                <a:solidFill>
+                  <a:srgbClr val="595959"/>
+                </a:solidFill>
+                <a:latin typeface="Sakkal Majalla"/>
+                <a:cs typeface="Sakkal Majalla"/>
+              </a:rPr>
+              <a:t>أدرج صورة: مِفرَد أو مقطع للعبوة</a:t>
+            </a:r>
+          </a:p>
+        </p:txBody>
+      </p:sp>
+    </p:spTree>
+  </p:cSld>
+  <p:clrMapOvr>
+    <a:masterClrMapping/>
+  </p:clrMapOvr>
+</p:sld>
+</file>
+
+<file path=ppt/slides/slide28.xml><?xml version="1.0" encoding="utf-8"?>
+<p:sld xmlns:a="http://schemas.openxmlformats.org/drawingml/2006/main" xmlns:p="http://schemas.openxmlformats.org/presentationml/2006/main" xmlns:r="http://schemas.openxmlformats.org/officeDocument/2006/relationships">
+  <p:cSld>
+    <p:spTree>
+      <p:nvGrpSpPr>
+        <p:cNvPr id="1" name=""/>
+        <p:cNvGrpSpPr/>
+        <p:nvPr/>
+      </p:nvGrpSpPr>
+      <p:grpSpPr/>
+      <p:sp>
+        <p:nvSpPr>
+          <p:cNvPr id="3" name="Content Placeholder 2"/>
+          <p:cNvSpPr>
+            <a:spLocks noGrp="1"/>
+          </p:cNvSpPr>
+          <p:nvPr>
+            <p:ph idx="1"/>
+          </p:nvPr>
+        </p:nvSpPr>
+        <p:spPr>
+          <a:xfrm>
+            <a:off x="5669280" y="1600200"/>
+            <a:ext cx="5852160" cy="4389120"/>
+          </a:xfrm>
+        </p:spPr>
+        <p:txBody>
+          <a:bodyPr anchor="ctr">
+            <a:normAutofit/>
+          </a:bodyPr>
+          <a:lstStyle/>
+          <a:p>
+            <a:pPr marL="0" indent="0">
+              <a:buNone/>
+            </a:pPr>
+            <a:r>
+              <a:rPr lang="ar-SA" sz="2000" b="1"/>
+              <a:t>عبوات من السوق: الأسطح المائلة والجدران المستدقة</a:t>
+            </a:r>
+          </a:p>
+          <a:p>
+            <a:pPr marL="0" indent="0">
+              <a:buNone/>
+            </a:pPr>
+            <a:r>
+              <a:rPr lang="ar-SA" sz="2000" b="1"/>
+              <a:t>علبة البطاطس المقلية في مطاعم الوجبات السريعة: </a:t>
+            </a:r>
+            <a:r>
+              <a:rPr lang="ar-SA" sz="2000"/>
+              <a:t>جدارها الأمامي أقصر من الخلفي وحافتها العلوية مائلة أو منحنية، فتُظهر المنتج وتسهّل تناوله؛ وهي تطبيق لفكرة كشط الوجه والتقويس.</a:t>
+            </a:r>
+          </a:p>
+          <a:p>
+            <a:pPr marL="0" indent="0">
+              <a:buNone/>
+            </a:pPr>
+            <a:r>
+              <a:rPr lang="ar-SA" sz="2000" b="1"/>
+              <a:t>علبة الطعام الصينية (Oyster Pail): </a:t>
+            </a:r>
+            <a:r>
+              <a:rPr lang="ar-SA" sz="2000"/>
+              <a:t>تُطوى من لوح واحد دون لصق، وجدرانها مائلة تتسع نحو الأعلى، وتُغلق بألسنة متداخلة؛ وهي قريبة من فكرة المطّ.</a:t>
+            </a:r>
+          </a:p>
+          <a:p>
+            <a:pPr marL="0" indent="0">
+              <a:buNone/>
+            </a:pPr>
+            <a:r>
+              <a:rPr lang="ar-SA" sz="2000" b="1"/>
+              <a:t>علب العرض المائلة لمستحضرات التجميل: </a:t>
+            </a:r>
+            <a:r>
+              <a:rPr lang="ar-SA" sz="2000"/>
+              <a:t>سطحها العلوي المنحدر يعمل واجهة عرض على الرف.</a:t>
+            </a:r>
+          </a:p>
+        </p:txBody>
+      </p:sp>
+      <p:sp>
+        <p:nvSpPr>
+          <p:cNvPr id="15" name="Footer Placeholder 3">
+            <a:extLst>
+              <a:ext uri="{FF2B5EF4-FFF2-40B4-BE49-F238E27FC236}">
+                <a16:creationId xmlns:a16="http://schemas.microsoft.com/office/drawing/2014/main" id="{CFE48E32-A7F6-E621-F2A2-8E8D30A65EAF}"/>
+              </a:ext>
+            </a:extLst>
+          </p:cNvPr>
+          <p:cNvSpPr>
+            <a:spLocks noGrp="1"/>
+          </p:cNvSpPr>
+          <p:nvPr>
+            <p:ph type="ftr" sz="quarter" idx="11"/>
+          </p:nvPr>
+        </p:nvSpPr>
+        <p:spPr>
+          <a:xfrm>
+            <a:off x="4038600" y="6356350"/>
+            <a:ext cx="4114800" cy="365125"/>
+          </a:xfrm>
+        </p:spPr>
+        <p:txBody>
+          <a:bodyPr/>
+          <a:lstStyle/>
+          <a:p>
+            <a:r>
+              <a:rPr lang="ar-SA" dirty="0"/>
+              <a:t>برنامج التصميم الجرافيكي - المستوى السادس</a:t>
+            </a:r>
+            <a:endParaRPr lang="en-US" dirty="0"/>
+          </a:p>
+        </p:txBody>
+      </p:sp>
+      <p:sp>
+        <p:nvSpPr>
+          <p:cNvPr id="16" name="Photo slot"/>
+          <p:cNvSpPr/>
+          <p:nvPr/>
+        </p:nvSpPr>
+        <p:spPr>
+          <a:xfrm>
+            <a:off x="457200" y="1600200"/>
+            <a:ext cx="4937760" cy="2322576"/>
+          </a:xfrm>
+          <a:prstGeom prst="rect">
+            <a:avLst/>
+          </a:prstGeom>
+          <a:solidFill>
+            <a:srgbClr val="F2F2F2"/>
+          </a:solidFill>
+          <a:ln w="12700">
+            <a:solidFill>
+              <a:srgbClr val="A6A6A6"/>
+            </a:solidFill>
+            <a:prstDash val="dash"/>
+          </a:ln>
+          <a:effectLst/>
+        </p:spPr>
+        <p:style>
+          <a:lnRef idx="1">
+            <a:schemeClr val="accent1"/>
+          </a:lnRef>
+          <a:fillRef idx="3">
+            <a:schemeClr val="accent1"/>
+          </a:fillRef>
+          <a:effectRef idx="2">
+            <a:schemeClr val="accent1"/>
+          </a:effectRef>
+          <a:fontRef idx="minor">
+            <a:schemeClr val="lt1"/>
+          </a:fontRef>
+        </p:style>
+        <p:txBody>
+          <a:bodyPr rtlCol="0" anchor="ctr"/>
+          <a:lstStyle/>
+          <a:p>
+            <a:pPr algn="ctr"/>
+          </a:p>
+        </p:txBody>
+      </p:sp>
+      <p:sp>
+        <p:nvSpPr>
+          <p:cNvPr id="17" name="TextBox 16"/>
+          <p:cNvSpPr txBox="1"/>
+          <p:nvPr/>
+        </p:nvSpPr>
+        <p:spPr>
+          <a:xfrm>
+            <a:off x="594360" y="1600200"/>
+            <a:ext cx="4663440" cy="2322576"/>
+          </a:xfrm>
+          <a:prstGeom prst="rect">
+            <a:avLst/>
+          </a:prstGeom>
+          <a:noFill/>
+        </p:spPr>
+        <p:txBody>
+          <a:bodyPr wrap="square" anchor="ctr">
+            <a:spAutoFit/>
+          </a:bodyPr>
+          <a:lstStyle/>
+          <a:p>
+            <a:pPr algn="ctr" rtl="1"/>
+            <a:r>
+              <a:rPr sz="1600" b="0" lang="ar-SA">
+                <a:solidFill>
+                  <a:srgbClr val="595959"/>
+                </a:solidFill>
+                <a:latin typeface="Sakkal Majalla"/>
+                <a:cs typeface="Sakkal Majalla"/>
+              </a:rPr>
+              <a:t>أدرج صورة: علبة بطاطس مقلية</a:t>
+            </a:r>
+          </a:p>
+        </p:txBody>
+      </p:sp>
+      <p:sp>
+        <p:nvSpPr>
+          <p:cNvPr id="18" name="Photo slot"/>
+          <p:cNvSpPr/>
+          <p:nvPr/>
+        </p:nvSpPr>
+        <p:spPr>
+          <a:xfrm>
+            <a:off x="457200" y="4105656"/>
+            <a:ext cx="2377440" cy="1883664"/>
+          </a:xfrm>
+          <a:prstGeom prst="rect">
+            <a:avLst/>
+          </a:prstGeom>
+          <a:solidFill>
+            <a:srgbClr val="F2F2F2"/>
+          </a:solidFill>
+          <a:ln w="12700">
+            <a:solidFill>
+              <a:srgbClr val="A6A6A6"/>
+            </a:solidFill>
+            <a:prstDash val="dash"/>
+          </a:ln>
+          <a:effectLst/>
+        </p:spPr>
+        <p:style>
+          <a:lnRef idx="1">
+            <a:schemeClr val="accent1"/>
+          </a:lnRef>
+          <a:fillRef idx="3">
+            <a:schemeClr val="accent1"/>
+          </a:fillRef>
+          <a:effectRef idx="2">
+            <a:schemeClr val="accent1"/>
+          </a:effectRef>
+          <a:fontRef idx="minor">
+            <a:schemeClr val="lt1"/>
+          </a:fontRef>
+        </p:style>
+        <p:txBody>
+          <a:bodyPr rtlCol="0" anchor="ctr"/>
+          <a:lstStyle/>
+          <a:p>
+            <a:pPr algn="ctr"/>
+          </a:p>
+        </p:txBody>
+      </p:sp>
+      <p:sp>
+        <p:nvSpPr>
+          <p:cNvPr id="19" name="TextBox 18"/>
+          <p:cNvSpPr txBox="1"/>
+          <p:nvPr/>
+        </p:nvSpPr>
+        <p:spPr>
+          <a:xfrm>
+            <a:off x="594360" y="4105656"/>
+            <a:ext cx="2103120" cy="1883664"/>
+          </a:xfrm>
+          <a:prstGeom prst="rect">
+            <a:avLst/>
+          </a:prstGeom>
+          <a:noFill/>
+        </p:spPr>
+        <p:txBody>
+          <a:bodyPr wrap="square" anchor="ctr">
+            <a:spAutoFit/>
+          </a:bodyPr>
+          <a:lstStyle/>
+          <a:p>
+            <a:pPr algn="ctr" rtl="1"/>
+            <a:r>
+              <a:rPr sz="1600" b="0" lang="ar-SA">
+                <a:solidFill>
+                  <a:srgbClr val="595959"/>
+                </a:solidFill>
+                <a:latin typeface="Sakkal Majalla"/>
+                <a:cs typeface="Sakkal Majalla"/>
+              </a:rPr>
+              <a:t>أدرج صورة: علبة طعام صينية</a:t>
+            </a:r>
+          </a:p>
+        </p:txBody>
+      </p:sp>
+      <p:sp>
+        <p:nvSpPr>
+          <p:cNvPr id="20" name="Photo slot"/>
+          <p:cNvSpPr/>
+          <p:nvPr/>
+        </p:nvSpPr>
+        <p:spPr>
+          <a:xfrm>
+            <a:off x="3017520" y="4105656"/>
+            <a:ext cx="2377440" cy="1883664"/>
+          </a:xfrm>
+          <a:prstGeom prst="rect">
+            <a:avLst/>
+          </a:prstGeom>
+          <a:solidFill>
+            <a:srgbClr val="F2F2F2"/>
+          </a:solidFill>
+          <a:ln w="12700">
+            <a:solidFill>
+              <a:srgbClr val="A6A6A6"/>
+            </a:solidFill>
+            <a:prstDash val="dash"/>
+          </a:ln>
+          <a:effectLst/>
+        </p:spPr>
+        <p:style>
+          <a:lnRef idx="1">
+            <a:schemeClr val="accent1"/>
+          </a:lnRef>
+          <a:fillRef idx="3">
+            <a:schemeClr val="accent1"/>
+          </a:fillRef>
+          <a:effectRef idx="2">
+            <a:schemeClr val="accent1"/>
+          </a:effectRef>
+          <a:fontRef idx="minor">
+            <a:schemeClr val="lt1"/>
+          </a:fontRef>
+        </p:style>
+        <p:txBody>
+          <a:bodyPr rtlCol="0" anchor="ctr"/>
+          <a:lstStyle/>
+          <a:p>
+            <a:pPr algn="ctr"/>
+          </a:p>
+        </p:txBody>
+      </p:sp>
+      <p:sp>
+        <p:nvSpPr>
+          <p:cNvPr id="21" name="TextBox 20"/>
+          <p:cNvSpPr txBox="1"/>
+          <p:nvPr/>
+        </p:nvSpPr>
+        <p:spPr>
+          <a:xfrm>
+            <a:off x="3154680" y="4105656"/>
+            <a:ext cx="2103120" cy="1883664"/>
+          </a:xfrm>
+          <a:prstGeom prst="rect">
+            <a:avLst/>
+          </a:prstGeom>
+          <a:noFill/>
+        </p:spPr>
+        <p:txBody>
+          <a:bodyPr wrap="square" anchor="ctr">
+            <a:spAutoFit/>
+          </a:bodyPr>
+          <a:lstStyle/>
+          <a:p>
+            <a:pPr algn="ctr" rtl="1"/>
+            <a:r>
+              <a:rPr sz="1600" b="0" lang="ar-SA">
+                <a:solidFill>
+                  <a:srgbClr val="595959"/>
+                </a:solidFill>
+                <a:latin typeface="Sakkal Majalla"/>
+                <a:cs typeface="Sakkal Majalla"/>
+              </a:rPr>
+              <a:t>أدرج صورة: علبة عرض بسطح مائل</a:t>
+            </a:r>
+          </a:p>
+        </p:txBody>
+      </p:sp>
+    </p:spTree>
+  </p:cSld>
+  <p:clrMapOvr>
+    <a:masterClrMapping/>
+  </p:clrMapOvr>
+</p:sld>
+</file>
+
+<file path=ppt/slides/slide29.xml><?xml version="1.0" encoding="utf-8"?>
+<p:sld xmlns:a="http://schemas.openxmlformats.org/drawingml/2006/main" xmlns:p="http://schemas.openxmlformats.org/presentationml/2006/main" xmlns:r="http://schemas.openxmlformats.org/officeDocument/2006/relationships">
+  <p:cSld>
+    <p:spTree>
+      <p:nvGrpSpPr>
+        <p:cNvPr id="1" name=""/>
+        <p:cNvGrpSpPr/>
+        <p:nvPr/>
+      </p:nvGrpSpPr>
+      <p:grpSpPr/>
+      <p:sp>
+        <p:nvSpPr>
+          <p:cNvPr id="3" name="Content Placeholder 2"/>
+          <p:cNvSpPr>
+            <a:spLocks noGrp="1"/>
+          </p:cNvSpPr>
+          <p:nvPr>
+            <p:ph idx="1"/>
+          </p:nvPr>
+        </p:nvSpPr>
+        <p:spPr>
+          <a:xfrm>
+            <a:off x="5669280" y="1600200"/>
+            <a:ext cx="5852160" cy="4389120"/>
+          </a:xfrm>
+        </p:spPr>
+        <p:txBody>
+          <a:bodyPr anchor="ctr">
+            <a:normAutofit/>
+          </a:bodyPr>
+          <a:lstStyle/>
+          <a:p>
+            <a:pPr marL="0" indent="0">
+              <a:buNone/>
+            </a:pPr>
+            <a:r>
+              <a:rPr lang="ar-SA" sz="2000" b="1"/>
+              <a:t>عبوات من السوق: المنحنيات والأشكال البلورية</a:t>
+            </a:r>
+          </a:p>
+          <a:p>
+            <a:pPr marL="0" indent="0">
+              <a:buNone/>
+            </a:pPr>
+            <a:r>
+              <a:rPr lang="ar-SA" sz="2000" b="1"/>
+              <a:t>علبة الوسادة (Pillow Box): </a:t>
+            </a:r>
+            <a:r>
+              <a:rPr lang="ar-SA" sz="2000"/>
+              <a:t>تُصنع من لوح واحد بطيّات منحنية على طرفيها، وتُغلق بالضغط على الأقواس دون لصق؛ وهي مثال مباشر على المنحنيات المفردة، وتُستخدم للهدايا والمجوهرات والإكسسوارات.</a:t>
+            </a:r>
+          </a:p>
+          <a:p>
+            <a:pPr marL="0" indent="0">
+              <a:buNone/>
+            </a:pPr>
+            <a:r>
+              <a:rPr lang="ar-SA" sz="2000" b="1"/>
+              <a:t>علب الهدايا والشوكولاتة المُضلَّعة: </a:t>
+            </a:r>
+            <a:r>
+              <a:rPr lang="ar-SA" sz="2000"/>
+              <a:t>أشكال سداسية أو بلورية بأوجه مثلثة تحاكي الأحجار الكريمة، قريبة من تقنية الليّ المُضلَّع.</a:t>
+            </a:r>
+          </a:p>
+          <a:p>
+            <a:pPr marL="0" indent="0">
+              <a:buNone/>
+            </a:pPr>
+            <a:r>
+              <a:rPr lang="ar-SA" sz="2000" b="1"/>
+              <a:t>علب العطور ذات الحواف المشطوفة: </a:t>
+            </a:r>
+            <a:r>
+              <a:rPr lang="ar-SA" sz="2000"/>
+              <a:t>تطبيق لكشط الحافة يمنح العلبة طابعًا ناعمًا وفاخرًا.</a:t>
+            </a:r>
+          </a:p>
+        </p:txBody>
+      </p:sp>
+      <p:sp>
+        <p:nvSpPr>
+          <p:cNvPr id="15" name="Footer Placeholder 3">
+            <a:extLst>
+              <a:ext uri="{FF2B5EF4-FFF2-40B4-BE49-F238E27FC236}">
+                <a16:creationId xmlns:a16="http://schemas.microsoft.com/office/drawing/2014/main" id="{CFE48E32-A7F6-E621-F2A2-8E8D30A65EAF}"/>
+              </a:ext>
+            </a:extLst>
+          </p:cNvPr>
+          <p:cNvSpPr>
+            <a:spLocks noGrp="1"/>
+          </p:cNvSpPr>
+          <p:nvPr>
+            <p:ph type="ftr" sz="quarter" idx="11"/>
+          </p:nvPr>
+        </p:nvSpPr>
+        <p:spPr>
+          <a:xfrm>
+            <a:off x="4038600" y="6356350"/>
+            <a:ext cx="4114800" cy="365125"/>
+          </a:xfrm>
+        </p:spPr>
+        <p:txBody>
+          <a:bodyPr/>
+          <a:lstStyle/>
+          <a:p>
+            <a:r>
+              <a:rPr lang="ar-SA" dirty="0"/>
+              <a:t>برنامج التصميم الجرافيكي - المستوى السادس</a:t>
+            </a:r>
+            <a:endParaRPr lang="en-US" dirty="0"/>
+          </a:p>
+        </p:txBody>
+      </p:sp>
+      <p:sp>
+        <p:nvSpPr>
+          <p:cNvPr id="16" name="Photo slot"/>
+          <p:cNvSpPr/>
+          <p:nvPr/>
+        </p:nvSpPr>
+        <p:spPr>
+          <a:xfrm>
+            <a:off x="457200" y="1600200"/>
+            <a:ext cx="4937760" cy="2322576"/>
+          </a:xfrm>
+          <a:prstGeom prst="rect">
+            <a:avLst/>
+          </a:prstGeom>
+          <a:solidFill>
+            <a:srgbClr val="F2F2F2"/>
+          </a:solidFill>
+          <a:ln w="12700">
+            <a:solidFill>
+              <a:srgbClr val="A6A6A6"/>
+            </a:solidFill>
+            <a:prstDash val="dash"/>
+          </a:ln>
+          <a:effectLst/>
+        </p:spPr>
+        <p:style>
+          <a:lnRef idx="1">
+            <a:schemeClr val="accent1"/>
+          </a:lnRef>
+          <a:fillRef idx="3">
+            <a:schemeClr val="accent1"/>
+          </a:fillRef>
+          <a:effectRef idx="2">
+            <a:schemeClr val="accent1"/>
+          </a:effectRef>
+          <a:fontRef idx="minor">
+            <a:schemeClr val="lt1"/>
+          </a:fontRef>
+        </p:style>
+        <p:txBody>
+          <a:bodyPr rtlCol="0" anchor="ctr"/>
+          <a:lstStyle/>
+          <a:p>
+            <a:pPr algn="ctr"/>
+          </a:p>
+        </p:txBody>
+      </p:sp>
+      <p:sp>
+        <p:nvSpPr>
+          <p:cNvPr id="17" name="TextBox 16"/>
+          <p:cNvSpPr txBox="1"/>
+          <p:nvPr/>
+        </p:nvSpPr>
+        <p:spPr>
+          <a:xfrm>
+            <a:off x="594360" y="1600200"/>
+            <a:ext cx="4663440" cy="2322576"/>
+          </a:xfrm>
+          <a:prstGeom prst="rect">
+            <a:avLst/>
+          </a:prstGeom>
+          <a:noFill/>
+        </p:spPr>
+        <p:txBody>
+          <a:bodyPr wrap="square" anchor="ctr">
+            <a:spAutoFit/>
+          </a:bodyPr>
+          <a:lstStyle/>
+          <a:p>
+            <a:pPr algn="ctr" rtl="1"/>
+            <a:r>
+              <a:rPr sz="1600" b="0" lang="ar-SA">
+                <a:solidFill>
+                  <a:srgbClr val="595959"/>
+                </a:solidFill>
+                <a:latin typeface="Sakkal Majalla"/>
+                <a:cs typeface="Sakkal Majalla"/>
+              </a:rPr>
+              <a:t>أدرج صورة: علبة وسادة (Pillow Box)</a:t>
+            </a:r>
+          </a:p>
+        </p:txBody>
+      </p:sp>
+      <p:sp>
+        <p:nvSpPr>
+          <p:cNvPr id="18" name="Photo slot"/>
+          <p:cNvSpPr/>
+          <p:nvPr/>
+        </p:nvSpPr>
+        <p:spPr>
+          <a:xfrm>
+            <a:off x="457200" y="4105656"/>
+            <a:ext cx="2377440" cy="1883664"/>
+          </a:xfrm>
+          <a:prstGeom prst="rect">
+            <a:avLst/>
+          </a:prstGeom>
+          <a:solidFill>
+            <a:srgbClr val="F2F2F2"/>
+          </a:solidFill>
+          <a:ln w="12700">
+            <a:solidFill>
+              <a:srgbClr val="A6A6A6"/>
+            </a:solidFill>
+            <a:prstDash val="dash"/>
+          </a:ln>
+          <a:effectLst/>
+        </p:spPr>
+        <p:style>
+          <a:lnRef idx="1">
+            <a:schemeClr val="accent1"/>
+          </a:lnRef>
+          <a:fillRef idx="3">
+            <a:schemeClr val="accent1"/>
+          </a:fillRef>
+          <a:effectRef idx="2">
+            <a:schemeClr val="accent1"/>
+          </a:effectRef>
+          <a:fontRef idx="minor">
+            <a:schemeClr val="lt1"/>
+          </a:fontRef>
+        </p:style>
+        <p:txBody>
+          <a:bodyPr rtlCol="0" anchor="ctr"/>
+          <a:lstStyle/>
+          <a:p>
+            <a:pPr algn="ctr"/>
+          </a:p>
+        </p:txBody>
+      </p:sp>
+      <p:sp>
+        <p:nvSpPr>
+          <p:cNvPr id="19" name="TextBox 18"/>
+          <p:cNvSpPr txBox="1"/>
+          <p:nvPr/>
+        </p:nvSpPr>
+        <p:spPr>
+          <a:xfrm>
+            <a:off x="594360" y="4105656"/>
+            <a:ext cx="2103120" cy="1883664"/>
+          </a:xfrm>
+          <a:prstGeom prst="rect">
+            <a:avLst/>
+          </a:prstGeom>
+          <a:noFill/>
+        </p:spPr>
+        <p:txBody>
+          <a:bodyPr wrap="square" anchor="ctr">
+            <a:spAutoFit/>
+          </a:bodyPr>
+          <a:lstStyle/>
+          <a:p>
+            <a:pPr algn="ctr" rtl="1"/>
+            <a:r>
+              <a:rPr sz="1600" b="0" lang="ar-SA">
+                <a:solidFill>
+                  <a:srgbClr val="595959"/>
+                </a:solidFill>
+                <a:latin typeface="Sakkal Majalla"/>
+                <a:cs typeface="Sakkal Majalla"/>
+              </a:rPr>
+              <a:t>أدرج صورة: علبة هدايا مُضلَّعة</a:t>
+            </a:r>
+          </a:p>
+        </p:txBody>
+      </p:sp>
+      <p:sp>
+        <p:nvSpPr>
+          <p:cNvPr id="20" name="Photo slot"/>
+          <p:cNvSpPr/>
+          <p:nvPr/>
+        </p:nvSpPr>
+        <p:spPr>
+          <a:xfrm>
+            <a:off x="3017520" y="4105656"/>
+            <a:ext cx="2377440" cy="1883664"/>
+          </a:xfrm>
+          <a:prstGeom prst="rect">
+            <a:avLst/>
+          </a:prstGeom>
+          <a:solidFill>
+            <a:srgbClr val="F2F2F2"/>
+          </a:solidFill>
+          <a:ln w="12700">
+            <a:solidFill>
+              <a:srgbClr val="A6A6A6"/>
+            </a:solidFill>
+            <a:prstDash val="dash"/>
+          </a:ln>
+          <a:effectLst/>
+        </p:spPr>
+        <p:style>
+          <a:lnRef idx="1">
+            <a:schemeClr val="accent1"/>
+          </a:lnRef>
+          <a:fillRef idx="3">
+            <a:schemeClr val="accent1"/>
+          </a:fillRef>
+          <a:effectRef idx="2">
+            <a:schemeClr val="accent1"/>
+          </a:effectRef>
+          <a:fontRef idx="minor">
+            <a:schemeClr val="lt1"/>
+          </a:fontRef>
+        </p:style>
+        <p:txBody>
+          <a:bodyPr rtlCol="0" anchor="ctr"/>
+          <a:lstStyle/>
+          <a:p>
+            <a:pPr algn="ctr"/>
+          </a:p>
+        </p:txBody>
+      </p:sp>
+      <p:sp>
+        <p:nvSpPr>
+          <p:cNvPr id="21" name="TextBox 20"/>
+          <p:cNvSpPr txBox="1"/>
+          <p:nvPr/>
+        </p:nvSpPr>
+        <p:spPr>
+          <a:xfrm>
+            <a:off x="3154680" y="4105656"/>
+            <a:ext cx="2103120" cy="1883664"/>
+          </a:xfrm>
+          <a:prstGeom prst="rect">
+            <a:avLst/>
+          </a:prstGeom>
+          <a:noFill/>
+        </p:spPr>
+        <p:txBody>
+          <a:bodyPr wrap="square" anchor="ctr">
+            <a:spAutoFit/>
+          </a:bodyPr>
+          <a:lstStyle/>
+          <a:p>
+            <a:pPr algn="ctr" rtl="1"/>
+            <a:r>
+              <a:rPr sz="1600" b="0" lang="ar-SA">
+                <a:solidFill>
+                  <a:srgbClr val="595959"/>
+                </a:solidFill>
+                <a:latin typeface="Sakkal Majalla"/>
+                <a:cs typeface="Sakkal Majalla"/>
+              </a:rPr>
+              <a:t>أدرج صورة: علبة عطر بحواف مشطوفة</a:t>
+            </a:r>
+          </a:p>
+        </p:txBody>
+      </p:sp>
+    </p:spTree>
+  </p:cSld>
+  <p:clrMapOvr>
+    <a:masterClrMapping/>
+  </p:clrMapOvr>
+</p:sld>
+</file>
+
+<file path=ppt/slides/slide3.xml><?xml version="1.0" encoding="utf-8"?>
+<p:sld xmlns:a="http://schemas.openxmlformats.org/drawingml/2006/main" xmlns:p="http://schemas.openxmlformats.org/presentationml/2006/main" xmlns:r="http://schemas.openxmlformats.org/officeDocument/2006/relationships">
+  <p:cSld>
+    <p:spTree>
+      <p:nvGrpSpPr>
+        <p:cNvPr id="1" name=""/>
+        <p:cNvGrpSpPr/>
+        <p:nvPr/>
+      </p:nvGrpSpPr>
+      <p:grpSpPr/>
+      <p:sp>
+        <p:nvSpPr>
+          <p:cNvPr id="3" name="Content Placeholder 2"/>
+          <p:cNvSpPr>
+            <a:spLocks noGrp="1"/>
+          </p:cNvSpPr>
+          <p:nvPr>
+            <p:ph idx="1"/>
+          </p:nvPr>
+        </p:nvSpPr>
+        <p:spPr>
+          <a:xfrm>
+            <a:off x="1005840" y="1600200"/>
+            <a:ext cx="10149840" cy="4389120"/>
+          </a:xfrm>
+        </p:spPr>
+        <p:txBody>
+          <a:bodyPr anchor="ctr">
+            <a:normAutofit/>
+          </a:bodyPr>
+          <a:lstStyle/>
+          <a:p>
+            <a:pPr marL="0" indent="0">
+              <a:buNone/>
+            </a:pPr>
+            <a:r>
+              <a:rPr lang="ar-SA" sz="2000" b="1"/>
+              <a:t>أهداف المحاضرة:</a:t>
+            </a:r>
+          </a:p>
+          <a:p>
+            <a:pPr marL="0" indent="0">
+              <a:buNone/>
+            </a:pPr>
+            <a:r>
+              <a:rPr lang="ar-SA" sz="2000"/>
+              <a:t>يُتوقع من الطالب في نهاية المحاضرة أن يكون قادرًا على:</a:t>
+            </a:r>
+          </a:p>
+          <a:p>
+            <a:pPr/>
+            <a:r>
+              <a:rPr lang="ar-SA" sz="2000"/>
+              <a:t>استخدام أدوات القص والطي استخدامًا دقيقًا وآمنًا.</a:t>
+            </a:r>
+          </a:p>
+          <a:p>
+            <a:pPr/>
+            <a:r>
+              <a:rPr lang="ar-SA" sz="2000"/>
+              <a:t>تحليل المكعّب ومِفرَده بوصفه أساسًا للعبوة.</a:t>
+            </a:r>
+          </a:p>
+          <a:p>
+            <a:pPr/>
+            <a:r>
+              <a:rPr lang="ar-SA" sz="2000"/>
+              <a:t>تطبيق الاستراتيجيات الثلاث لتشويه المكعّب.</a:t>
+            </a:r>
+          </a:p>
+          <a:p>
+            <a:pPr/>
+            <a:r>
+              <a:rPr lang="ar-SA" sz="2000"/>
+              <a:t>رسم الطيات المنحنية وتنفيذها بدقة.</a:t>
+            </a:r>
+          </a:p>
+          <a:p>
+            <a:pPr/>
+            <a:r>
+              <a:rPr lang="ar-SA" sz="2000"/>
+              <a:t>المواءمة بين الجانبين الجمالي والوظيفي للعبوة.</a:t>
+            </a:r>
+          </a:p>
+        </p:txBody>
+      </p:sp>
+      <p:sp>
+        <p:nvSpPr>
+          <p:cNvPr id="15" name="Footer Placeholder 3">
+            <a:extLst>
+              <a:ext uri="{FF2B5EF4-FFF2-40B4-BE49-F238E27FC236}">
+                <a16:creationId xmlns:a16="http://schemas.microsoft.com/office/drawing/2014/main" id="{CFE48E32-A7F6-E621-F2A2-8E8D30A65EAF}"/>
+              </a:ext>
+            </a:extLst>
+          </p:cNvPr>
+          <p:cNvSpPr>
+            <a:spLocks noGrp="1"/>
+          </p:cNvSpPr>
+          <p:nvPr>
+            <p:ph type="ftr" sz="quarter" idx="11"/>
+          </p:nvPr>
+        </p:nvSpPr>
+        <p:spPr>
+          <a:xfrm>
+            <a:off x="4038600" y="6356350"/>
+            <a:ext cx="4114800" cy="365125"/>
+          </a:xfrm>
+        </p:spPr>
+        <p:txBody>
+          <a:bodyPr/>
+          <a:lstStyle/>
+          <a:p>
+            <a:r>
+              <a:rPr lang="ar-SA" dirty="0"/>
+              <a:t>برنامج التصميم الجرافيكي - المستوى السادس</a:t>
+            </a:r>
+            <a:endParaRPr lang="en-US" dirty="0"/>
+          </a:p>
+        </p:txBody>
+      </p:sp>
+    </p:spTree>
+  </p:cSld>
+  <p:clrMapOvr>
+    <a:masterClrMapping/>
+  </p:clrMapOvr>
+</p:sld>
+</file>
+
+<file path=ppt/slides/slide30.xml><?xml version="1.0" encoding="utf-8"?>
 <p:sld xmlns:a="http://schemas.openxmlformats.org/drawingml/2006/main" xmlns:p="http://schemas.openxmlformats.org/presentationml/2006/main" xmlns:r="http://schemas.openxmlformats.org/officeDocument/2006/relationships">
   <p:cSld>
     <p:spTree>
@@ -8092,7 +10139,7 @@
 </p:sld>
 </file>
 
-<file path=ppt/slides/slide25.xml><?xml version="1.0" encoding="utf-8"?>
+<file path=ppt/slides/slide31.xml><?xml version="1.0" encoding="utf-8"?>
 <p:sld xmlns:a="http://schemas.openxmlformats.org/drawingml/2006/main" xmlns:p="http://schemas.openxmlformats.org/presentationml/2006/main" xmlns:r="http://schemas.openxmlformats.org/officeDocument/2006/relationships">
   <p:cSld>
     <p:spTree>
@@ -8296,7 +10343,7 @@
 </p:sld>
 </file>
 
-<file path=ppt/slides/slide26.xml><?xml version="1.0" encoding="utf-8"?>
+<file path=ppt/slides/slide32.xml><?xml version="1.0" encoding="utf-8"?>
 <p:sld xmlns:a="http://schemas.openxmlformats.org/drawingml/2006/main" xmlns:p="http://schemas.openxmlformats.org/presentationml/2006/main" xmlns:r="http://schemas.openxmlformats.org/officeDocument/2006/relationships">
   <p:cSld>
     <p:spTree>
@@ -8458,7 +10505,7 @@
 </p:sld>
 </file>
 
-<file path=ppt/slides/slide27.xml><?xml version="1.0" encoding="utf-8"?>
+<file path=ppt/slides/slide33.xml><?xml version="1.0" encoding="utf-8"?>
 <p:sld xmlns:a="http://schemas.openxmlformats.org/drawingml/2006/main" xmlns:p="http://schemas.openxmlformats.org/presentationml/2006/main" xmlns:r="http://schemas.openxmlformats.org/officeDocument/2006/relationships">
   <p:cSld>
     <p:spTree>
@@ -8619,7 +10666,7 @@
 </p:sld>
 </file>
 
-<file path=ppt/slides/slide28.xml><?xml version="1.0" encoding="utf-8"?>
+<file path=ppt/slides/slide34.xml><?xml version="1.0" encoding="utf-8"?>
 <p:sld xmlns:a="http://schemas.openxmlformats.org/drawingml/2006/main" xmlns:p="http://schemas.openxmlformats.org/presentationml/2006/main" xmlns:r="http://schemas.openxmlformats.org/officeDocument/2006/relationships">
   <p:cSld>
     <p:spTree>
@@ -8666,134 +10713,6 @@
             <a:r>
               <a:rPr lang="ar-SA" sz="2000"/>
               <a:t>الفصل الرابع «Deforming a Cube» والقسم ١٫٢ «How to Cut and Fold» من الكتاب المرجعي للمقرر، والصور مأخوذة منه.</a:t>
-            </a:r>
-          </a:p>
-        </p:txBody>
-      </p:sp>
-      <p:sp>
-        <p:nvSpPr>
-          <p:cNvPr id="15" name="Footer Placeholder 3">
-            <a:extLst>
-              <a:ext uri="{FF2B5EF4-FFF2-40B4-BE49-F238E27FC236}">
-                <a16:creationId xmlns:a16="http://schemas.microsoft.com/office/drawing/2014/main" id="{CFE48E32-A7F6-E621-F2A2-8E8D30A65EAF}"/>
-              </a:ext>
-            </a:extLst>
-          </p:cNvPr>
-          <p:cNvSpPr>
-            <a:spLocks noGrp="1"/>
-          </p:cNvSpPr>
-          <p:nvPr>
-            <p:ph type="ftr" sz="quarter" idx="11"/>
-          </p:nvPr>
-        </p:nvSpPr>
-        <p:spPr>
-          <a:xfrm>
-            <a:off x="4038600" y="6356350"/>
-            <a:ext cx="4114800" cy="365125"/>
-          </a:xfrm>
-        </p:spPr>
-        <p:txBody>
-          <a:bodyPr/>
-          <a:lstStyle/>
-          <a:p>
-            <a:r>
-              <a:rPr lang="ar-SA" dirty="0"/>
-              <a:t>برنامج التصميم الجرافيكي - المستوى السادس</a:t>
-            </a:r>
-            <a:endParaRPr lang="en-US" dirty="0"/>
-          </a:p>
-        </p:txBody>
-      </p:sp>
-    </p:spTree>
-  </p:cSld>
-  <p:clrMapOvr>
-    <a:masterClrMapping/>
-  </p:clrMapOvr>
-</p:sld>
-</file>
-
-<file path=ppt/slides/slide3.xml><?xml version="1.0" encoding="utf-8"?>
-<p:sld xmlns:a="http://schemas.openxmlformats.org/drawingml/2006/main" xmlns:p="http://schemas.openxmlformats.org/presentationml/2006/main" xmlns:r="http://schemas.openxmlformats.org/officeDocument/2006/relationships">
-  <p:cSld>
-    <p:spTree>
-      <p:nvGrpSpPr>
-        <p:cNvPr id="1" name=""/>
-        <p:cNvGrpSpPr/>
-        <p:nvPr/>
-      </p:nvGrpSpPr>
-      <p:grpSpPr/>
-      <p:sp>
-        <p:nvSpPr>
-          <p:cNvPr id="3" name="Content Placeholder 2"/>
-          <p:cNvSpPr>
-            <a:spLocks noGrp="1"/>
-          </p:cNvSpPr>
-          <p:nvPr>
-            <p:ph idx="1"/>
-          </p:nvPr>
-        </p:nvSpPr>
-        <p:spPr>
-          <a:xfrm>
-            <a:off x="1005840" y="1600200"/>
-            <a:ext cx="10149840" cy="4389120"/>
-          </a:xfrm>
-        </p:spPr>
-        <p:txBody>
-          <a:bodyPr anchor="ctr">
-            <a:normAutofit/>
-          </a:bodyPr>
-          <a:lstStyle/>
-          <a:p>
-            <a:pPr marL="0" indent="0">
-              <a:buNone/>
-            </a:pPr>
-            <a:r>
-              <a:rPr lang="ar-SA" sz="2000" b="1"/>
-              <a:t>أهداف المحاضرة:</a:t>
-            </a:r>
-          </a:p>
-          <a:p>
-            <a:pPr marL="0" indent="0">
-              <a:buNone/>
-            </a:pPr>
-            <a:r>
-              <a:rPr lang="ar-SA" sz="2000"/>
-              <a:t>يُتوقع من الطالب في نهاية المحاضرة أن يكون قادرًا على:</a:t>
-            </a:r>
-          </a:p>
-          <a:p>
-            <a:pPr/>
-            <a:r>
-              <a:rPr lang="ar-SA" sz="2000"/>
-              <a:t>استخدام أدوات القص والطي استخدامًا دقيقًا وآمنًا.</a:t>
-            </a:r>
-          </a:p>
-          <a:p>
-            <a:pPr/>
-            <a:r>
-              <a:rPr lang="ar-SA" sz="2000"/>
-              <a:t>تحليل المكعّب ومِفرَده بوصفه أساسًا للعبوة.</a:t>
-            </a:r>
-          </a:p>
-          <a:p>
-            <a:pPr/>
-            <a:r>
-              <a:rPr lang="ar-SA" sz="2000"/>
-              <a:t>تطبيق الاستراتيجيات الثلاث لتشويه المكعّب.</a:t>
-            </a:r>
-          </a:p>
-          <a:p>
-            <a:pPr/>
-            <a:r>
-              <a:rPr lang="ar-SA" sz="2000"/>
-              <a:t>رسم الطيات المنحنية وتنفيذها بدقة.</a:t>
-            </a:r>
-          </a:p>
-          <a:p>
-            <a:pPr/>
-            <a:r>
-              <a:rPr lang="ar-SA" sz="2000"/>
-              <a:t>المواءمة بين الجانبين الجمالي والوظيفي للعبوة.</a:t>
             </a:r>
           </a:p>
         </p:txBody>
@@ -9355,7 +11274,7 @@
             </a:pPr>
             <a:r>
               <a:rPr lang="ar-SA" sz="2000" b="1"/>
-              <a:t>عناصر المكعّب الثلاثة:</a:t>
+              <a:t>اتجاه ألياف الورق (Grain Direction):</a:t>
             </a:r>
           </a:p>
           <a:p>
@@ -9364,40 +11283,55 @@
             </a:pPr>
             <a:r>
               <a:rPr lang="ar-SA" sz="2000"/>
-              <a:t>يتكوّن المكعّب، شأنه شأن معظم تصاميم التغليف الإنشائي، من ثلاثة عناصر، وكل تشويه للمكعّب تعديل على عنصر منها أو أكثر:</a:t>
+              <a:t>تُصنَّع الألواح الورقية بحيث تصطف أليافها في اتجاه واحد، ويؤثر هذا الاتجاه مباشرة في جودة الطي:</a:t>
             </a:r>
           </a:p>
           <a:p>
             <a:pPr/>
             <a:r>
               <a:rPr lang="ar-SA" sz="2000" b="1"/>
-              <a:t>الأوجه (Faces): </a:t>
-            </a:r>
-            <a:r>
-              <a:rPr lang="ar-SA" sz="2000"/>
-              <a:t>الأسطح المستوية، وتمثّل مساحات الطباعة والهوية البصرية.</a:t>
+              <a:t>الطي الموازي للألياف: </a:t>
+            </a:r>
+            <a:r>
+              <a:rPr lang="ar-SA" sz="2000"/>
+              <a:t>أسهل وأنظف، ويعطي حافة مستقيمة.</a:t>
             </a:r>
           </a:p>
           <a:p>
             <a:pPr/>
             <a:r>
               <a:rPr lang="ar-SA" sz="2000" b="1"/>
-              <a:t>الحواف (Edges): </a:t>
-            </a:r>
-            <a:r>
-              <a:rPr lang="ar-SA" sz="2000"/>
-              <a:t>خطوط التقاء وجهين، وتمثّل خطوط الطي.</a:t>
-            </a:r>
-          </a:p>
-          <a:p>
-            <a:pPr/>
-            <a:r>
-              <a:rPr lang="ar-SA" sz="2000" b="1"/>
-              <a:t>الأركان (Corners): </a:t>
-            </a:r>
-            <a:r>
-              <a:rPr lang="ar-SA" sz="2000"/>
-              <a:t>نقاط التقاء الحواف، وهي أكثر مواضع العبوة عرضة للتلف.</a:t>
+              <a:t>الطي العمودي على الألياف: </a:t>
+            </a:r>
+            <a:r>
+              <a:rPr lang="ar-SA" sz="2000"/>
+              <a:t>أصعب، وقد تتشقق الطبقة السطحية عند خط الطي، خاصة في الورق السميك.</a:t>
+            </a:r>
+          </a:p>
+          <a:p>
+            <a:pPr marL="0" indent="0">
+              <a:buNone/>
+            </a:pPr>
+            <a:r>
+              <a:rPr lang="ar-SA" sz="2000" b="1"/>
+              <a:t>طريقة التحقق: </a:t>
+            </a:r>
+            <a:r>
+              <a:rPr lang="ar-SA" sz="2000"/>
+              <a:t>تُثنى قطعة صغيرة في الاتجاهين، فالاتجاه الأسهل انثناءً هو اتجاه الألياف.</a:t>
+            </a:r>
+          </a:p>
+          <a:p>
+            <a:pPr marL="0" indent="0">
+              <a:buNone/>
+            </a:pPr>
+            <a:r>
+              <a:rPr lang="ar-SA" sz="2000" b="1"/>
+              <a:t>في التصميم: </a:t>
+            </a:r>
+            <a:r>
+              <a:rPr lang="ar-SA" sz="2000"/>
+              <a:t>تُوزَّع المِفرَدات على اللوح بحيث تكون أهم خطوط الطي وأطولها موازية للألياف قدر الإمكان.</a:t>
             </a:r>
           </a:p>
         </p:txBody>
@@ -9436,30 +11370,617 @@
           </a:p>
         </p:txBody>
       </p:sp>
-      <p:pic>
-        <p:nvPicPr>
-          <p:cNvPr id="16" name="Picture 15" descr="cover.png"/>
-          <p:cNvPicPr>
-            <a:picLocks noChangeAspect="1"/>
-          </p:cNvPicPr>
+      <p:sp>
+        <p:nvSpPr>
+          <p:cNvPr id="16" name="Rectangle 15"/>
+          <p:cNvSpPr/>
           <p:nvPr/>
-        </p:nvPicPr>
-        <p:blipFill>
-          <a:blip r:embed="rId2"/>
-          <a:stretch>
-            <a:fillRect/>
-          </a:stretch>
-        </p:blipFill>
-        <p:spPr>
-          <a:xfrm>
-            <a:off x="457200" y="2220096"/>
-            <a:ext cx="4937760" cy="3149327"/>
+        </p:nvSpPr>
+        <p:spPr>
+          <a:xfrm>
+            <a:off x="731520" y="1965960"/>
+            <a:ext cx="4389120" cy="2926080"/>
           </a:xfrm>
           <a:prstGeom prst="rect">
             <a:avLst/>
           </a:prstGeom>
-        </p:spPr>
-      </p:pic>
+          <a:solidFill>
+            <a:srgbClr val="FAFAFA"/>
+          </a:solidFill>
+          <a:ln w="15875">
+            <a:solidFill>
+              <a:srgbClr val="000000"/>
+            </a:solidFill>
+          </a:ln>
+          <a:effectLst/>
+        </p:spPr>
+        <p:style>
+          <a:lnRef idx="1">
+            <a:schemeClr val="accent1"/>
+          </a:lnRef>
+          <a:fillRef idx="3">
+            <a:schemeClr val="accent1"/>
+          </a:fillRef>
+          <a:effectRef idx="2">
+            <a:schemeClr val="accent1"/>
+          </a:effectRef>
+          <a:fontRef idx="minor">
+            <a:schemeClr val="lt1"/>
+          </a:fontRef>
+        </p:style>
+        <p:txBody>
+          <a:bodyPr rtlCol="0" anchor="ctr"/>
+          <a:lstStyle/>
+          <a:p>
+            <a:pPr algn="ctr"/>
+          </a:p>
+        </p:txBody>
+      </p:sp>
+      <p:cxnSp>
+        <p:nvCxnSpPr>
+          <p:cNvPr id="17" name="Connector 16"/>
+          <p:cNvCxnSpPr/>
+          <p:nvPr/>
+        </p:nvCxnSpPr>
+        <p:spPr>
+          <a:xfrm>
+            <a:off x="868680" y="2209800"/>
+            <a:ext cx="4114800" cy="0"/>
+          </a:xfrm>
+          <a:prstGeom prst="line">
+            <a:avLst/>
+          </a:prstGeom>
+          <a:ln w="9525">
+            <a:solidFill>
+              <a:srgbClr val="BFBFBF"/>
+            </a:solidFill>
+          </a:ln>
+        </p:spPr>
+        <p:style>
+          <a:lnRef idx="2">
+            <a:schemeClr val="accent1"/>
+          </a:lnRef>
+          <a:fillRef idx="0">
+            <a:schemeClr val="accent1"/>
+          </a:fillRef>
+          <a:effectRef idx="1">
+            <a:schemeClr val="accent1"/>
+          </a:effectRef>
+          <a:fontRef idx="minor">
+            <a:schemeClr val="tx1"/>
+          </a:fontRef>
+        </p:style>
+      </p:cxnSp>
+      <p:cxnSp>
+        <p:nvCxnSpPr>
+          <p:cNvPr id="18" name="Connector 17"/>
+          <p:cNvCxnSpPr/>
+          <p:nvPr/>
+        </p:nvCxnSpPr>
+        <p:spPr>
+          <a:xfrm>
+            <a:off x="868680" y="2453640"/>
+            <a:ext cx="4114800" cy="0"/>
+          </a:xfrm>
+          <a:prstGeom prst="line">
+            <a:avLst/>
+          </a:prstGeom>
+          <a:ln w="9525">
+            <a:solidFill>
+              <a:srgbClr val="BFBFBF"/>
+            </a:solidFill>
+          </a:ln>
+        </p:spPr>
+        <p:style>
+          <a:lnRef idx="2">
+            <a:schemeClr val="accent1"/>
+          </a:lnRef>
+          <a:fillRef idx="0">
+            <a:schemeClr val="accent1"/>
+          </a:fillRef>
+          <a:effectRef idx="1">
+            <a:schemeClr val="accent1"/>
+          </a:effectRef>
+          <a:fontRef idx="minor">
+            <a:schemeClr val="tx1"/>
+          </a:fontRef>
+        </p:style>
+      </p:cxnSp>
+      <p:cxnSp>
+        <p:nvCxnSpPr>
+          <p:cNvPr id="19" name="Connector 18"/>
+          <p:cNvCxnSpPr/>
+          <p:nvPr/>
+        </p:nvCxnSpPr>
+        <p:spPr>
+          <a:xfrm>
+            <a:off x="868680" y="2697480"/>
+            <a:ext cx="4114800" cy="0"/>
+          </a:xfrm>
+          <a:prstGeom prst="line">
+            <a:avLst/>
+          </a:prstGeom>
+          <a:ln w="9525">
+            <a:solidFill>
+              <a:srgbClr val="BFBFBF"/>
+            </a:solidFill>
+          </a:ln>
+        </p:spPr>
+        <p:style>
+          <a:lnRef idx="2">
+            <a:schemeClr val="accent1"/>
+          </a:lnRef>
+          <a:fillRef idx="0">
+            <a:schemeClr val="accent1"/>
+          </a:fillRef>
+          <a:effectRef idx="1">
+            <a:schemeClr val="accent1"/>
+          </a:effectRef>
+          <a:fontRef idx="minor">
+            <a:schemeClr val="tx1"/>
+          </a:fontRef>
+        </p:style>
+      </p:cxnSp>
+      <p:cxnSp>
+        <p:nvCxnSpPr>
+          <p:cNvPr id="20" name="Connector 19"/>
+          <p:cNvCxnSpPr/>
+          <p:nvPr/>
+        </p:nvCxnSpPr>
+        <p:spPr>
+          <a:xfrm>
+            <a:off x="868680" y="2941320"/>
+            <a:ext cx="4114800" cy="0"/>
+          </a:xfrm>
+          <a:prstGeom prst="line">
+            <a:avLst/>
+          </a:prstGeom>
+          <a:ln w="9525">
+            <a:solidFill>
+              <a:srgbClr val="BFBFBF"/>
+            </a:solidFill>
+          </a:ln>
+        </p:spPr>
+        <p:style>
+          <a:lnRef idx="2">
+            <a:schemeClr val="accent1"/>
+          </a:lnRef>
+          <a:fillRef idx="0">
+            <a:schemeClr val="accent1"/>
+          </a:fillRef>
+          <a:effectRef idx="1">
+            <a:schemeClr val="accent1"/>
+          </a:effectRef>
+          <a:fontRef idx="minor">
+            <a:schemeClr val="tx1"/>
+          </a:fontRef>
+        </p:style>
+      </p:cxnSp>
+      <p:cxnSp>
+        <p:nvCxnSpPr>
+          <p:cNvPr id="21" name="Connector 20"/>
+          <p:cNvCxnSpPr/>
+          <p:nvPr/>
+        </p:nvCxnSpPr>
+        <p:spPr>
+          <a:xfrm>
+            <a:off x="868680" y="3185160"/>
+            <a:ext cx="4114800" cy="0"/>
+          </a:xfrm>
+          <a:prstGeom prst="line">
+            <a:avLst/>
+          </a:prstGeom>
+          <a:ln w="9525">
+            <a:solidFill>
+              <a:srgbClr val="BFBFBF"/>
+            </a:solidFill>
+          </a:ln>
+        </p:spPr>
+        <p:style>
+          <a:lnRef idx="2">
+            <a:schemeClr val="accent1"/>
+          </a:lnRef>
+          <a:fillRef idx="0">
+            <a:schemeClr val="accent1"/>
+          </a:fillRef>
+          <a:effectRef idx="1">
+            <a:schemeClr val="accent1"/>
+          </a:effectRef>
+          <a:fontRef idx="minor">
+            <a:schemeClr val="tx1"/>
+          </a:fontRef>
+        </p:style>
+      </p:cxnSp>
+      <p:cxnSp>
+        <p:nvCxnSpPr>
+          <p:cNvPr id="22" name="Connector 21"/>
+          <p:cNvCxnSpPr/>
+          <p:nvPr/>
+        </p:nvCxnSpPr>
+        <p:spPr>
+          <a:xfrm>
+            <a:off x="868680" y="3429000"/>
+            <a:ext cx="4114800" cy="0"/>
+          </a:xfrm>
+          <a:prstGeom prst="line">
+            <a:avLst/>
+          </a:prstGeom>
+          <a:ln w="9525">
+            <a:solidFill>
+              <a:srgbClr val="BFBFBF"/>
+            </a:solidFill>
+          </a:ln>
+        </p:spPr>
+        <p:style>
+          <a:lnRef idx="2">
+            <a:schemeClr val="accent1"/>
+          </a:lnRef>
+          <a:fillRef idx="0">
+            <a:schemeClr val="accent1"/>
+          </a:fillRef>
+          <a:effectRef idx="1">
+            <a:schemeClr val="accent1"/>
+          </a:effectRef>
+          <a:fontRef idx="minor">
+            <a:schemeClr val="tx1"/>
+          </a:fontRef>
+        </p:style>
+      </p:cxnSp>
+      <p:cxnSp>
+        <p:nvCxnSpPr>
+          <p:cNvPr id="23" name="Connector 22"/>
+          <p:cNvCxnSpPr/>
+          <p:nvPr/>
+        </p:nvCxnSpPr>
+        <p:spPr>
+          <a:xfrm>
+            <a:off x="868680" y="3672840"/>
+            <a:ext cx="4114800" cy="0"/>
+          </a:xfrm>
+          <a:prstGeom prst="line">
+            <a:avLst/>
+          </a:prstGeom>
+          <a:ln w="9525">
+            <a:solidFill>
+              <a:srgbClr val="BFBFBF"/>
+            </a:solidFill>
+          </a:ln>
+        </p:spPr>
+        <p:style>
+          <a:lnRef idx="2">
+            <a:schemeClr val="accent1"/>
+          </a:lnRef>
+          <a:fillRef idx="0">
+            <a:schemeClr val="accent1"/>
+          </a:fillRef>
+          <a:effectRef idx="1">
+            <a:schemeClr val="accent1"/>
+          </a:effectRef>
+          <a:fontRef idx="minor">
+            <a:schemeClr val="tx1"/>
+          </a:fontRef>
+        </p:style>
+      </p:cxnSp>
+      <p:cxnSp>
+        <p:nvCxnSpPr>
+          <p:cNvPr id="24" name="Connector 23"/>
+          <p:cNvCxnSpPr/>
+          <p:nvPr/>
+        </p:nvCxnSpPr>
+        <p:spPr>
+          <a:xfrm>
+            <a:off x="868680" y="3916680"/>
+            <a:ext cx="4114800" cy="0"/>
+          </a:xfrm>
+          <a:prstGeom prst="line">
+            <a:avLst/>
+          </a:prstGeom>
+          <a:ln w="9525">
+            <a:solidFill>
+              <a:srgbClr val="BFBFBF"/>
+            </a:solidFill>
+          </a:ln>
+        </p:spPr>
+        <p:style>
+          <a:lnRef idx="2">
+            <a:schemeClr val="accent1"/>
+          </a:lnRef>
+          <a:fillRef idx="0">
+            <a:schemeClr val="accent1"/>
+          </a:fillRef>
+          <a:effectRef idx="1">
+            <a:schemeClr val="accent1"/>
+          </a:effectRef>
+          <a:fontRef idx="minor">
+            <a:schemeClr val="tx1"/>
+          </a:fontRef>
+        </p:style>
+      </p:cxnSp>
+      <p:cxnSp>
+        <p:nvCxnSpPr>
+          <p:cNvPr id="25" name="Connector 24"/>
+          <p:cNvCxnSpPr/>
+          <p:nvPr/>
+        </p:nvCxnSpPr>
+        <p:spPr>
+          <a:xfrm>
+            <a:off x="868680" y="4160520"/>
+            <a:ext cx="4114800" cy="0"/>
+          </a:xfrm>
+          <a:prstGeom prst="line">
+            <a:avLst/>
+          </a:prstGeom>
+          <a:ln w="9525">
+            <a:solidFill>
+              <a:srgbClr val="BFBFBF"/>
+            </a:solidFill>
+          </a:ln>
+        </p:spPr>
+        <p:style>
+          <a:lnRef idx="2">
+            <a:schemeClr val="accent1"/>
+          </a:lnRef>
+          <a:fillRef idx="0">
+            <a:schemeClr val="accent1"/>
+          </a:fillRef>
+          <a:effectRef idx="1">
+            <a:schemeClr val="accent1"/>
+          </a:effectRef>
+          <a:fontRef idx="minor">
+            <a:schemeClr val="tx1"/>
+          </a:fontRef>
+        </p:style>
+      </p:cxnSp>
+      <p:cxnSp>
+        <p:nvCxnSpPr>
+          <p:cNvPr id="26" name="Connector 25"/>
+          <p:cNvCxnSpPr/>
+          <p:nvPr/>
+        </p:nvCxnSpPr>
+        <p:spPr>
+          <a:xfrm>
+            <a:off x="868680" y="4404360"/>
+            <a:ext cx="4114800" cy="0"/>
+          </a:xfrm>
+          <a:prstGeom prst="line">
+            <a:avLst/>
+          </a:prstGeom>
+          <a:ln w="9525">
+            <a:solidFill>
+              <a:srgbClr val="BFBFBF"/>
+            </a:solidFill>
+          </a:ln>
+        </p:spPr>
+        <p:style>
+          <a:lnRef idx="2">
+            <a:schemeClr val="accent1"/>
+          </a:lnRef>
+          <a:fillRef idx="0">
+            <a:schemeClr val="accent1"/>
+          </a:fillRef>
+          <a:effectRef idx="1">
+            <a:schemeClr val="accent1"/>
+          </a:effectRef>
+          <a:fontRef idx="minor">
+            <a:schemeClr val="tx1"/>
+          </a:fontRef>
+        </p:style>
+      </p:cxnSp>
+      <p:cxnSp>
+        <p:nvCxnSpPr>
+          <p:cNvPr id="27" name="Connector 26"/>
+          <p:cNvCxnSpPr/>
+          <p:nvPr/>
+        </p:nvCxnSpPr>
+        <p:spPr>
+          <a:xfrm>
+            <a:off x="868680" y="4648200"/>
+            <a:ext cx="4114800" cy="0"/>
+          </a:xfrm>
+          <a:prstGeom prst="line">
+            <a:avLst/>
+          </a:prstGeom>
+          <a:ln w="9525">
+            <a:solidFill>
+              <a:srgbClr val="BFBFBF"/>
+            </a:solidFill>
+          </a:ln>
+        </p:spPr>
+        <p:style>
+          <a:lnRef idx="2">
+            <a:schemeClr val="accent1"/>
+          </a:lnRef>
+          <a:fillRef idx="0">
+            <a:schemeClr val="accent1"/>
+          </a:fillRef>
+          <a:effectRef idx="1">
+            <a:schemeClr val="accent1"/>
+          </a:effectRef>
+          <a:fontRef idx="minor">
+            <a:schemeClr val="tx1"/>
+          </a:fontRef>
+        </p:style>
+      </p:cxnSp>
+      <p:cxnSp>
+        <p:nvCxnSpPr>
+          <p:cNvPr id="28" name="Connector 27"/>
+          <p:cNvCxnSpPr/>
+          <p:nvPr/>
+        </p:nvCxnSpPr>
+        <p:spPr>
+          <a:xfrm>
+            <a:off x="868680" y="3429000"/>
+            <a:ext cx="4114800" cy="0"/>
+          </a:xfrm>
+          <a:prstGeom prst="line">
+            <a:avLst/>
+          </a:prstGeom>
+          <a:ln w="38100">
+            <a:solidFill>
+              <a:srgbClr val="2E7D32"/>
+            </a:solidFill>
+            <a:prstDash val="dash"/>
+          </a:ln>
+        </p:spPr>
+        <p:style>
+          <a:lnRef idx="2">
+            <a:schemeClr val="accent1"/>
+          </a:lnRef>
+          <a:fillRef idx="0">
+            <a:schemeClr val="accent1"/>
+          </a:fillRef>
+          <a:effectRef idx="1">
+            <a:schemeClr val="accent1"/>
+          </a:effectRef>
+          <a:fontRef idx="minor">
+            <a:schemeClr val="tx1"/>
+          </a:fontRef>
+        </p:style>
+      </p:cxnSp>
+      <p:cxnSp>
+        <p:nvCxnSpPr>
+          <p:cNvPr id="29" name="Connector 28"/>
+          <p:cNvCxnSpPr/>
+          <p:nvPr/>
+        </p:nvCxnSpPr>
+        <p:spPr>
+          <a:xfrm>
+            <a:off x="2926080" y="2103120"/>
+            <a:ext cx="0" cy="2651759"/>
+          </a:xfrm>
+          <a:prstGeom prst="line">
+            <a:avLst/>
+          </a:prstGeom>
+          <a:ln w="38100">
+            <a:solidFill>
+              <a:srgbClr val="C0392B"/>
+            </a:solidFill>
+            <a:prstDash val="dash"/>
+          </a:ln>
+        </p:spPr>
+        <p:style>
+          <a:lnRef idx="2">
+            <a:schemeClr val="accent1"/>
+          </a:lnRef>
+          <a:fillRef idx="0">
+            <a:schemeClr val="accent1"/>
+          </a:fillRef>
+          <a:effectRef idx="1">
+            <a:schemeClr val="accent1"/>
+          </a:effectRef>
+          <a:fontRef idx="minor">
+            <a:schemeClr val="tx1"/>
+          </a:fontRef>
+        </p:style>
+      </p:cxnSp>
+      <p:sp>
+        <p:nvSpPr>
+          <p:cNvPr id="30" name="TextBox 29"/>
+          <p:cNvSpPr txBox="1"/>
+          <p:nvPr/>
+        </p:nvSpPr>
+        <p:spPr>
+          <a:xfrm>
+            <a:off x="731520" y="4983479"/>
+            <a:ext cx="4389120" cy="365760"/>
+          </a:xfrm>
+          <a:prstGeom prst="rect">
+            <a:avLst/>
+          </a:prstGeom>
+          <a:noFill/>
+        </p:spPr>
+        <p:txBody>
+          <a:bodyPr wrap="square" anchor="ctr">
+            <a:spAutoFit/>
+          </a:bodyPr>
+          <a:lstStyle/>
+          <a:p>
+            <a:pPr algn="ctr" rtl="1"/>
+            <a:r>
+              <a:rPr sz="1500" b="0" lang="ar-SA">
+                <a:solidFill>
+                  <a:srgbClr val="595959"/>
+                </a:solidFill>
+                <a:latin typeface="Sakkal Majalla"/>
+                <a:cs typeface="Sakkal Majalla"/>
+              </a:rPr>
+              <a:t>الخطوط الرمادية: اتجاه الألياف</a:t>
+            </a:r>
+          </a:p>
+        </p:txBody>
+      </p:sp>
+      <p:sp>
+        <p:nvSpPr>
+          <p:cNvPr id="31" name="TextBox 30"/>
+          <p:cNvSpPr txBox="1"/>
+          <p:nvPr/>
+        </p:nvSpPr>
+        <p:spPr>
+          <a:xfrm>
+            <a:off x="731520" y="5349240"/>
+            <a:ext cx="4389120" cy="365760"/>
+          </a:xfrm>
+          <a:prstGeom prst="rect">
+            <a:avLst/>
+          </a:prstGeom>
+          <a:noFill/>
+        </p:spPr>
+        <p:txBody>
+          <a:bodyPr wrap="square" anchor="ctr">
+            <a:spAutoFit/>
+          </a:bodyPr>
+          <a:lstStyle/>
+          <a:p>
+            <a:pPr algn="ctr" rtl="1"/>
+            <a:r>
+              <a:rPr sz="1600" b="1" lang="ar-SA">
+                <a:solidFill>
+                  <a:srgbClr val="2E7D32"/>
+                </a:solidFill>
+                <a:latin typeface="Sakkal Majalla"/>
+                <a:cs typeface="Sakkal Majalla"/>
+              </a:rPr>
+              <a:t>طيّ موازٍ للألياف: نظيف ✓</a:t>
+            </a:r>
+          </a:p>
+        </p:txBody>
+      </p:sp>
+      <p:sp>
+        <p:nvSpPr>
+          <p:cNvPr id="32" name="TextBox 31"/>
+          <p:cNvSpPr txBox="1"/>
+          <p:nvPr/>
+        </p:nvSpPr>
+        <p:spPr>
+          <a:xfrm>
+            <a:off x="731520" y="5715000"/>
+            <a:ext cx="4389120" cy="365760"/>
+          </a:xfrm>
+          <a:prstGeom prst="rect">
+            <a:avLst/>
+          </a:prstGeom>
+          <a:noFill/>
+        </p:spPr>
+        <p:txBody>
+          <a:bodyPr wrap="square" anchor="ctr">
+            <a:spAutoFit/>
+          </a:bodyPr>
+          <a:lstStyle/>
+          <a:p>
+            <a:pPr algn="ctr" rtl="1"/>
+            <a:r>
+              <a:rPr sz="1600" b="1" lang="ar-SA">
+                <a:solidFill>
+                  <a:srgbClr val="C0392B"/>
+                </a:solidFill>
+                <a:latin typeface="Sakkal Majalla"/>
+                <a:cs typeface="Sakkal Majalla"/>
+              </a:rPr>
+              <a:t>طيّ عمودي على الألياف: قد يتشقق ✗</a:t>
+            </a:r>
+          </a:p>
+        </p:txBody>
+      </p:sp>
     </p:spTree>
   </p:cSld>
   <p:clrMapOvr>
@@ -9505,7 +12026,7 @@
             </a:pPr>
             <a:r>
               <a:rPr lang="ar-SA" sz="2000" b="1"/>
-              <a:t>المِفرَد (Net):</a:t>
+              <a:t>سماكة الورق في المِفرَد:</a:t>
             </a:r>
           </a:p>
           <a:p>
@@ -9514,40 +12035,40 @@
             </a:pPr>
             <a:r>
               <a:rPr lang="ar-SA" sz="2000"/>
-              <a:t>المِفرَد هو الصورة المسطحة للعبوة قبل طيّها، ويتطلب تصميمه مراعاة ما يلي:</a:t>
+              <a:t>للورق المقوّى سماكة فعلية، فإذا رُسم المِفرَد بمقاسات الشكل النظرية تمامًا لم تنطبق الأوجه عند الطي، وظهرت فراغات أو تزاحم عند الحواف.</a:t>
             </a:r>
           </a:p>
           <a:p>
             <a:pPr/>
             <a:r>
               <a:rPr lang="ar-SA" sz="2000" b="1"/>
-              <a:t>ترتيب الأوجه: </a:t>
-            </a:r>
-            <a:r>
-              <a:rPr lang="ar-SA" sz="2000"/>
-              <a:t>بما يضمن انغلاق الشكل انغلاقًا صحيحًا.</a:t>
+              <a:t>الألسنة الداخلية: </a:t>
+            </a:r>
+            <a:r>
+              <a:rPr lang="ar-SA" sz="2000"/>
+              <a:t>تُصغَّر قليلًا (بمقدار السماكة تقريبًا) كي تدخل دون أن تنتفخ العبوة.</a:t>
             </a:r>
           </a:p>
           <a:p>
             <a:pPr/>
             <a:r>
               <a:rPr lang="ar-SA" sz="2000" b="1"/>
-              <a:t>الألسنة (Tabs): </a:t>
-            </a:r>
-            <a:r>
-              <a:rPr lang="ar-SA" sz="2000"/>
-              <a:t>أشكالها ومواضعها، لأنها أداة الربط بين الأوجه.</a:t>
+              <a:t>الأوجه التي تلتف على غيرها: </a:t>
+            </a:r>
+            <a:r>
+              <a:rPr lang="ar-SA" sz="2000"/>
+              <a:t>تُكبَّر قليلًا لأنها تحيط بسماكة الورق الداخلي.</a:t>
             </a:r>
           </a:p>
           <a:p>
             <a:pPr/>
             <a:r>
               <a:rPr lang="ar-SA" sz="2000" b="1"/>
-              <a:t>آلية الإغلاق: </a:t>
-            </a:r>
-            <a:r>
-              <a:rPr lang="ar-SA" sz="2000"/>
-              <a:t>لسان اللصق (Glue Tab) للإغلاق الدائم، وقفل النقر (Click Lock) للإغلاق السريع، وقفل اللسان (Tongue Lock) للفتح والإغلاق المتكرر.</a:t>
+              <a:t>أطراف الألسنة: </a:t>
+            </a:r>
+            <a:r>
+              <a:rPr lang="ar-SA" sz="2000"/>
+              <a:t>تُشطف أو تُميَّل زواياها حتى لا تحتك بخطوط الطي المجاورة.</a:t>
             </a:r>
           </a:p>
           <a:p>
@@ -9556,11 +12077,11 @@
             </a:pPr>
             <a:r>
               <a:rPr lang="ar-SA" sz="2000" b="1"/>
-              <a:t>موضع الغطاء: </a:t>
-            </a:r>
-            <a:r>
-              <a:rPr lang="ar-SA" sz="2000"/>
-              <a:t>غير ثابت؛ يمكن وضعه على أي وجه وبأي اتجاه وفق طريقة عرض المنتج واستخدامه.</a:t>
+              <a:t>قاعدة عملية: </a:t>
+            </a:r>
+            <a:r>
+              <a:rPr lang="ar-SA" sz="2000"/>
+              <a:t>كلما زادت سماكة الورق زادت الحاجة إلى التعويض، ويُختبر المِفرَد دائمًا بنموذج أولي قبل اعتماده.</a:t>
             </a:r>
           </a:p>
         </p:txBody>
@@ -9601,22 +12122,22 @@
       </p:sp>
       <p:pic>
         <p:nvPicPr>
-          <p:cNvPr id="16" name="Picture 15" descr="dc1.png"/>
+          <p:cNvPr id="16" name="Picture 15" descr="edge.png"/>
           <p:cNvPicPr>
             <a:picLocks noChangeAspect="1"/>
           </p:cNvPicPr>
           <p:nvPr/>
         </p:nvPicPr>
         <p:blipFill>
-          <a:blip r:embed="rId2"/>
+          <a:blip r:embed="rId3"/>
           <a:stretch>
             <a:fillRect/>
           </a:stretch>
         </p:blipFill>
         <p:spPr>
           <a:xfrm>
-            <a:off x="457200" y="1726320"/>
-            <a:ext cx="4937760" cy="4136879"/>
+            <a:off x="894997" y="1600200"/>
+            <a:ext cx="4062165" cy="4389120"/>
           </a:xfrm>
           <a:prstGeom prst="rect">
             <a:avLst/>
@@ -9668,7 +12189,29 @@
             </a:pPr>
             <a:r>
               <a:rPr lang="ar-SA" sz="2000" b="1"/>
-              <a:t>استراتيجيات تشويه المكعّب:</a:t>
+              <a:t>اتجاه الطي: الجبلي والوادي (Mountain and Valley Folds):</a:t>
+            </a:r>
+          </a:p>
+          <a:p>
+            <a:pPr/>
+            <a:r>
+              <a:rPr lang="ar-SA" sz="2000" b="1"/>
+              <a:t>طيّة الوادي (Valley Fold): </a:t>
+            </a:r>
+            <a:r>
+              <a:rPr lang="ar-SA" sz="2000"/>
+              <a:t>ينثني الورق نحو الناظر فيتشكّل مجرى كالوادي.</a:t>
+            </a:r>
+          </a:p>
+          <a:p>
+            <a:pPr/>
+            <a:r>
+              <a:rPr lang="ar-SA" sz="2000" b="1"/>
+              <a:t>طيّة الجبل (Mountain Fold): </a:t>
+            </a:r>
+            <a:r>
+              <a:rPr lang="ar-SA" sz="2000"/>
+              <a:t>ينثني الورق بعيدًا عن الناظر فتتشكّل حافة بارزة كقمة الجبل.</a:t>
             </a:r>
           </a:p>
           <a:p>
@@ -9676,12 +12219,8 @@
               <a:buNone/>
             </a:pPr>
             <a:r>
-              <a:rPr lang="ar-SA" sz="2000" b="1"/>
-              <a:t>١. النحت: </a:t>
-            </a:r>
-            <a:r>
-              <a:rPr lang="ar-SA" sz="2000"/>
-              <a:t>يُتخيّل المكعّب كتلة صلبة يُكشط منها جزء من وجه أو حافة أو ركن، بمقدار قليل أو كبير، بصورة متماثلة أو غير متماثلة.</a:t>
+              <a:rPr lang="ar-SA" sz="2000"/>
+              <a:t>وتُميَّز الطيتان في المِفرَد برمزين مختلفين يوضَّحان في مفتاح الرسم، وتختلف الرموز بين المصادر.</a:t>
             </a:r>
           </a:p>
           <a:p>
@@ -9690,33 +12229,11 @@
             </a:pPr>
             <a:r>
               <a:rPr lang="ar-SA" sz="2000" b="1"/>
-              <a:t>٢. المرونة: </a:t>
-            </a:r>
-            <a:r>
-              <a:rPr lang="ar-SA" sz="2000"/>
-              <a:t>يُتخيّل المكعّب كتلة مطاطية تُشدّ أو تُضغط أو تُلوى على محاور تصل بين أوجه أو حواف أو أركان متقابلة.</a:t>
-            </a:r>
-          </a:p>
-          <a:p>
-            <a:pPr marL="0" indent="0">
-              <a:buNone/>
-            </a:pPr>
-            <a:r>
-              <a:rPr lang="ar-SA" sz="2000" b="1"/>
-              <a:t>٣. التقويس: </a:t>
-            </a:r>
-            <a:r>
-              <a:rPr lang="ar-SA" sz="2000"/>
-              <a:t>تُستبدل الحواف المستقيمة بحواف منحنية، فتتقوّس الأوجه المستوية.</a:t>
-            </a:r>
-          </a:p>
-          <a:p>
-            <a:pPr marL="0" indent="0">
-              <a:buNone/>
-            </a:pPr>
-            <a:r>
-              <a:rPr lang="ar-SA" sz="2000"/>
-              <a:t>ومتى استوعب المصمم هذه الاستراتيجيات، أصبح ابتكار أشكال تغليف جديدة ميسورًا حتى مع معرفة محدودة بالهندسة الفراغية.</a:t>
+              <a:t>أهميته: </a:t>
+            </a:r>
+            <a:r>
+              <a:rPr lang="ar-SA" sz="2000"/>
+              <a:t>في الأشكال المركّبة، كتقنية الضغط، تُطوى بعض الخطوط باتجاه معاكس لغيرها، والخطأ في الاتجاه يُفسد الشكل.</a:t>
             </a:r>
           </a:p>
         </p:txBody>
@@ -9757,31 +12274,7 @@
       </p:sp>
       <p:pic>
         <p:nvPicPr>
-          <p:cNvPr id="16" name="Picture 15" descr="face.png"/>
-          <p:cNvPicPr>
-            <a:picLocks noChangeAspect="1"/>
-          </p:cNvPicPr>
-          <p:nvPr/>
-        </p:nvPicPr>
-        <p:blipFill>
-          <a:blip r:embed="rId2"/>
-          <a:stretch>
-            <a:fillRect/>
-          </a:stretch>
-        </p:blipFill>
-        <p:spPr>
-          <a:xfrm>
-            <a:off x="1872699" y="1600200"/>
-            <a:ext cx="2106761" cy="2322576"/>
-          </a:xfrm>
-          <a:prstGeom prst="rect">
-            <a:avLst/>
-          </a:prstGeom>
-        </p:spPr>
-      </p:pic>
-      <p:pic>
-        <p:nvPicPr>
-          <p:cNvPr id="17" name="Picture 16" descr="stretch-edge.png"/>
+          <p:cNvPr id="16" name="Picture 15" descr="compress.png"/>
           <p:cNvPicPr>
             <a:picLocks noChangeAspect="1"/>
           </p:cNvPicPr>
@@ -9795,38 +12288,158 @@
         </p:blipFill>
         <p:spPr>
           <a:xfrm>
-            <a:off x="783975" y="4105656"/>
-            <a:ext cx="1723888" cy="1883664"/>
+            <a:off x="1409924" y="1600200"/>
+            <a:ext cx="3032311" cy="3017520"/>
           </a:xfrm>
           <a:prstGeom prst="rect">
             <a:avLst/>
           </a:prstGeom>
         </p:spPr>
       </p:pic>
-      <p:pic>
-        <p:nvPicPr>
-          <p:cNvPr id="18" name="Picture 17" descr="single.png"/>
-          <p:cNvPicPr>
-            <a:picLocks noChangeAspect="1"/>
-          </p:cNvPicPr>
+      <p:cxnSp>
+        <p:nvCxnSpPr>
+          <p:cNvPr id="17" name="Connector 16"/>
+          <p:cNvCxnSpPr/>
           <p:nvPr/>
-        </p:nvPicPr>
-        <p:blipFill>
-          <a:blip r:embed="rId4"/>
-          <a:stretch>
-            <a:fillRect/>
-          </a:stretch>
-        </p:blipFill>
-        <p:spPr>
-          <a:xfrm>
-            <a:off x="3017520" y="4108109"/>
-            <a:ext cx="2377440" cy="1878757"/>
+        </p:nvCxnSpPr>
+        <p:spPr>
+          <a:xfrm>
+            <a:off x="1005840" y="5029200"/>
+            <a:ext cx="1463040" cy="0"/>
+          </a:xfrm>
+          <a:prstGeom prst="line">
+            <a:avLst/>
+          </a:prstGeom>
+          <a:ln w="38100">
+            <a:solidFill>
+              <a:srgbClr val="000000"/>
+            </a:solidFill>
+            <a:prstDash val="dash"/>
+          </a:ln>
+        </p:spPr>
+        <p:style>
+          <a:lnRef idx="2">
+            <a:schemeClr val="accent1"/>
+          </a:lnRef>
+          <a:fillRef idx="0">
+            <a:schemeClr val="accent1"/>
+          </a:fillRef>
+          <a:effectRef idx="1">
+            <a:schemeClr val="accent1"/>
+          </a:effectRef>
+          <a:fontRef idx="minor">
+            <a:schemeClr val="tx1"/>
+          </a:fontRef>
+        </p:style>
+      </p:cxnSp>
+      <p:sp>
+        <p:nvSpPr>
+          <p:cNvPr id="18" name="TextBox 17"/>
+          <p:cNvSpPr txBox="1"/>
+          <p:nvPr/>
+        </p:nvSpPr>
+        <p:spPr>
+          <a:xfrm>
+            <a:off x="2651760" y="4800600"/>
+            <a:ext cx="2560320" cy="457200"/>
           </a:xfrm>
           <a:prstGeom prst="rect">
             <a:avLst/>
           </a:prstGeom>
-        </p:spPr>
-      </p:pic>
+          <a:noFill/>
+        </p:spPr>
+        <p:txBody>
+          <a:bodyPr wrap="square" anchor="ctr">
+            <a:spAutoFit/>
+          </a:bodyPr>
+          <a:lstStyle/>
+          <a:p>
+            <a:pPr algn="ctr" rtl="1"/>
+            <a:r>
+              <a:rPr sz="1600" b="1" lang="ar-SA">
+                <a:solidFill>
+                  <a:srgbClr val="000000"/>
+                </a:solidFill>
+                <a:latin typeface="Sakkal Majalla"/>
+                <a:cs typeface="Sakkal Majalla"/>
+              </a:rPr>
+              <a:t>وادٍ (متقطع)</a:t>
+            </a:r>
+          </a:p>
+        </p:txBody>
+      </p:sp>
+      <p:cxnSp>
+        <p:nvCxnSpPr>
+          <p:cNvPr id="19" name="Connector 18"/>
+          <p:cNvCxnSpPr/>
+          <p:nvPr/>
+        </p:nvCxnSpPr>
+        <p:spPr>
+          <a:xfrm>
+            <a:off x="1005840" y="5577840"/>
+            <a:ext cx="1463040" cy="0"/>
+          </a:xfrm>
+          <a:prstGeom prst="line">
+            <a:avLst/>
+          </a:prstGeom>
+          <a:ln w="38100">
+            <a:solidFill>
+              <a:srgbClr val="000000"/>
+            </a:solidFill>
+            <a:prstDash val="dashDot"/>
+          </a:ln>
+        </p:spPr>
+        <p:style>
+          <a:lnRef idx="2">
+            <a:schemeClr val="accent1"/>
+          </a:lnRef>
+          <a:fillRef idx="0">
+            <a:schemeClr val="accent1"/>
+          </a:fillRef>
+          <a:effectRef idx="1">
+            <a:schemeClr val="accent1"/>
+          </a:effectRef>
+          <a:fontRef idx="minor">
+            <a:schemeClr val="tx1"/>
+          </a:fontRef>
+        </p:style>
+      </p:cxnSp>
+      <p:sp>
+        <p:nvSpPr>
+          <p:cNvPr id="20" name="TextBox 19"/>
+          <p:cNvSpPr txBox="1"/>
+          <p:nvPr/>
+        </p:nvSpPr>
+        <p:spPr>
+          <a:xfrm>
+            <a:off x="2651760" y="5349240"/>
+            <a:ext cx="2560320" cy="457200"/>
+          </a:xfrm>
+          <a:prstGeom prst="rect">
+            <a:avLst/>
+          </a:prstGeom>
+          <a:noFill/>
+        </p:spPr>
+        <p:txBody>
+          <a:bodyPr wrap="square" anchor="ctr">
+            <a:spAutoFit/>
+          </a:bodyPr>
+          <a:lstStyle/>
+          <a:p>
+            <a:pPr algn="ctr" rtl="1"/>
+            <a:r>
+              <a:rPr sz="1600" b="1" lang="ar-SA">
+                <a:solidFill>
+                  <a:srgbClr val="000000"/>
+                </a:solidFill>
+                <a:latin typeface="Sakkal Majalla"/>
+                <a:cs typeface="Sakkal Majalla"/>
+              </a:rPr>
+              <a:t>جبل (شرطة ونقطة)</a:t>
+            </a:r>
+          </a:p>
+        </p:txBody>
+      </p:sp>
     </p:spTree>
   </p:cSld>
   <p:clrMapOvr>

</xml_diff>

<commit_message>
Simplify explanations on tools, die-cut, grain, thickness, folds and techniques
Co-Authored-By: Claude Opus 5.5 <noreply@anthropic.com>
Claude-Session: https://claude.ai/code/session_01AHTaFDu9kUfR2hK38q6H2d
</commit_message>
<xml_diff>
--- a/lecture-from-cube-to-box-template.pptx
+++ b/lecture-from-cube-to-box-template.pptx
@@ -809,7 +809,7 @@
           <a:lstStyle/>
           <a:p>
             <a:r>
-              <a:t>الشدّ من حافة إلى حافة (Stretching Edge-to-edge): نتخيل المكعّب مطاطًا، ونمسك حافتين متقابلتين ونشدّهما بعيدًا عن بعض، فيصبح صندوقًا مائلًا (Leaning Box).</a:t>
+              <a:t>شطف زاوية (Shaving a Corner): نقطع رأس إحدى زوايا المكعّب بقطعة صغيرة، فيظهر مكانها سطح على شكل مثلث. وإذا قطعنا المسافة نفسها على الحواف الثلاث كان المثلث متساوي الأضلاع.</a:t>
             </a:r>
           </a:p>
         </p:txBody>
@@ -879,7 +879,7 @@
           <a:lstStyle/>
           <a:p>
             <a:r>
-              <a:t>الشدّ من زاوية إلى زاوية (Stretching Corner-to-corner): نمسك زاويتين متقابلتين (أبعد نقطتين في المكعّب) ونشدّهما، فيصبح الشكل كالمعيّن الممدود.</a:t>
+              <a:t>الشدّ من حافة إلى حافة (Stretching Edge-to-edge): نتخيل المكعّب إسفنجة، نمسك الحافة العلوية من جهة والحافة السفلية من الجهة المقابلة ونشدّهما، فيميل الصندوق كله إلى جهة واحدة.</a:t>
             </a:r>
           </a:p>
         </p:txBody>
@@ -949,7 +949,7 @@
           <a:lstStyle/>
           <a:p>
             <a:r>
-              <a:t>لفّ الغطاء والقاعدة (Twisting Opposite Faces): الوجهان المقصودان هما الغطاء (الوجه العلوي) والقاعدة (الوجه السفلي). نثبّت القاعدة ونلفّ الغطاء لفّة خفيفة، كما نفتح غطاء البرطمان، فتميل الجدران الأربعة.</a:t>
+              <a:t>الشدّ من زاوية إلى زاوية (Stretching Corner-to-corner): نمسك الزاوية العلوية من جهة والزاوية السفلية المقابلة لها تمامًا (أبعد نقطتين في المكعّب) ونشدّهما، فيتمدد المكعّب على طول هذا الخط.</a:t>
             </a:r>
           </a:p>
         </p:txBody>
@@ -1019,7 +1019,7 @@
           <a:lstStyle/>
           <a:p>
             <a:r>
-              <a:t>اللفّ: النسخة المُضلَّعة (Twisting: Faceted Version): نكمل لفّ الغطاء أكثر حتى تصبح كل زاوية في الغطاء فوق منتصف حافة القاعدة، ثم نصل الزوايا بخطوط طي.</a:t>
+              <a:t>لفّ الغطاء والقاعدة (Twisting Opposite Faces): الوجهان المقصودان هما الغطاء والقاعدة. نثبّت القاعدة ونلفّ الغطاء قليلًا، كما نفتح غطاء البرطمان، فتميل الجدران الأربعة.</a:t>
             </a:r>
           </a:p>
         </p:txBody>
@@ -1089,7 +1089,7 @@
           <a:lstStyle/>
           <a:p>
             <a:r>
-              <a:t>الضغط من الأعلى إلى الأسفل (Compressing Face-to-face): نضغط الغطاء نحو القاعدة كأننا نضغط علبة مطاطية، فتنثني الجدران عند منتصفها. والشكل المعروض تبسيط لهذه الفكرة بخطوط طي مستقيمة.</a:t>
+              <a:t>اللفّ: النسخة المُضلَّعة (Twisting: Faceted Version): نكمل لفّ الغطاء أكثر حتى تقع كل زاوية من الغطاء فوق منتصف حافة من حواف القاعدة، ثم نصل كل زاوية بالزاويتين القريبتين منها بخطوط طي.</a:t>
             </a:r>
           </a:p>
         </p:txBody>
@@ -1159,7 +1159,7 @@
           <a:lstStyle/>
           <a:p>
             <a:r>
-              <a:t>لماذا ٥٪؟ الفرجار المفتوح كثيرًا يرسم قوسًا خفيف الانحناء يسهل طيّه، والمفتوح قليلًا يرسم قوسًا حادًا يصعب طيّه. في الصورة: الخط السميك هو الحافة، والدائرة المنقطة مرسومة بالفرجار ومركزها على الخط المساعد.</a:t>
+              <a:t>الضغط من الأعلى إلى الأسفل (Compressing Face-to-face): نتخيل علبة إسفنجية نضغطها من فوق بكفّ اليد، فتنثني جدرانها من المنتصف. والشكل في الصورة تبسيط لهذه الفكرة بخطوط طي مستقيمة.</a:t>
             </a:r>
           </a:p>
         </p:txBody>
@@ -1229,7 +1229,7 @@
           <a:lstStyle/>
           <a:p>
             <a:r>
-              <a:t>يمكن عرض العبوات الحقيقية في القاعة إن توفرت، وسؤال الطلاب: أي تقنية من تقنيات المحاضرة تفسّر هذا الشكل؟</a:t>
+              <a:t>لماذا ٥٪؟ الفرجار المفتوح كثيرًا يرسم قوسًا خفيف الانحناء يسهل طيّه، والمفتوح قليلًا يرسم قوسًا حادًا يصعب طيّه. في الصورة: الخط السميك هو الحافة، والدائرة المنقطة مرسومة بالفرجار ومركزها على الخط المساعد.</a:t>
             </a:r>
           </a:p>
         </p:txBody>
@@ -1299,6 +1299,76 @@
           <a:lstStyle/>
           <a:p>
             <a:r>
+              <a:t>يمكن عرض العبوات الحقيقية في القاعة إن توفرت، وسؤال الطلاب: أي تقنية من تقنيات المحاضرة تفسّر هذا الشكل؟</a:t>
+            </a:r>
+          </a:p>
+        </p:txBody>
+      </p:sp>
+      <p:sp>
+        <p:nvSpPr>
+          <p:cNvPr id="4" name="Slide Number Placeholder 3"/>
+          <p:cNvSpPr>
+            <a:spLocks noGrp="1"/>
+          </p:cNvSpPr>
+          <p:nvPr>
+            <p:ph type="sldNum" idx="5" sz="quarter"/>
+          </p:nvPr>
+        </p:nvSpPr>
+        <p:spPr/>
+      </p:sp>
+    </p:spTree>
+  </p:cSld>
+  <p:clrMapOvr>
+    <a:masterClrMapping/>
+  </p:clrMapOvr>
+</p:notes>
+</file>
+
+<file path=ppt/notesSlides/notesSlide18.xml><?xml version="1.0" encoding="utf-8"?>
+<p:notes xmlns:a="http://schemas.openxmlformats.org/drawingml/2006/main" xmlns:p="http://schemas.openxmlformats.org/presentationml/2006/main" xmlns:r="http://schemas.openxmlformats.org/officeDocument/2006/relationships">
+  <p:cSld>
+    <p:spTree>
+      <p:nvGrpSpPr>
+        <p:cNvPr id="1" name=""/>
+        <p:cNvGrpSpPr/>
+        <p:nvPr/>
+      </p:nvGrpSpPr>
+      <p:grpSpPr>
+        <a:xfrm>
+          <a:off x="0" y="0"/>
+          <a:ext cx="0" cy="0"/>
+          <a:chOff x="0" y="0"/>
+          <a:chExt cx="0" cy="0"/>
+        </a:xfrm>
+      </p:grpSpPr>
+      <p:sp>
+        <p:nvSpPr>
+          <p:cNvPr id="2" name="Slide Image Placeholder 1"/>
+          <p:cNvSpPr>
+            <a:spLocks noGrp="1"/>
+          </p:cNvSpPr>
+          <p:nvPr>
+            <p:ph type="sldImg" idx="2"/>
+          </p:nvPr>
+        </p:nvSpPr>
+        <p:spPr/>
+      </p:sp>
+      <p:sp>
+        <p:nvSpPr>
+          <p:cNvPr id="3" name="Notes Placeholder 2"/>
+          <p:cNvSpPr>
+            <a:spLocks noGrp="1"/>
+          </p:cNvSpPr>
+          <p:nvPr>
+            <p:ph type="body" idx="3" sz="quarter"/>
+          </p:nvPr>
+        </p:nvSpPr>
+        <p:spPr/>
+        <p:txBody>
+          <a:bodyPr/>
+          <a:lstStyle/>
+          <a:p>
+            <a:r>
               <a:t>الإجابات: ١) بالضغط عليه بظهر الشفرة أو أداة غير حادة؛ لأن الحد القاطع يقطع الورق فيضعف. ٢) فوق التصميم، كي تتجه الشفرة إن انزلقت نحو الورق الزائد. ٣) سبعة أوجه. ٤) ٨٠°، ولا يُنصح بأقل من ٧٠°. ٥) ١٢ × ١٫٠٥ = ١٢٫٦ سم. ٦) لأن الأقواس تعمل أزواجًا متعاكسة.</a:t>
             </a:r>
           </a:p>
@@ -1439,7 +1509,7 @@
           <a:lstStyle/>
           <a:p>
             <a:r>
-              <a:t>الشكل المائل لأطراف اللسان ضروري؛ لو كان اللسان مستطيلًا لاصطدم بلسان الوجه المجاور عند الطي.</a:t>
+              <a:t>في الصورة: دايلاين مكعّب؛ الخطوط المتصلة للقص، والمتقطعة للطي، وحرف T يدل على الألسنة.</a:t>
             </a:r>
           </a:p>
         </p:txBody>
@@ -1509,7 +1579,7 @@
           <a:lstStyle/>
           <a:p>
             <a:r>
-              <a:t>اختبار الاتجاه: تُثنى قطعة صغيرة في الاتجاهين، فالأسهل انثناءً هو اتجاه الألياف. أو تُمزَّق: التمزق مع الألياف يكون مستقيمًا ومع عكسها متعرجًا.</a:t>
+              <a:t>الشكل المائل لأطراف اللسان ضروري؛ لو كان اللسان مستطيلًا لاصطدم بلسان الوجه المجاور عند الطي.</a:t>
             </a:r>
           </a:p>
         </p:txBody>
@@ -1579,7 +1649,7 @@
           <a:lstStyle/>
           <a:p>
             <a:r>
-              <a:t>قاعدة عملية: كلما زادت سماكة الورق زادت الحاجة إلى هذا التعديل، ويُجرَّب الدايلاين دائمًا بنموذج قبل اعتماده.</a:t>
+              <a:t>اختبار الاتجاه: تُثنى قطعة صغيرة في الاتجاهين، فالأسهل انثناءً هو اتجاه الألياف. أو تُمزَّق: التمزق مع الألياف يكون مستقيمًا ومع عكسها متعرجًا.</a:t>
             </a:r>
           </a:p>
         </p:txBody>
@@ -1649,7 +1719,7 @@
           <a:lstStyle/>
           <a:p>
             <a:r>
-              <a:t>في تقنية الضغط يُطوى الخط الأفقي في منتصف الجدار عكس اتجاه الخطوط العمودية، وهذا ما يجعل الجدار ينثني للداخل.</a:t>
+              <a:t>قاعدة عملية: كلما زادت سماكة الورق زاد هذا الفرق، ويُجرَّب الدايلاين دائمًا بنموذج قبل اعتماده.</a:t>
             </a:r>
           </a:p>
         </p:txBody>
@@ -1719,7 +1789,7 @@
           <a:lstStyle/>
           <a:p>
             <a:r>
-              <a:t>إمالة السطح العلوي (Shaving a Face): نقطع الجزء العلوي من المكعّب بخط مائل، فيصبح السطح العلوي منحدرًا بدل أن يكون مستويًا. ويمكن أن يكون الميل خفيفًا أو حادًا، أو مائلًا للأمام أو للخلف.</a:t>
+              <a:t>في تقنية الضغط يُطوى الخط الأفقي في منتصف الجدار عكس اتجاه الخطوط العمودية، وهذا ما يجعل الجدار ينثني للداخل.</a:t>
             </a:r>
           </a:p>
         </p:txBody>
@@ -1789,7 +1859,7 @@
           <a:lstStyle/>
           <a:p>
             <a:r>
-              <a:t>شطف حافة (Shaving an Edge): نقطع إحدى الحواف الحادة بقطع مائل، فيظهر مكانها سطح جديد صغير، كما يُشطف طرف قطعة الخشب.</a:t>
+              <a:t>إمالة السطح العلوي (Shaving a Face): نتخيل مكعّب جبن ونقطع رأسه بالسكين قطعًا مائلًا، فيصبح السطح العلوي منحدرًا مثل السقف المائل.</a:t>
             </a:r>
           </a:p>
         </p:txBody>
@@ -1859,7 +1929,7 @@
           <a:lstStyle/>
           <a:p>
             <a:r>
-              <a:t>شطف زاوية (Shaving a Corner): نقطع إحدى زوايا المكعّب، فيظهر مكانها سطح جديد على شكل مثلث. وإذا قطعنا المسافة نفسها على الحواف الثلاث كان المثلث متساوي الأضلاع.</a:t>
+              <a:t>شطف حافة (Shaving an Edge): نقطع إحدى الحواف الحادة قطعًا مائلًا صغيرًا، مثل حافة الطاولة المشطوفة، فيظهر مكانها سطح جديد ضيق.</a:t>
             </a:r>
           </a:p>
         </p:txBody>
@@ -6410,30 +6480,47 @@
               <a:buNone/>
             </a:pPr>
             <a:r>
-              <a:rPr lang="ar-SA" sz="2000"/>
-              <a:t>الورق مصنوع من ألياف دقيقة، وأثناء تصنيعه تصطف هذه الألياف في اتجاه واحد، تمامًا كخطوط الخشب أو خيوط القماش. ولذلك ينثني الورق في اتجاه أسهل من الآخر.</a:t>
+              <a:rPr lang="ar-SA" sz="2000" b="1"/>
+              <a:t>ما هو؟ </a:t>
+            </a:r>
+            <a:r>
+              <a:rPr lang="ar-SA" sz="2000"/>
+              <a:t>الورق مصنوع من ألياف دقيقة جدًا، وأثناء تصنيعه في المصنع تصطف أغلب هذه الألياف في اتجاه واحد، مثل خطوط الخشب.</a:t>
+            </a:r>
+          </a:p>
+          <a:p>
+            <a:pPr marL="0" indent="0">
+              <a:buNone/>
+            </a:pPr>
+            <a:r>
+              <a:rPr lang="ar-SA" sz="2000" b="1"/>
+              <a:t>مثال للتوضيح: </a:t>
+            </a:r>
+            <a:r>
+              <a:rPr lang="ar-SA" sz="2000"/>
+              <a:t>تخيّلي حزمة من أعواد المعكرونة النيئة مصفوفة جنب بعض: لو ثنيناها على طول الأعواد تنثني بسهولة، ولو ثنيناها بعرض الأعواد تتكسر. والورق كذلك.</a:t>
             </a:r>
           </a:p>
           <a:p>
             <a:pPr/>
             <a:r>
               <a:rPr lang="ar-SA" sz="2000" b="1"/>
-              <a:t>الطي مع اتجاه الألياف: </a:t>
-            </a:r>
-            <a:r>
-              <a:rPr lang="ar-SA" sz="2000"/>
-              <a:t>الخط يكون نظيفًا ومستقيمًا.</a:t>
+              <a:t>خط الطي على طول الألياف: </a:t>
+            </a:r>
+            <a:r>
+              <a:rPr lang="ar-SA" sz="2000"/>
+              <a:t>الطي سهل والخط نظيف ومستقيم (الخط الأخضر في الرسم).</a:t>
             </a:r>
           </a:p>
           <a:p>
             <a:pPr/>
             <a:r>
               <a:rPr lang="ar-SA" sz="2000" b="1"/>
-              <a:t>الطي عكس اتجاه الألياف: </a:t>
-            </a:r>
-            <a:r>
-              <a:rPr lang="ar-SA" sz="2000"/>
-              <a:t>الطي أصعب، وقد تتشقق طبقة الطباعة على الخط، خاصة في الورق السميك.</a:t>
+              <a:t>خط الطي بعرض الألياف: </a:t>
+            </a:r>
+            <a:r>
+              <a:rPr lang="ar-SA" sz="2000"/>
+              <a:t>الطي أصعب، وقد تتشقق طبقة الطباعة على الخط (الخط الأحمر).</a:t>
             </a:r>
           </a:p>
           <a:p>
@@ -6442,11 +6529,11 @@
             </a:pPr>
             <a:r>
               <a:rPr lang="ar-SA" sz="2000" b="1"/>
-              <a:t>كيف أعرف اتجاه الألياف؟ </a:t>
-            </a:r>
-            <a:r>
-              <a:rPr lang="ar-SA" sz="2000"/>
-              <a:t>نثني قطعة صغيرة طولًا ثم عرضًا: الاتجاه الأسهل انثناءً هو اتجاه الألياف. أو نمزّقها: التمزق مع الألياف مستقيم، وعكسها متعرج.</a:t>
+              <a:t>كيف أعرف الاتجاه؟ </a:t>
+            </a:r>
+            <a:r>
+              <a:rPr lang="ar-SA" sz="2000"/>
+              <a:t>نقص قطعة صغيرة ونثنيها طولًا ثم عرضًا؛ الاتجاه الأسهل هو اتجاه الألياف.</a:t>
             </a:r>
           </a:p>
           <a:p>
@@ -6455,11 +6542,11 @@
             </a:pPr>
             <a:r>
               <a:rPr lang="ar-SA" sz="2000" b="1"/>
-              <a:t>في التصميم: </a:t>
-            </a:r>
-            <a:r>
-              <a:rPr lang="ar-SA" sz="2000"/>
-              <a:t>نضع الدايلاين على اللوح بحيث تكون أطول خطوط الطي وأهمها مع اتجاه الألياف.</a:t>
+              <a:t>عند التصميم: </a:t>
+            </a:r>
+            <a:r>
+              <a:rPr lang="ar-SA" sz="2000"/>
+              <a:t>نضع الدايلاين على اللوح بحيث تكون أطول خطوط الطي على طول الألياف.</a:t>
             </a:r>
           </a:p>
         </p:txBody>
@@ -7162,54 +7249,58 @@
               <a:buNone/>
             </a:pPr>
             <a:r>
-              <a:rPr lang="ar-SA" sz="2000"/>
-              <a:t>الورق المقوّى له سماكة حقيقية، فإذا رسمنا الدايلاين بالمقاسات النظرية تمامًا لن تنطبق الأوجه عند الطي، وستظهر فتحات أو انتفاخ عند الحواف. لذلك:</a:t>
+              <a:rPr lang="ar-SA" sz="2000" b="1"/>
+              <a:t>المشكلة: </a:t>
+            </a:r>
+            <a:r>
+              <a:rPr lang="ar-SA" sz="2000"/>
+              <a:t>الورق المقوّى له سماكة، مثل الكرتون. فإذا رسمنا كل الأوجه بنفس المقاس تمامًا، لن تنطبق عند الطي: يظهر انتفاخ أو فتحات عند الحواف.</a:t>
+            </a:r>
+          </a:p>
+          <a:p>
+            <a:pPr marL="0" indent="0">
+              <a:buNone/>
+            </a:pPr>
+            <a:r>
+              <a:rPr lang="ar-SA" sz="2000" b="1"/>
+              <a:t>مثال للتوضيح: </a:t>
+            </a:r>
+            <a:r>
+              <a:rPr lang="ar-SA" sz="2000"/>
+              <a:t>غلاف الكتاب أعرض قليلًا من صفحاته لأنه يلف حولها؛ ولو كان بنفس مقاسها لما أغلق. والعبوة كذلك.</a:t>
             </a:r>
           </a:p>
           <a:p>
             <a:pPr/>
             <a:r>
               <a:rPr lang="ar-SA" sz="2000" b="1"/>
-              <a:t>الألسنة التي تدخل للداخل: </a:t>
-            </a:r>
-            <a:r>
-              <a:rPr lang="ar-SA" sz="2000"/>
-              <a:t>تُصغَّر قليلًا (بقدر سماكة الورق تقريبًا) حتى تدخل دون أن تنفخ العبوة.</a:t>
+              <a:t>الجزء الذي يدخل للداخل (كلسان الإدخال): </a:t>
+            </a:r>
+            <a:r>
+              <a:rPr lang="ar-SA" sz="2000"/>
+              <a:t>نصغّره قليلًا، بقدر سماكة الورق تقريبًا، حتى يدخل بسهولة.</a:t>
             </a:r>
           </a:p>
           <a:p>
             <a:pPr/>
             <a:r>
               <a:rPr lang="ar-SA" sz="2000" b="1"/>
-              <a:t>الأوجه التي تلتف حول غيرها: </a:t>
-            </a:r>
-            <a:r>
-              <a:rPr lang="ar-SA" sz="2000"/>
-              <a:t>تُكبَّر قليلًا لأنها تحيط بسماكة الورق الذي تحتها.</a:t>
+              <a:t>الجزء الذي يلف من الخارج: </a:t>
+            </a:r>
+            <a:r>
+              <a:rPr lang="ar-SA" sz="2000"/>
+              <a:t>نكبّره قليلًا لأنه يحيط بسماكة الورق الذي تحته.</a:t>
             </a:r>
           </a:p>
           <a:p>
             <a:pPr/>
             <a:r>
               <a:rPr lang="ar-SA" sz="2000" b="1"/>
-              <a:t>زوايا الألسنة: </a:t>
-            </a:r>
-            <a:r>
-              <a:rPr lang="ar-SA" sz="2000"/>
-              <a:t>تُقص بميل حتى لا تحتك بخطوط الطي المجاورة.</a:t>
-            </a:r>
-          </a:p>
-          <a:p>
-            <a:pPr marL="0" indent="0">
-              <a:buNone/>
-            </a:pPr>
-            <a:r>
-              <a:rPr lang="ar-SA" sz="2000" b="1"/>
-              <a:t>قاعدة عملية: </a:t>
-            </a:r>
-            <a:r>
-              <a:rPr lang="ar-SA" sz="2000"/>
-              <a:t>كلما زادت سماكة الورق زادت الحاجة إلى هذا التعديل، ويُجرَّب الدايلاين دائمًا بنموذج قبل اعتماده.</a:t>
+              <a:t>أطراف الألسنة: </a:t>
+            </a:r>
+            <a:r>
+              <a:rPr lang="ar-SA" sz="2000"/>
+              <a:t>نقصها بميل حتى لا تحتك بخطوط الطي المجاورة.</a:t>
             </a:r>
           </a:p>
         </p:txBody>
@@ -7248,30 +7339,238 @@
           </a:p>
         </p:txBody>
       </p:sp>
-      <p:pic>
-        <p:nvPicPr>
-          <p:cNvPr id="16" name="Picture 15" descr="edge.png"/>
-          <p:cNvPicPr>
-            <a:picLocks noChangeAspect="1"/>
-          </p:cNvPicPr>
+      <p:sp>
+        <p:nvSpPr>
+          <p:cNvPr id="16" name="Rectangle 15"/>
+          <p:cNvSpPr/>
           <p:nvPr/>
-        </p:nvPicPr>
-        <p:blipFill>
-          <a:blip r:embed="rId3"/>
-          <a:stretch>
-            <a:fillRect/>
-          </a:stretch>
-        </p:blipFill>
-        <p:spPr>
-          <a:xfrm>
-            <a:off x="894997" y="1600200"/>
-            <a:ext cx="4062165" cy="4389120"/>
-          </a:xfrm>
-          <a:prstGeom prst="rect">
-            <a:avLst/>
-          </a:prstGeom>
-        </p:spPr>
-      </p:pic>
+        </p:nvSpPr>
+        <p:spPr>
+          <a:xfrm>
+            <a:off x="1371600" y="2148840"/>
+            <a:ext cx="3108960" cy="2377440"/>
+          </a:xfrm>
+          <a:prstGeom prst="rect">
+            <a:avLst/>
+          </a:prstGeom>
+          <a:noFill/>
+          <a:ln w="50800">
+            <a:solidFill>
+              <a:srgbClr val="000000"/>
+            </a:solidFill>
+          </a:ln>
+          <a:effectLst/>
+        </p:spPr>
+        <p:style>
+          <a:lnRef idx="1">
+            <a:schemeClr val="accent1"/>
+          </a:lnRef>
+          <a:fillRef idx="3">
+            <a:schemeClr val="accent1"/>
+          </a:fillRef>
+          <a:effectRef idx="2">
+            <a:schemeClr val="accent1"/>
+          </a:effectRef>
+          <a:fontRef idx="minor">
+            <a:schemeClr val="lt1"/>
+          </a:fontRef>
+        </p:style>
+        <p:txBody>
+          <a:bodyPr rtlCol="0" anchor="ctr"/>
+          <a:lstStyle/>
+          <a:p>
+            <a:pPr algn="ctr"/>
+          </a:p>
+        </p:txBody>
+      </p:sp>
+      <p:sp>
+        <p:nvSpPr>
+          <p:cNvPr id="17" name="Rectangle 16"/>
+          <p:cNvSpPr/>
+          <p:nvPr/>
+        </p:nvSpPr>
+        <p:spPr>
+          <a:xfrm>
+            <a:off x="1536192" y="2313432"/>
+            <a:ext cx="2779776" cy="2048256"/>
+          </a:xfrm>
+          <a:prstGeom prst="rect">
+            <a:avLst/>
+          </a:prstGeom>
+          <a:noFill/>
+          <a:ln w="50800">
+            <a:solidFill>
+              <a:srgbClr val="2E7D32"/>
+            </a:solidFill>
+          </a:ln>
+          <a:effectLst/>
+        </p:spPr>
+        <p:style>
+          <a:lnRef idx="1">
+            <a:schemeClr val="accent1"/>
+          </a:lnRef>
+          <a:fillRef idx="3">
+            <a:schemeClr val="accent1"/>
+          </a:fillRef>
+          <a:effectRef idx="2">
+            <a:schemeClr val="accent1"/>
+          </a:effectRef>
+          <a:fontRef idx="minor">
+            <a:schemeClr val="lt1"/>
+          </a:fontRef>
+        </p:style>
+        <p:txBody>
+          <a:bodyPr rtlCol="0" anchor="ctr"/>
+          <a:lstStyle/>
+          <a:p>
+            <a:pPr algn="ctr"/>
+          </a:p>
+        </p:txBody>
+      </p:sp>
+      <p:sp>
+        <p:nvSpPr>
+          <p:cNvPr id="18" name="TextBox 17"/>
+          <p:cNvSpPr txBox="1"/>
+          <p:nvPr/>
+        </p:nvSpPr>
+        <p:spPr>
+          <a:xfrm>
+            <a:off x="1371600" y="1691640"/>
+            <a:ext cx="3108960" cy="365760"/>
+          </a:xfrm>
+          <a:prstGeom prst="rect">
+            <a:avLst/>
+          </a:prstGeom>
+          <a:noFill/>
+        </p:spPr>
+        <p:txBody>
+          <a:bodyPr wrap="square" anchor="ctr">
+            <a:spAutoFit/>
+          </a:bodyPr>
+          <a:lstStyle/>
+          <a:p>
+            <a:pPr algn="ctr" rtl="1"/>
+            <a:r>
+              <a:rPr sz="1500" b="0" lang="ar-SA">
+                <a:solidFill>
+                  <a:srgbClr val="595959"/>
+                </a:solidFill>
+                <a:latin typeface="Sakkal Majalla"/>
+                <a:cs typeface="Sakkal Majalla"/>
+              </a:rPr>
+              <a:t>مقطع في عبوة من الأعلى</a:t>
+            </a:r>
+          </a:p>
+        </p:txBody>
+      </p:sp>
+      <p:sp>
+        <p:nvSpPr>
+          <p:cNvPr id="19" name="TextBox 18"/>
+          <p:cNvSpPr txBox="1"/>
+          <p:nvPr/>
+        </p:nvSpPr>
+        <p:spPr>
+          <a:xfrm>
+            <a:off x="457200" y="4709160"/>
+            <a:ext cx="4937760" cy="457200"/>
+          </a:xfrm>
+          <a:prstGeom prst="rect">
+            <a:avLst/>
+          </a:prstGeom>
+          <a:noFill/>
+        </p:spPr>
+        <p:txBody>
+          <a:bodyPr wrap="square" anchor="ctr">
+            <a:spAutoFit/>
+          </a:bodyPr>
+          <a:lstStyle/>
+          <a:p>
+            <a:pPr algn="ctr" rtl="1"/>
+            <a:r>
+              <a:rPr sz="1500" b="1" lang="ar-SA">
+                <a:solidFill>
+                  <a:srgbClr val="000000"/>
+                </a:solidFill>
+                <a:latin typeface="Sakkal Majalla"/>
+                <a:cs typeface="Sakkal Majalla"/>
+              </a:rPr>
+              <a:t>الخط الأسود: الجزء الخارجي، يلف حول غيره فيحتاج مقاسًا أكبر</a:t>
+            </a:r>
+          </a:p>
+        </p:txBody>
+      </p:sp>
+      <p:sp>
+        <p:nvSpPr>
+          <p:cNvPr id="20" name="TextBox 19"/>
+          <p:cNvSpPr txBox="1"/>
+          <p:nvPr/>
+        </p:nvSpPr>
+        <p:spPr>
+          <a:xfrm>
+            <a:off x="457200" y="5166360"/>
+            <a:ext cx="4937760" cy="457200"/>
+          </a:xfrm>
+          <a:prstGeom prst="rect">
+            <a:avLst/>
+          </a:prstGeom>
+          <a:noFill/>
+        </p:spPr>
+        <p:txBody>
+          <a:bodyPr wrap="square" anchor="ctr">
+            <a:spAutoFit/>
+          </a:bodyPr>
+          <a:lstStyle/>
+          <a:p>
+            <a:pPr algn="ctr" rtl="1"/>
+            <a:r>
+              <a:rPr sz="1500" b="1" lang="ar-SA">
+                <a:solidFill>
+                  <a:srgbClr val="2E7D32"/>
+                </a:solidFill>
+                <a:latin typeface="Sakkal Majalla"/>
+                <a:cs typeface="Sakkal Majalla"/>
+              </a:rPr>
+              <a:t>الخط الأخضر: الجزء الداخلي، يحتاج مقاسًا أصغر</a:t>
+            </a:r>
+          </a:p>
+        </p:txBody>
+      </p:sp>
+      <p:sp>
+        <p:nvSpPr>
+          <p:cNvPr id="21" name="TextBox 20"/>
+          <p:cNvSpPr txBox="1"/>
+          <p:nvPr/>
+        </p:nvSpPr>
+        <p:spPr>
+          <a:xfrm>
+            <a:off x="457200" y="5623560"/>
+            <a:ext cx="4937760" cy="457200"/>
+          </a:xfrm>
+          <a:prstGeom prst="rect">
+            <a:avLst/>
+          </a:prstGeom>
+          <a:noFill/>
+        </p:spPr>
+        <p:txBody>
+          <a:bodyPr wrap="square" anchor="ctr">
+            <a:spAutoFit/>
+          </a:bodyPr>
+          <a:lstStyle/>
+          <a:p>
+            <a:pPr algn="ctr" rtl="1"/>
+            <a:r>
+              <a:rPr sz="1500" b="0" lang="ar-SA">
+                <a:solidFill>
+                  <a:srgbClr val="595959"/>
+                </a:solidFill>
+                <a:latin typeface="Sakkal Majalla"/>
+                <a:cs typeface="Sakkal Majalla"/>
+              </a:rPr>
+              <a:t>الفرق بينهما = سماكة الورق</a:t>
+            </a:r>
+          </a:p>
+        </p:txBody>
+      </p:sp>
     </p:spTree>
   </p:cSld>
   <p:clrMapOvr>
@@ -7326,29 +7625,29 @@
             </a:pPr>
             <a:r>
               <a:rPr lang="ar-SA" sz="2000"/>
-              <a:t>خط الطي في الدايلاين يمكن أن يُطوى في اتجاهين، ولكل اتجاه اسم:</a:t>
+              <a:t>كل خط طي في الدايلاين يُطوى في أحد اتجاهين، ولكل اتجاه اسم ورمز:</a:t>
             </a:r>
           </a:p>
           <a:p>
             <a:pPr/>
             <a:r>
               <a:rPr lang="ar-SA" sz="2000" b="1"/>
-              <a:t>طيّة للداخل، وتُسمّى «الوادي» (Valley Fold): </a:t>
-            </a:r>
-            <a:r>
-              <a:rPr lang="ar-SA" sz="2000"/>
-              <a:t>يُطوى الورق نحونا فيتكوّن شكل حرف V، كالوادي بين جبلين.</a:t>
+              <a:t>طيّة الوادي (Valley Fold): </a:t>
+            </a:r>
+            <a:r>
+              <a:rPr lang="ar-SA" sz="2000"/>
+              <a:t>نضع الورقة على الطاولة ونرفع طرفيها للأعلى، فيبقى خط الطي في الأسفل، مثل كتاب مفتوح أو حرف V. رمزها خط متقطع.</a:t>
             </a:r>
           </a:p>
           <a:p>
             <a:pPr/>
             <a:r>
               <a:rPr lang="ar-SA" sz="2000" b="1"/>
-              <a:t>طيّة للخارج، وتُسمّى «الجبل» (Mountain Fold): </a:t>
-            </a:r>
-            <a:r>
-              <a:rPr lang="ar-SA" sz="2000"/>
-              <a:t>يُطوى الورق بعيدًا عنا فيتكوّن شكل حرف V مقلوب، كقمة الجبل.</a:t>
+              <a:t>طيّة الجبل (Mountain Fold): </a:t>
+            </a:r>
+            <a:r>
+              <a:rPr lang="ar-SA" sz="2000"/>
+              <a:t>نرفع خط الطي نفسه للأعلى وينزل الطرفان، مثل الخيمة أو سقف البيت أو حرف V مقلوب. رمزها شرطة ونقطة.</a:t>
             </a:r>
           </a:p>
           <a:p>
@@ -7356,21 +7655,12 @@
               <a:buNone/>
             </a:pPr>
             <a:r>
-              <a:rPr lang="ar-SA" sz="2000"/>
-              <a:t>ويُرسم كل نوع في الدايلاين برمز مختلف، ويُوضَّح الرمزان في مفتاح الرسم بجانب الدايلاين.</a:t>
-            </a:r>
-          </a:p>
-          <a:p>
-            <a:pPr marL="0" indent="0">
-              <a:buNone/>
-            </a:pPr>
-            <a:r>
-              <a:rPr lang="ar-SA" sz="2000" b="1"/>
-              <a:t>متى يهمنا ذلك؟ </a:t>
-            </a:r>
-            <a:r>
-              <a:rPr lang="ar-SA" sz="2000"/>
-              <a:t>في الأشكال المركّبة، مثل تقنية الضغط، تُطوى بعض الخطوط للداخل وبعضها للخارج، والخطأ في الاتجاه يفسد الشكل.</a:t>
+              <a:rPr lang="ar-SA" sz="2000" b="1"/>
+              <a:t>لماذا نهتم؟ </a:t>
+            </a:r>
+            <a:r>
+              <a:rPr lang="ar-SA" sz="2000"/>
+              <a:t>في أغلب الصناديق تُطوى كل الخطوط في اتجاه واحد. لكن في بعض الأشكال، مثل تقنية الضغط، يُطوى خط المنتصف عكس باقي الخطوط، ولو طُوي خطأً لن يتكوّن الشكل.</a:t>
             </a:r>
           </a:p>
         </p:txBody>
@@ -7510,7 +7800,7 @@
                 <a:latin typeface="Sakkal Majalla"/>
                 <a:cs typeface="Sakkal Majalla"/>
               </a:rPr>
-              <a:t>وادٍ: للداخل</a:t>
+              <a:t>وادٍ: مثل كتاب مفتوح</a:t>
             </a:r>
           </a:p>
         </p:txBody>
@@ -7616,7 +7906,7 @@
                 <a:latin typeface="Sakkal Majalla"/>
                 <a:cs typeface="Sakkal Majalla"/>
               </a:rPr>
-              <a:t>جبل: للخارج</a:t>
+              <a:t>جبل: مثل الخيمة</a:t>
             </a:r>
           </a:p>
         </p:txBody>
@@ -7819,7 +8109,7 @@
             </a:pPr>
             <a:r>
               <a:rPr lang="ar-SA" sz="2000"/>
-              <a:t>الفكرة: نبدأ بصندوق مكعّب عادي، ثم نغيّر شكله بطريقة مدروسة فنحصل على عبوة جديدة ومميزة. وهناك ثلاث طرق للتفكير:</a:t>
+              <a:t>نبدأ بصندوق مكعّب عادي، ونغيّر شكله بطريقة مدروسة لنحصل على عبوة جديدة. وللتفكير في ذلك ثلاث طرق:</a:t>
             </a:r>
           </a:p>
           <a:p>
@@ -7832,7 +8122,7 @@
             </a:r>
             <a:r>
               <a:rPr lang="ar-SA" sz="2000"/>
-              <a:t>نتخيل المكعّب قطعة خشب صلبة، ونقطع منها جزءًا: من سطح أو حافة أو زاوية.</a:t>
+              <a:t>نتخيل المكعّب قطعة صابون أو جبن صلبة، ونقطع منها جزءًا بالسكين: نميل السطح العلوي، أو نشطف حافة، أو نشطف زاوية. هنا يصغر الشكل ويظهر سطح جديد مكان القطع.</a:t>
             </a:r>
           </a:p>
           <a:p>
@@ -7845,7 +8135,7 @@
             </a:r>
             <a:r>
               <a:rPr lang="ar-SA" sz="2000"/>
-              <a:t>نتخيل المكعّب قطعة مطاط، فنشدّه أو نضغطه أو نلفّه، فيميل أو ينثني دون أن نقطع منه شيئًا.</a:t>
+              <a:t>نتخيل المكعّب إسفنجة: نشدّها فتميل، أو نضغطها فتنثني، أو نلفّها فتلتوي. هنا لا نقطع شيئًا، بل يتغير ميلان الأوجه فقط.</a:t>
             </a:r>
           </a:p>
           <a:p>
@@ -7858,7 +8148,7 @@
             </a:r>
             <a:r>
               <a:rPr lang="ar-SA" sz="2000"/>
-              <a:t>نجعل خطوط الطي منحنية بدل المستقيمة، فتتقوّس الأوجه.</a:t>
+              <a:t>نرسم خطوط الطي منحنية بدل المستقيمة، فتتقوّس الأوجه وتصبح العبوة ناعمة.</a:t>
             </a:r>
           </a:p>
           <a:p>
@@ -7867,7 +8157,7 @@
             </a:pPr>
             <a:r>
               <a:rPr lang="ar-SA" sz="2000"/>
-              <a:t>وبهذه الطرق الثلاث يمكن ابتكار عبوات جديدة دون معرفة متقدمة بالهندسة.</a:t>
+              <a:t>الصور يسارًا: مثال لكل طريقة بالترتيب.</a:t>
             </a:r>
           </a:p>
         </p:txBody>
@@ -8032,11 +8322,11 @@
             </a:pPr>
             <a:r>
               <a:rPr lang="ar-SA" sz="2000" b="1"/>
-              <a:t>الطريقة وعدد الأوجه: </a:t>
-            </a:r>
-            <a:r>
-              <a:rPr lang="ar-SA" sz="2000"/>
-              <a:t>القطع، ٦ أوجه</a:t>
+              <a:t>الفكرة ببساطة: </a:t>
+            </a:r>
+            <a:r>
+              <a:rPr lang="ar-SA" sz="2000"/>
+              <a:t>نتخيل مكعّب جبن ونقطع رأسه بالسكين قطعًا مائلًا، فيصبح السطح العلوي منحدرًا مثل السقف المائل.</a:t>
             </a:r>
           </a:p>
           <a:p>
@@ -8045,11 +8335,11 @@
             </a:pPr>
             <a:r>
               <a:rPr lang="ar-SA" sz="2000" b="1"/>
-              <a:t>الفكرة: </a:t>
-            </a:r>
-            <a:r>
-              <a:rPr lang="ar-SA" sz="2000"/>
-              <a:t>نقطع الجزء العلوي من المكعّب بخط مائل، فيصبح السطح العلوي منحدرًا بدل أن يكون مستويًا. ويمكن أن يكون الميل خفيفًا أو حادًا، أو مائلًا للأمام أو للخلف.</a:t>
+              <a:t>ماذا يتغير؟ </a:t>
+            </a:r>
+            <a:r>
+              <a:rPr lang="ar-SA" sz="2000"/>
+              <a:t>الجدار الأمامي يقصر والخلفي يبقى طويلًا، فيصبح الجداران الجانبيان شبه منحرف (ضلع أطول من الآخر)، ويصبح السطح العلوي مستطيلًا أطول من القاعدة لأنه مائل.</a:t>
             </a:r>
           </a:p>
           <a:p>
@@ -8058,24 +8348,11 @@
             </a:pPr>
             <a:r>
               <a:rPr lang="ar-SA" sz="2000" b="1"/>
-              <a:t>ماذا يتغير في الشكل؟ </a:t>
-            </a:r>
-            <a:r>
-              <a:rPr lang="ar-SA" sz="2000"/>
-              <a:t>الجانبان يصبحان على شكل شبه منحرف (أحد طرفيهما أعلى من الآخر)، والسطح العلوي يصبح مستطيلًا مائلًا أطول من القاعدة.</a:t>
-            </a:r>
-          </a:p>
-          <a:p>
-            <a:pPr marL="0" indent="0">
-              <a:buNone/>
-            </a:pPr>
-            <a:r>
-              <a:rPr lang="ar-SA" sz="2000" b="1"/>
               <a:t>الاستخدام في التغليف: </a:t>
             </a:r>
             <a:r>
               <a:rPr lang="ar-SA" sz="2000"/>
-              <a:t>السطح المائل يصبح واجهة لعرض الشعار أو المنتج، ويُقرأ بسهولة عندما ينظر المشتري إلى الرف.</a:t>
+              <a:t>السطح المائل يصبح واجهة للشعار أو المنتج تُقرأ بسهولة من فوق الرف.</a:t>
             </a:r>
           </a:p>
         </p:txBody>
@@ -8130,14 +8407,86 @@
         </p:blipFill>
         <p:spPr>
           <a:xfrm>
-            <a:off x="935439" y="1600200"/>
-            <a:ext cx="3981281" cy="4389120"/>
+            <a:off x="1287948" y="1600200"/>
+            <a:ext cx="3276262" cy="3611879"/>
           </a:xfrm>
           <a:prstGeom prst="rect">
             <a:avLst/>
           </a:prstGeom>
         </p:spPr>
       </p:pic>
+      <p:sp>
+        <p:nvSpPr>
+          <p:cNvPr id="17" name="TextBox 16"/>
+          <p:cNvSpPr txBox="1"/>
+          <p:nvPr/>
+        </p:nvSpPr>
+        <p:spPr>
+          <a:xfrm>
+            <a:off x="457200" y="5257800"/>
+            <a:ext cx="4937760" cy="347472"/>
+          </a:xfrm>
+          <a:prstGeom prst="rect">
+            <a:avLst/>
+          </a:prstGeom>
+          <a:noFill/>
+        </p:spPr>
+        <p:txBody>
+          <a:bodyPr wrap="square" anchor="ctr">
+            <a:spAutoFit/>
+          </a:bodyPr>
+          <a:lstStyle/>
+          <a:p>
+            <a:pPr algn="ctr" rtl="1"/>
+            <a:r>
+              <a:rPr sz="1500" b="0" lang="ar-SA">
+                <a:solidFill>
+                  <a:srgbClr val="595959"/>
+                </a:solidFill>
+                <a:latin typeface="Sakkal Majalla"/>
+                <a:cs typeface="Sakkal Majalla"/>
+              </a:rPr>
+              <a:t>في الصورة: الدايلاين، والعبوة بعد الطي</a:t>
+            </a:r>
+          </a:p>
+        </p:txBody>
+      </p:sp>
+      <p:sp>
+        <p:nvSpPr>
+          <p:cNvPr id="18" name="TextBox 17"/>
+          <p:cNvSpPr txBox="1"/>
+          <p:nvPr/>
+        </p:nvSpPr>
+        <p:spPr>
+          <a:xfrm>
+            <a:off x="457200" y="5605272"/>
+            <a:ext cx="4937760" cy="347472"/>
+          </a:xfrm>
+          <a:prstGeom prst="rect">
+            <a:avLst/>
+          </a:prstGeom>
+          <a:noFill/>
+        </p:spPr>
+        <p:txBody>
+          <a:bodyPr wrap="square" anchor="ctr">
+            <a:spAutoFit/>
+          </a:bodyPr>
+          <a:lstStyle/>
+          <a:p>
+            <a:pPr algn="ctr" rtl="1"/>
+            <a:r>
+              <a:rPr sz="1600" b="1" lang="ar-SA">
+                <a:solidFill>
+                  <a:srgbClr val="000000"/>
+                </a:solidFill>
+                <a:latin typeface="Sakkal Majalla"/>
+                <a:cs typeface="Sakkal Majalla"/>
+              </a:rPr>
+              <a:t>الطريقة: القطع، عدد الأوجه: ٦ أوجه</a:t>
+            </a:r>
+          </a:p>
+        </p:txBody>
+      </p:sp>
     </p:spTree>
   </p:cSld>
   <p:clrMapOvr>
@@ -8192,11 +8541,11 @@
             </a:pPr>
             <a:r>
               <a:rPr lang="ar-SA" sz="2000" b="1"/>
-              <a:t>الطريقة وعدد الأوجه: </a:t>
-            </a:r>
-            <a:r>
-              <a:rPr lang="ar-SA" sz="2000"/>
-              <a:t>القطع، ٧ أوجه</a:t>
+              <a:t>الفكرة ببساطة: </a:t>
+            </a:r>
+            <a:r>
+              <a:rPr lang="ar-SA" sz="2000"/>
+              <a:t>نقطع إحدى الحواف الحادة قطعًا مائلًا صغيرًا، مثل حافة الطاولة المشطوفة، فيظهر مكانها سطح جديد ضيق.</a:t>
             </a:r>
           </a:p>
           <a:p>
@@ -8205,11 +8554,11 @@
             </a:pPr>
             <a:r>
               <a:rPr lang="ar-SA" sz="2000" b="1"/>
-              <a:t>الفكرة: </a:t>
-            </a:r>
-            <a:r>
-              <a:rPr lang="ar-SA" sz="2000"/>
-              <a:t>نقطع إحدى الحواف الحادة بقطع مائل، فيظهر مكانها سطح جديد صغير، كما يُشطف طرف قطعة الخشب.</a:t>
+              <a:t>ماذا يتغير؟ </a:t>
+            </a:r>
+            <a:r>
+              <a:rPr lang="ar-SA" sz="2000"/>
+              <a:t>يُضاف في الدايلاين شريط مستطيل جديد بين الوجهين، ويُقص من كل جدار جانبي زاوية، فيصبح شكله خماسيًا.</a:t>
             </a:r>
           </a:p>
           <a:p>
@@ -8218,24 +8567,11 @@
             </a:pPr>
             <a:r>
               <a:rPr lang="ar-SA" sz="2000" b="1"/>
-              <a:t>ماذا يتغير في الشكل؟ </a:t>
-            </a:r>
-            <a:r>
-              <a:rPr lang="ar-SA" sz="2000"/>
-              <a:t>يزيد عدد الأوجه وجهًا واحدًا، ويصبح الجانبان خماسيين (مربع قُطع أحد أطرافه).</a:t>
-            </a:r>
-          </a:p>
-          <a:p>
-            <a:pPr marL="0" indent="0">
-              <a:buNone/>
-            </a:pPr>
-            <a:r>
-              <a:rPr lang="ar-SA" sz="2000" b="1"/>
               <a:t>الاستخدام في التغليف: </a:t>
             </a:r>
             <a:r>
               <a:rPr lang="ar-SA" sz="2000"/>
-              <a:t>السطح الجديد مساحة إضافية لمعلومة أو عنصر بصري، ويجعل العبوة أنعم، فيناسب علب الهدايا والعطور.</a:t>
+              <a:t>السطح الجديد مكان لمعلومة أو لون مميز، ويجعل العبوة أنعم، فيناسب علب الهدايا والعطور.</a:t>
             </a:r>
           </a:p>
         </p:txBody>
@@ -8290,14 +8626,86 @@
         </p:blipFill>
         <p:spPr>
           <a:xfrm>
-            <a:off x="894997" y="1600200"/>
-            <a:ext cx="4062165" cy="4389120"/>
+            <a:off x="1254668" y="1600200"/>
+            <a:ext cx="3342823" cy="3611879"/>
           </a:xfrm>
           <a:prstGeom prst="rect">
             <a:avLst/>
           </a:prstGeom>
         </p:spPr>
       </p:pic>
+      <p:sp>
+        <p:nvSpPr>
+          <p:cNvPr id="17" name="TextBox 16"/>
+          <p:cNvSpPr txBox="1"/>
+          <p:nvPr/>
+        </p:nvSpPr>
+        <p:spPr>
+          <a:xfrm>
+            <a:off x="457200" y="5257800"/>
+            <a:ext cx="4937760" cy="347472"/>
+          </a:xfrm>
+          <a:prstGeom prst="rect">
+            <a:avLst/>
+          </a:prstGeom>
+          <a:noFill/>
+        </p:spPr>
+        <p:txBody>
+          <a:bodyPr wrap="square" anchor="ctr">
+            <a:spAutoFit/>
+          </a:bodyPr>
+          <a:lstStyle/>
+          <a:p>
+            <a:pPr algn="ctr" rtl="1"/>
+            <a:r>
+              <a:rPr sz="1500" b="0" lang="ar-SA">
+                <a:solidFill>
+                  <a:srgbClr val="595959"/>
+                </a:solidFill>
+                <a:latin typeface="Sakkal Majalla"/>
+                <a:cs typeface="Sakkal Majalla"/>
+              </a:rPr>
+              <a:t>في الصورة: الدايلاين، والعبوة بعد الطي</a:t>
+            </a:r>
+          </a:p>
+        </p:txBody>
+      </p:sp>
+      <p:sp>
+        <p:nvSpPr>
+          <p:cNvPr id="18" name="TextBox 17"/>
+          <p:cNvSpPr txBox="1"/>
+          <p:nvPr/>
+        </p:nvSpPr>
+        <p:spPr>
+          <a:xfrm>
+            <a:off x="457200" y="5605272"/>
+            <a:ext cx="4937760" cy="347472"/>
+          </a:xfrm>
+          <a:prstGeom prst="rect">
+            <a:avLst/>
+          </a:prstGeom>
+          <a:noFill/>
+        </p:spPr>
+        <p:txBody>
+          <a:bodyPr wrap="square" anchor="ctr">
+            <a:spAutoFit/>
+          </a:bodyPr>
+          <a:lstStyle/>
+          <a:p>
+            <a:pPr algn="ctr" rtl="1"/>
+            <a:r>
+              <a:rPr sz="1600" b="1" lang="ar-SA">
+                <a:solidFill>
+                  <a:srgbClr val="000000"/>
+                </a:solidFill>
+                <a:latin typeface="Sakkal Majalla"/>
+                <a:cs typeface="Sakkal Majalla"/>
+              </a:rPr>
+              <a:t>الطريقة: القطع، عدد الأوجه: ٧ أوجه</a:t>
+            </a:r>
+          </a:p>
+        </p:txBody>
+      </p:sp>
     </p:spTree>
   </p:cSld>
   <p:clrMapOvr>
@@ -8352,11 +8760,11 @@
             </a:pPr>
             <a:r>
               <a:rPr lang="ar-SA" sz="2000" b="1"/>
-              <a:t>الطريقة وعدد الأوجه: </a:t>
-            </a:r>
-            <a:r>
-              <a:rPr lang="ar-SA" sz="2000"/>
-              <a:t>القطع، ٧ أوجه</a:t>
+              <a:t>الفكرة ببساطة: </a:t>
+            </a:r>
+            <a:r>
+              <a:rPr lang="ar-SA" sz="2000"/>
+              <a:t>نقطع رأس إحدى زوايا المكعّب بقطعة صغيرة، فيظهر مكانها سطح على شكل مثلث. وإذا قطعنا المسافة نفسها على الحواف الثلاث كان المثلث متساوي الأضلاع.</a:t>
             </a:r>
           </a:p>
           <a:p>
@@ -8365,11 +8773,11 @@
             </a:pPr>
             <a:r>
               <a:rPr lang="ar-SA" sz="2000" b="1"/>
-              <a:t>الفكرة: </a:t>
-            </a:r>
-            <a:r>
-              <a:rPr lang="ar-SA" sz="2000"/>
-              <a:t>نقطع إحدى زوايا المكعّب، فيظهر مكانها سطح جديد على شكل مثلث. وإذا قطعنا المسافة نفسها على الحواف الثلاث كان المثلث متساوي الأضلاع.</a:t>
+              <a:t>ماذا يتغير؟ </a:t>
+            </a:r>
+            <a:r>
+              <a:rPr lang="ar-SA" sz="2000"/>
+              <a:t>الأوجه الثلاثة التي كانت تلتقي عند الزاوية يُقص من كل منها زاوية صغيرة فتصبح خماسية، ويُضاف مثلث في الدايلاين.</a:t>
             </a:r>
           </a:p>
           <a:p>
@@ -8378,24 +8786,11 @@
             </a:pPr>
             <a:r>
               <a:rPr lang="ar-SA" sz="2000" b="1"/>
-              <a:t>ماذا يتغير في الشكل؟ </a:t>
-            </a:r>
-            <a:r>
-              <a:rPr lang="ar-SA" sz="2000"/>
-              <a:t>الأوجه الثلاثة التي كانت تلتقي عند الزاوية تصبح خماسية.</a:t>
-            </a:r>
-          </a:p>
-          <a:p>
-            <a:pPr marL="0" indent="0">
-              <a:buNone/>
-            </a:pPr>
-            <a:r>
-              <a:rPr lang="ar-SA" sz="2000" b="1"/>
               <a:t>الاستخدام في التغليف: </a:t>
             </a:r>
             <a:r>
               <a:rPr lang="ar-SA" sz="2000"/>
-              <a:t>المثلث مكان مميز للشعار، وإيقاف العبوة عليه يعطيها شكلًا نحتيًا يناسب الإصدارات الخاصة.</a:t>
+              <a:t>المثلث مكان مميز للشعار، ويمكن إيقاف العبوة عليه فتبدو كأنها منحوتة.</a:t>
             </a:r>
           </a:p>
         </p:txBody>
@@ -8450,14 +8845,86 @@
         </p:blipFill>
         <p:spPr>
           <a:xfrm>
-            <a:off x="457200" y="1834710"/>
-            <a:ext cx="4937760" cy="3920099"/>
+            <a:off x="651316" y="1600200"/>
+            <a:ext cx="4549526" cy="3611879"/>
           </a:xfrm>
           <a:prstGeom prst="rect">
             <a:avLst/>
           </a:prstGeom>
         </p:spPr>
       </p:pic>
+      <p:sp>
+        <p:nvSpPr>
+          <p:cNvPr id="17" name="TextBox 16"/>
+          <p:cNvSpPr txBox="1"/>
+          <p:nvPr/>
+        </p:nvSpPr>
+        <p:spPr>
+          <a:xfrm>
+            <a:off x="457200" y="5257800"/>
+            <a:ext cx="4937760" cy="347472"/>
+          </a:xfrm>
+          <a:prstGeom prst="rect">
+            <a:avLst/>
+          </a:prstGeom>
+          <a:noFill/>
+        </p:spPr>
+        <p:txBody>
+          <a:bodyPr wrap="square" anchor="ctr">
+            <a:spAutoFit/>
+          </a:bodyPr>
+          <a:lstStyle/>
+          <a:p>
+            <a:pPr algn="ctr" rtl="1"/>
+            <a:r>
+              <a:rPr sz="1500" b="0" lang="ar-SA">
+                <a:solidFill>
+                  <a:srgbClr val="595959"/>
+                </a:solidFill>
+                <a:latin typeface="Sakkal Majalla"/>
+                <a:cs typeface="Sakkal Majalla"/>
+              </a:rPr>
+              <a:t>في الصورة: الدايلاين، والعبوة بعد الطي</a:t>
+            </a:r>
+          </a:p>
+        </p:txBody>
+      </p:sp>
+      <p:sp>
+        <p:nvSpPr>
+          <p:cNvPr id="18" name="TextBox 17"/>
+          <p:cNvSpPr txBox="1"/>
+          <p:nvPr/>
+        </p:nvSpPr>
+        <p:spPr>
+          <a:xfrm>
+            <a:off x="457200" y="5605272"/>
+            <a:ext cx="4937760" cy="347472"/>
+          </a:xfrm>
+          <a:prstGeom prst="rect">
+            <a:avLst/>
+          </a:prstGeom>
+          <a:noFill/>
+        </p:spPr>
+        <p:txBody>
+          <a:bodyPr wrap="square" anchor="ctr">
+            <a:spAutoFit/>
+          </a:bodyPr>
+          <a:lstStyle/>
+          <a:p>
+            <a:pPr algn="ctr" rtl="1"/>
+            <a:r>
+              <a:rPr sz="1600" b="1" lang="ar-SA">
+                <a:solidFill>
+                  <a:srgbClr val="000000"/>
+                </a:solidFill>
+                <a:latin typeface="Sakkal Majalla"/>
+                <a:cs typeface="Sakkal Majalla"/>
+              </a:rPr>
+              <a:t>الطريقة: القطع، عدد الأوجه: ٧ أوجه</a:t>
+            </a:r>
+          </a:p>
+        </p:txBody>
+      </p:sp>
     </p:spTree>
   </p:cSld>
   <p:clrMapOvr>
@@ -8512,11 +8979,11 @@
             </a:pPr>
             <a:r>
               <a:rPr lang="ar-SA" sz="2000" b="1"/>
-              <a:t>الطريقة وعدد الأوجه: </a:t>
-            </a:r>
-            <a:r>
-              <a:rPr lang="ar-SA" sz="2000"/>
-              <a:t>الشدّ، ٦ أوجه</a:t>
+              <a:t>الفكرة ببساطة: </a:t>
+            </a:r>
+            <a:r>
+              <a:rPr lang="ar-SA" sz="2000"/>
+              <a:t>نتخيل المكعّب إسفنجة، نمسك الحافة العلوية من جهة والحافة السفلية من الجهة المقابلة ونشدّهما، فيميل الصندوق كله إلى جهة واحدة.</a:t>
             </a:r>
           </a:p>
           <a:p>
@@ -8525,11 +8992,11 @@
             </a:pPr>
             <a:r>
               <a:rPr lang="ar-SA" sz="2000" b="1"/>
-              <a:t>الفكرة: </a:t>
-            </a:r>
-            <a:r>
-              <a:rPr lang="ar-SA" sz="2000"/>
-              <a:t>نتخيل المكعّب مطاطًا، ونمسك حافتين متقابلتين ونشدّهما بعيدًا عن بعض، فيصبح صندوقًا مائلًا (Leaning Box).</a:t>
+              <a:t>ماذا يتغير؟ </a:t>
+            </a:r>
+            <a:r>
+              <a:rPr lang="ar-SA" sz="2000"/>
+              <a:t>الجداران الجانبيان يصبحان متوازيي أضلاع (مثل مربع مائل)، وباقي الأوجه تبقى مستطيلات.</a:t>
             </a:r>
           </a:p>
           <a:p>
@@ -8538,24 +9005,11 @@
             </a:pPr>
             <a:r>
               <a:rPr lang="ar-SA" sz="2000" b="1"/>
-              <a:t>ماذا يتغير في الشكل؟ </a:t>
-            </a:r>
-            <a:r>
-              <a:rPr lang="ar-SA" sz="2000"/>
-              <a:t>وجهان متقابلان يصبحان متوازيي أضلاع (مربع مائل)، والباقي مستطيلات.</a:t>
-            </a:r>
-          </a:p>
-          <a:p>
-            <a:pPr marL="0" indent="0">
-              <a:buNone/>
-            </a:pPr>
-            <a:r>
-              <a:rPr lang="ar-SA" sz="2000" b="1"/>
               <a:t>الاستخدام في التغليف: </a:t>
             </a:r>
             <a:r>
               <a:rPr lang="ar-SA" sz="2000"/>
-              <a:t>يوحي بالحركة والنشاط، فيناسب المنتجات الشبابية والرياضية.</a:t>
+              <a:t>شكل يوحي بالحركة والنشاط، يناسب المنتجات الشبابية والرياضية.</a:t>
             </a:r>
           </a:p>
         </p:txBody>
@@ -8610,14 +9064,86 @@
         </p:blipFill>
         <p:spPr>
           <a:xfrm>
-            <a:off x="917665" y="1600200"/>
-            <a:ext cx="4016828" cy="4389120"/>
+            <a:off x="1273322" y="1600199"/>
+            <a:ext cx="3305515" cy="3611880"/>
           </a:xfrm>
           <a:prstGeom prst="rect">
             <a:avLst/>
           </a:prstGeom>
         </p:spPr>
       </p:pic>
+      <p:sp>
+        <p:nvSpPr>
+          <p:cNvPr id="17" name="TextBox 16"/>
+          <p:cNvSpPr txBox="1"/>
+          <p:nvPr/>
+        </p:nvSpPr>
+        <p:spPr>
+          <a:xfrm>
+            <a:off x="457200" y="5257800"/>
+            <a:ext cx="4937760" cy="347472"/>
+          </a:xfrm>
+          <a:prstGeom prst="rect">
+            <a:avLst/>
+          </a:prstGeom>
+          <a:noFill/>
+        </p:spPr>
+        <p:txBody>
+          <a:bodyPr wrap="square" anchor="ctr">
+            <a:spAutoFit/>
+          </a:bodyPr>
+          <a:lstStyle/>
+          <a:p>
+            <a:pPr algn="ctr" rtl="1"/>
+            <a:r>
+              <a:rPr sz="1500" b="0" lang="ar-SA">
+                <a:solidFill>
+                  <a:srgbClr val="595959"/>
+                </a:solidFill>
+                <a:latin typeface="Sakkal Majalla"/>
+                <a:cs typeface="Sakkal Majalla"/>
+              </a:rPr>
+              <a:t>في الصورة: الدايلاين، والعبوة بعد الطي</a:t>
+            </a:r>
+          </a:p>
+        </p:txBody>
+      </p:sp>
+      <p:sp>
+        <p:nvSpPr>
+          <p:cNvPr id="18" name="TextBox 17"/>
+          <p:cNvSpPr txBox="1"/>
+          <p:nvPr/>
+        </p:nvSpPr>
+        <p:spPr>
+          <a:xfrm>
+            <a:off x="457200" y="5605272"/>
+            <a:ext cx="4937760" cy="347472"/>
+          </a:xfrm>
+          <a:prstGeom prst="rect">
+            <a:avLst/>
+          </a:prstGeom>
+          <a:noFill/>
+        </p:spPr>
+        <p:txBody>
+          <a:bodyPr wrap="square" anchor="ctr">
+            <a:spAutoFit/>
+          </a:bodyPr>
+          <a:lstStyle/>
+          <a:p>
+            <a:pPr algn="ctr" rtl="1"/>
+            <a:r>
+              <a:rPr sz="1600" b="1" lang="ar-SA">
+                <a:solidFill>
+                  <a:srgbClr val="000000"/>
+                </a:solidFill>
+                <a:latin typeface="Sakkal Majalla"/>
+                <a:cs typeface="Sakkal Majalla"/>
+              </a:rPr>
+              <a:t>الطريقة: الشدّ، عدد الأوجه: ٦ أوجه</a:t>
+            </a:r>
+          </a:p>
+        </p:txBody>
+      </p:sp>
     </p:spTree>
   </p:cSld>
   <p:clrMapOvr>
@@ -8672,11 +9198,11 @@
             </a:pPr>
             <a:r>
               <a:rPr lang="ar-SA" sz="2000" b="1"/>
-              <a:t>الطريقة وعدد الأوجه: </a:t>
-            </a:r>
-            <a:r>
-              <a:rPr lang="ar-SA" sz="2000"/>
-              <a:t>الشدّ، ٦ أوجه</a:t>
+              <a:t>الفكرة ببساطة: </a:t>
+            </a:r>
+            <a:r>
+              <a:rPr lang="ar-SA" sz="2000"/>
+              <a:t>نمسك الزاوية العلوية من جهة والزاوية السفلية المقابلة لها تمامًا (أبعد نقطتين في المكعّب) ونشدّهما، فيتمدد المكعّب على طول هذا الخط.</a:t>
             </a:r>
           </a:p>
           <a:p>
@@ -8685,11 +9211,11 @@
             </a:pPr>
             <a:r>
               <a:rPr lang="ar-SA" sz="2000" b="1"/>
-              <a:t>الفكرة: </a:t>
-            </a:r>
-            <a:r>
-              <a:rPr lang="ar-SA" sz="2000"/>
-              <a:t>نمسك زاويتين متقابلتين (أبعد نقطتين في المكعّب) ونشدّهما، فيصبح الشكل كالمعيّن الممدود.</a:t>
+              <a:t>ماذا يتغير؟ </a:t>
+            </a:r>
+            <a:r>
+              <a:rPr lang="ar-SA" sz="2000"/>
+              <a:t>كل الأوجه الستة تصبح معيّنات مثل شكل الماسة في ورق اللعب، ولا تبقى أي زاوية قائمة.</a:t>
             </a:r>
           </a:p>
           <a:p>
@@ -8698,24 +9224,11 @@
             </a:pPr>
             <a:r>
               <a:rPr lang="ar-SA" sz="2000" b="1"/>
-              <a:t>ماذا يتغير في الشكل؟ </a:t>
-            </a:r>
-            <a:r>
-              <a:rPr lang="ar-SA" sz="2000"/>
-              <a:t>كل الأوجه الستة تصبح معيّنات، ولا تبقى أي زاوية قائمة.</a:t>
-            </a:r>
-          </a:p>
-          <a:p>
-            <a:pPr marL="0" indent="0">
-              <a:buNone/>
-            </a:pPr>
-            <a:r>
-              <a:rPr lang="ar-SA" sz="2000" b="1"/>
               <a:t>الاستخدام في التغليف: </a:t>
             </a:r>
             <a:r>
               <a:rPr lang="ar-SA" sz="2000"/>
-              <a:t>شكل غريب يربك العين لأنها تبحث عن زوايا قائمة فلا تجدها، فيناسب المنتجات الفاخرة والفنية.</a:t>
+              <a:t>شكل يحيّر العين لأنها تتوقع زوايا قائمة فلا تجدها، فيناسب المنتجات الفاخرة والفنية.</a:t>
             </a:r>
           </a:p>
         </p:txBody>
@@ -8770,14 +9283,86 @@
         </p:blipFill>
         <p:spPr>
           <a:xfrm>
-            <a:off x="457200" y="1605887"/>
-            <a:ext cx="4937760" cy="4377745"/>
+            <a:off x="889118" y="1600199"/>
+            <a:ext cx="4073922" cy="3611880"/>
           </a:xfrm>
           <a:prstGeom prst="rect">
             <a:avLst/>
           </a:prstGeom>
         </p:spPr>
       </p:pic>
+      <p:sp>
+        <p:nvSpPr>
+          <p:cNvPr id="17" name="TextBox 16"/>
+          <p:cNvSpPr txBox="1"/>
+          <p:nvPr/>
+        </p:nvSpPr>
+        <p:spPr>
+          <a:xfrm>
+            <a:off x="457200" y="5257800"/>
+            <a:ext cx="4937760" cy="347472"/>
+          </a:xfrm>
+          <a:prstGeom prst="rect">
+            <a:avLst/>
+          </a:prstGeom>
+          <a:noFill/>
+        </p:spPr>
+        <p:txBody>
+          <a:bodyPr wrap="square" anchor="ctr">
+            <a:spAutoFit/>
+          </a:bodyPr>
+          <a:lstStyle/>
+          <a:p>
+            <a:pPr algn="ctr" rtl="1"/>
+            <a:r>
+              <a:rPr sz="1500" b="0" lang="ar-SA">
+                <a:solidFill>
+                  <a:srgbClr val="595959"/>
+                </a:solidFill>
+                <a:latin typeface="Sakkal Majalla"/>
+                <a:cs typeface="Sakkal Majalla"/>
+              </a:rPr>
+              <a:t>في الصورة: الدايلاين، والعبوة بعد الطي</a:t>
+            </a:r>
+          </a:p>
+        </p:txBody>
+      </p:sp>
+      <p:sp>
+        <p:nvSpPr>
+          <p:cNvPr id="18" name="TextBox 17"/>
+          <p:cNvSpPr txBox="1"/>
+          <p:nvPr/>
+        </p:nvSpPr>
+        <p:spPr>
+          <a:xfrm>
+            <a:off x="457200" y="5605272"/>
+            <a:ext cx="4937760" cy="347472"/>
+          </a:xfrm>
+          <a:prstGeom prst="rect">
+            <a:avLst/>
+          </a:prstGeom>
+          <a:noFill/>
+        </p:spPr>
+        <p:txBody>
+          <a:bodyPr wrap="square" anchor="ctr">
+            <a:spAutoFit/>
+          </a:bodyPr>
+          <a:lstStyle/>
+          <a:p>
+            <a:pPr algn="ctr" rtl="1"/>
+            <a:r>
+              <a:rPr sz="1600" b="1" lang="ar-SA">
+                <a:solidFill>
+                  <a:srgbClr val="000000"/>
+                </a:solidFill>
+                <a:latin typeface="Sakkal Majalla"/>
+                <a:cs typeface="Sakkal Majalla"/>
+              </a:rPr>
+              <a:t>الطريقة: الشدّ، عدد الأوجه: ٦ أوجه</a:t>
+            </a:r>
+          </a:p>
+        </p:txBody>
+      </p:sp>
     </p:spTree>
   </p:cSld>
   <p:clrMapOvr>
@@ -8943,11 +9528,11 @@
             </a:pPr>
             <a:r>
               <a:rPr lang="ar-SA" sz="2000" b="1"/>
-              <a:t>الطريقة وعدد الأوجه: </a:t>
-            </a:r>
-            <a:r>
-              <a:rPr lang="ar-SA" sz="2000"/>
-              <a:t>اللفّ، ٦ أوجه</a:t>
+              <a:t>الفكرة ببساطة: </a:t>
+            </a:r>
+            <a:r>
+              <a:rPr lang="ar-SA" sz="2000"/>
+              <a:t>الوجهان المقصودان هما الغطاء والقاعدة. نثبّت القاعدة ونلفّ الغطاء قليلًا، كما نفتح غطاء البرطمان، فتميل الجدران الأربعة.</a:t>
             </a:r>
           </a:p>
           <a:p>
@@ -8956,11 +9541,11 @@
             </a:pPr>
             <a:r>
               <a:rPr lang="ar-SA" sz="2000" b="1"/>
-              <a:t>الفكرة: </a:t>
-            </a:r>
-            <a:r>
-              <a:rPr lang="ar-SA" sz="2000"/>
-              <a:t>الوجهان المقصودان هما الغطاء (الوجه العلوي) والقاعدة (الوجه السفلي). نثبّت القاعدة ونلفّ الغطاء لفّة خفيفة، كما نفتح غطاء البرطمان، فتميل الجدران الأربعة.</a:t>
+              <a:t>ماذا يتغير؟ </a:t>
+            </a:r>
+            <a:r>
+              <a:rPr lang="ar-SA" sz="2000"/>
+              <a:t>يبقى الغطاء والقاعدة مربعين، وتصبح الجدران متوازيات أضلاع مائلة في الاتجاه نفسه. وأفضل ميل أن ينحرف الجدار ١٠ درجات فقط عن الوقوف المستقيم (زاوية ٨٠°)، وأكثر من ٢٠ درجة (أقل من ٧٠°) يجعل الشكل مبالغًا فيه.</a:t>
             </a:r>
           </a:p>
           <a:p>
@@ -8969,24 +9554,11 @@
             </a:pPr>
             <a:r>
               <a:rPr lang="ar-SA" sz="2000" b="1"/>
-              <a:t>ماذا يتغير في الشكل؟ </a:t>
-            </a:r>
-            <a:r>
-              <a:rPr lang="ar-SA" sz="2000"/>
-              <a:t>يبقى الغطاء والقاعدة مربعين، وتصبح الجدران الأربعة متوازيات أضلاع مائلة في الاتجاه نفسه. وأفضل ميل للجدار ٨٠° (أي أقل من القائمة بـ ١٠° فقط)، وإذا قلّ عن ٧٠° يصبح الشكل مبالغًا فيه.</a:t>
-            </a:r>
-          </a:p>
-          <a:p>
-            <a:pPr marL="0" indent="0">
-              <a:buNone/>
-            </a:pPr>
-            <a:r>
-              <a:rPr lang="ar-SA" sz="2000" b="1"/>
               <a:t>الاستخدام في التغليف: </a:t>
             </a:r>
             <a:r>
               <a:rPr lang="ar-SA" sz="2000"/>
-              <a:t>تغيير خفيف لا يُلاحظ من أول نظرة ثم يكتشفه المشتري، فيناسب العلامات الراقية.</a:t>
+              <a:t>تغيير خفيف لا يُلاحظ من أول نظرة، ثم يكتشفه المشتري، فيناسب العلامات الراقية.</a:t>
             </a:r>
           </a:p>
         </p:txBody>
@@ -9041,14 +9613,86 @@
         </p:blipFill>
         <p:spPr>
           <a:xfrm>
-            <a:off x="712624" y="1600200"/>
-            <a:ext cx="4426910" cy="4389120"/>
+            <a:off x="1104590" y="1600200"/>
+            <a:ext cx="3642978" cy="3611879"/>
           </a:xfrm>
           <a:prstGeom prst="rect">
             <a:avLst/>
           </a:prstGeom>
         </p:spPr>
       </p:pic>
+      <p:sp>
+        <p:nvSpPr>
+          <p:cNvPr id="17" name="TextBox 16"/>
+          <p:cNvSpPr txBox="1"/>
+          <p:nvPr/>
+        </p:nvSpPr>
+        <p:spPr>
+          <a:xfrm>
+            <a:off x="457200" y="5257800"/>
+            <a:ext cx="4937760" cy="347472"/>
+          </a:xfrm>
+          <a:prstGeom prst="rect">
+            <a:avLst/>
+          </a:prstGeom>
+          <a:noFill/>
+        </p:spPr>
+        <p:txBody>
+          <a:bodyPr wrap="square" anchor="ctr">
+            <a:spAutoFit/>
+          </a:bodyPr>
+          <a:lstStyle/>
+          <a:p>
+            <a:pPr algn="ctr" rtl="1"/>
+            <a:r>
+              <a:rPr sz="1500" b="0" lang="ar-SA">
+                <a:solidFill>
+                  <a:srgbClr val="595959"/>
+                </a:solidFill>
+                <a:latin typeface="Sakkal Majalla"/>
+                <a:cs typeface="Sakkal Majalla"/>
+              </a:rPr>
+              <a:t>في الصورة: الدايلاين، والعبوة بعد الطي</a:t>
+            </a:r>
+          </a:p>
+        </p:txBody>
+      </p:sp>
+      <p:sp>
+        <p:nvSpPr>
+          <p:cNvPr id="18" name="TextBox 17"/>
+          <p:cNvSpPr txBox="1"/>
+          <p:nvPr/>
+        </p:nvSpPr>
+        <p:spPr>
+          <a:xfrm>
+            <a:off x="457200" y="5605272"/>
+            <a:ext cx="4937760" cy="347472"/>
+          </a:xfrm>
+          <a:prstGeom prst="rect">
+            <a:avLst/>
+          </a:prstGeom>
+          <a:noFill/>
+        </p:spPr>
+        <p:txBody>
+          <a:bodyPr wrap="square" anchor="ctr">
+            <a:spAutoFit/>
+          </a:bodyPr>
+          <a:lstStyle/>
+          <a:p>
+            <a:pPr algn="ctr" rtl="1"/>
+            <a:r>
+              <a:rPr sz="1600" b="1" lang="ar-SA">
+                <a:solidFill>
+                  <a:srgbClr val="000000"/>
+                </a:solidFill>
+                <a:latin typeface="Sakkal Majalla"/>
+                <a:cs typeface="Sakkal Majalla"/>
+              </a:rPr>
+              <a:t>الطريقة: اللفّ، عدد الأوجه: ٦ أوجه</a:t>
+            </a:r>
+          </a:p>
+        </p:txBody>
+      </p:sp>
     </p:spTree>
   </p:cSld>
   <p:clrMapOvr>
@@ -9103,11 +9747,11 @@
             </a:pPr>
             <a:r>
               <a:rPr lang="ar-SA" sz="2000" b="1"/>
-              <a:t>الطريقة وعدد الأوجه: </a:t>
-            </a:r>
-            <a:r>
-              <a:rPr lang="ar-SA" sz="2000"/>
-              <a:t>اللفّ، ١٠ أوجه</a:t>
+              <a:t>الفكرة ببساطة: </a:t>
+            </a:r>
+            <a:r>
+              <a:rPr lang="ar-SA" sz="2000"/>
+              <a:t>نكمل لفّ الغطاء أكثر حتى تقع كل زاوية من الغطاء فوق منتصف حافة من حواف القاعدة، ثم نصل كل زاوية بالزاويتين القريبتين منها بخطوط طي.</a:t>
             </a:r>
           </a:p>
           <a:p>
@@ -9116,24 +9760,11 @@
             </a:pPr>
             <a:r>
               <a:rPr lang="ar-SA" sz="2000" b="1"/>
-              <a:t>الفكرة: </a:t>
-            </a:r>
-            <a:r>
-              <a:rPr lang="ar-SA" sz="2000"/>
-              <a:t>نكمل لفّ الغطاء أكثر حتى تصبح كل زاوية في الغطاء فوق منتصف حافة القاعدة، ثم نصل الزوايا بخطوط طي.</a:t>
-            </a:r>
-          </a:p>
-          <a:p>
-            <a:pPr marL="0" indent="0">
-              <a:buNone/>
-            </a:pPr>
-            <a:r>
-              <a:rPr lang="ar-SA" sz="2000" b="1"/>
-              <a:t>ماذا يتغير في الشكل؟ </a:t>
-            </a:r>
-            <a:r>
-              <a:rPr lang="ar-SA" sz="2000"/>
-              <a:t>تتحول الجدران إلى ثمانية مثلثات، مع الغطاء والقاعدة المربعين. ويحتاج ألسنة ذات حافة مثنية (Flanged Tabs) لتثبيت الغطاء والقاعدة.</a:t>
+              <a:t>ماذا يتغير؟ </a:t>
+            </a:r>
+            <a:r>
+              <a:rPr lang="ar-SA" sz="2000"/>
+              <a:t>تتحول الجدران إلى ثمانية مثلثات حول العبوة: أربعة رأسها للأعلى وأربعة رأسها للأسفل، وفي الدايلاين تظهر كشريط من مثلثات متعاكسة. ويحتاج ألسنة بحافة مثنية (Flanged Tabs) لتثبيت الغطاء والقاعدة.</a:t>
             </a:r>
           </a:p>
           <a:p>
@@ -9201,14 +9832,86 @@
         </p:blipFill>
         <p:spPr>
           <a:xfrm>
-            <a:off x="457200" y="1732341"/>
-            <a:ext cx="4937760" cy="4124836"/>
+            <a:off x="764224" y="1600200"/>
+            <a:ext cx="4323710" cy="3611879"/>
           </a:xfrm>
           <a:prstGeom prst="rect">
             <a:avLst/>
           </a:prstGeom>
         </p:spPr>
       </p:pic>
+      <p:sp>
+        <p:nvSpPr>
+          <p:cNvPr id="17" name="TextBox 16"/>
+          <p:cNvSpPr txBox="1"/>
+          <p:nvPr/>
+        </p:nvSpPr>
+        <p:spPr>
+          <a:xfrm>
+            <a:off x="457200" y="5257800"/>
+            <a:ext cx="4937760" cy="347472"/>
+          </a:xfrm>
+          <a:prstGeom prst="rect">
+            <a:avLst/>
+          </a:prstGeom>
+          <a:noFill/>
+        </p:spPr>
+        <p:txBody>
+          <a:bodyPr wrap="square" anchor="ctr">
+            <a:spAutoFit/>
+          </a:bodyPr>
+          <a:lstStyle/>
+          <a:p>
+            <a:pPr algn="ctr" rtl="1"/>
+            <a:r>
+              <a:rPr sz="1500" b="0" lang="ar-SA">
+                <a:solidFill>
+                  <a:srgbClr val="595959"/>
+                </a:solidFill>
+                <a:latin typeface="Sakkal Majalla"/>
+                <a:cs typeface="Sakkal Majalla"/>
+              </a:rPr>
+              <a:t>في الصورة: الدايلاين، والعبوة بعد الطي</a:t>
+            </a:r>
+          </a:p>
+        </p:txBody>
+      </p:sp>
+      <p:sp>
+        <p:nvSpPr>
+          <p:cNvPr id="18" name="TextBox 17"/>
+          <p:cNvSpPr txBox="1"/>
+          <p:nvPr/>
+        </p:nvSpPr>
+        <p:spPr>
+          <a:xfrm>
+            <a:off x="457200" y="5605272"/>
+            <a:ext cx="4937760" cy="347472"/>
+          </a:xfrm>
+          <a:prstGeom prst="rect">
+            <a:avLst/>
+          </a:prstGeom>
+          <a:noFill/>
+        </p:spPr>
+        <p:txBody>
+          <a:bodyPr wrap="square" anchor="ctr">
+            <a:spAutoFit/>
+          </a:bodyPr>
+          <a:lstStyle/>
+          <a:p>
+            <a:pPr algn="ctr" rtl="1"/>
+            <a:r>
+              <a:rPr sz="1600" b="1" lang="ar-SA">
+                <a:solidFill>
+                  <a:srgbClr val="000000"/>
+                </a:solidFill>
+                <a:latin typeface="Sakkal Majalla"/>
+                <a:cs typeface="Sakkal Majalla"/>
+              </a:rPr>
+              <a:t>الطريقة: اللفّ، عدد الأوجه: ١٠ أوجه</a:t>
+            </a:r>
+          </a:p>
+        </p:txBody>
+      </p:sp>
     </p:spTree>
   </p:cSld>
   <p:clrMapOvr>
@@ -9263,11 +9966,11 @@
             </a:pPr>
             <a:r>
               <a:rPr lang="ar-SA" sz="2000" b="1"/>
-              <a:t>الطريقة وعدد الأوجه: </a:t>
-            </a:r>
-            <a:r>
-              <a:rPr lang="ar-SA" sz="2000"/>
-              <a:t>الضغط، ٦ أوجه</a:t>
+              <a:t>الفكرة ببساطة: </a:t>
+            </a:r>
+            <a:r>
+              <a:rPr lang="ar-SA" sz="2000"/>
+              <a:t>نتخيل علبة إسفنجية نضغطها من فوق بكفّ اليد، فتنثني جدرانها من المنتصف. والشكل في الصورة تبسيط لهذه الفكرة بخطوط طي مستقيمة.</a:t>
             </a:r>
           </a:p>
           <a:p>
@@ -9276,11 +9979,11 @@
             </a:pPr>
             <a:r>
               <a:rPr lang="ar-SA" sz="2000" b="1"/>
-              <a:t>الفكرة: </a:t>
-            </a:r>
-            <a:r>
-              <a:rPr lang="ar-SA" sz="2000"/>
-              <a:t>نضغط الغطاء نحو القاعدة كأننا نضغط علبة مطاطية، فتنثني الجدران عند منتصفها. والشكل المعروض تبسيط لهذه الفكرة بخطوط طي مستقيمة.</a:t>
+              <a:t>ماذا يتغير؟ </a:t>
+            </a:r>
+            <a:r>
+              <a:rPr lang="ar-SA" sz="2000"/>
+              <a:t>يُضاف لكل جدار خط طي أفقي في منتصفه، وتصبح الخطوط بين الجدران منكسرة بدل المستقيمة. ورغم أن الشكل يبدو مضغوطًا، فإن كمية الورق نفسها كالمكعّب العادي.</a:t>
             </a:r>
           </a:p>
           <a:p>
@@ -9289,24 +9992,11 @@
             </a:pPr>
             <a:r>
               <a:rPr lang="ar-SA" sz="2000" b="1"/>
-              <a:t>ماذا يتغير في الشكل؟ </a:t>
-            </a:r>
-            <a:r>
-              <a:rPr lang="ar-SA" sz="2000"/>
-              <a:t>كل جدار يُقسم بخط طي أفقي في منتصفه وينثني عنده. ورغم أن الشكل يبدو مضغوطًا، فإن كمية الورق نفسها كالمكعّب العادي.</a:t>
-            </a:r>
-          </a:p>
-          <a:p>
-            <a:pPr marL="0" indent="0">
-              <a:buNone/>
-            </a:pPr>
-            <a:r>
-              <a:rPr lang="ar-SA" sz="2000" b="1"/>
               <a:t>الاستخدام في التغليف: </a:t>
             </a:r>
             <a:r>
               <a:rPr lang="ar-SA" sz="2000"/>
-              <a:t>شكل مرح يوحي بالليونة، فيناسب المنتجات الناعمة ومنتجات الأطفال.</a:t>
+              <a:t>شكل مرح يوحي بالليونة، يناسب المنتجات الناعمة ومنتجات الأطفال.</a:t>
             </a:r>
           </a:p>
         </p:txBody>
@@ -9361,14 +10051,86 @@
         </p:blipFill>
         <p:spPr>
           <a:xfrm>
-            <a:off x="720762" y="1600200"/>
-            <a:ext cx="4410635" cy="4389120"/>
+            <a:off x="1111287" y="1600200"/>
+            <a:ext cx="3629585" cy="3611879"/>
           </a:xfrm>
           <a:prstGeom prst="rect">
             <a:avLst/>
           </a:prstGeom>
         </p:spPr>
       </p:pic>
+      <p:sp>
+        <p:nvSpPr>
+          <p:cNvPr id="17" name="TextBox 16"/>
+          <p:cNvSpPr txBox="1"/>
+          <p:nvPr/>
+        </p:nvSpPr>
+        <p:spPr>
+          <a:xfrm>
+            <a:off x="457200" y="5257800"/>
+            <a:ext cx="4937760" cy="347472"/>
+          </a:xfrm>
+          <a:prstGeom prst="rect">
+            <a:avLst/>
+          </a:prstGeom>
+          <a:noFill/>
+        </p:spPr>
+        <p:txBody>
+          <a:bodyPr wrap="square" anchor="ctr">
+            <a:spAutoFit/>
+          </a:bodyPr>
+          <a:lstStyle/>
+          <a:p>
+            <a:pPr algn="ctr" rtl="1"/>
+            <a:r>
+              <a:rPr sz="1500" b="0" lang="ar-SA">
+                <a:solidFill>
+                  <a:srgbClr val="595959"/>
+                </a:solidFill>
+                <a:latin typeface="Sakkal Majalla"/>
+                <a:cs typeface="Sakkal Majalla"/>
+              </a:rPr>
+              <a:t>في الصورة: الدايلاين، والعبوة بعد الطي</a:t>
+            </a:r>
+          </a:p>
+        </p:txBody>
+      </p:sp>
+      <p:sp>
+        <p:nvSpPr>
+          <p:cNvPr id="18" name="TextBox 17"/>
+          <p:cNvSpPr txBox="1"/>
+          <p:nvPr/>
+        </p:nvSpPr>
+        <p:spPr>
+          <a:xfrm>
+            <a:off x="457200" y="5605272"/>
+            <a:ext cx="4937760" cy="347472"/>
+          </a:xfrm>
+          <a:prstGeom prst="rect">
+            <a:avLst/>
+          </a:prstGeom>
+          <a:noFill/>
+        </p:spPr>
+        <p:txBody>
+          <a:bodyPr wrap="square" anchor="ctr">
+            <a:spAutoFit/>
+          </a:bodyPr>
+          <a:lstStyle/>
+          <a:p>
+            <a:pPr algn="ctr" rtl="1"/>
+            <a:r>
+              <a:rPr sz="1600" b="1" lang="ar-SA">
+                <a:solidFill>
+                  <a:srgbClr val="000000"/>
+                </a:solidFill>
+                <a:latin typeface="Sakkal Majalla"/>
+                <a:cs typeface="Sakkal Majalla"/>
+              </a:rPr>
+              <a:t>الطريقة: الضغط، عدد الأوجه: ٦ أوجه</a:t>
+            </a:r>
+          </a:p>
+        </p:txBody>
+      </p:sp>
     </p:spTree>
   </p:cSld>
   <p:clrMapOvr>
@@ -11858,7 +12620,7 @@
             </a:r>
             <a:r>
               <a:rPr lang="ar-SA" sz="2000"/>
-              <a:t>هل يصلح الدايلاين لقالب القص والتخديد؟</a:t>
+              <a:t>هل يصلح الدايلاين لقالب القص والتكسير؟</a:t>
             </a:r>
           </a:p>
           <a:p>
@@ -12726,11 +13488,11 @@
             </a:pPr>
             <a:r>
               <a:rPr lang="ar-SA" sz="2000" b="1"/>
-              <a:t>٣. اتجاه القص: </a:t>
-            </a:r>
-            <a:r>
-              <a:rPr lang="ar-SA" sz="2000"/>
-              <a:t>تُسحب الشفرة على طول المسطرة بضغط خفيف، ويُكرَّر القص مرتين أو ثلاثًا بدل الضغط القوي مرة واحدة.</a:t>
+              <a:t>٣. طريقة القص: </a:t>
+            </a:r>
+            <a:r>
+              <a:rPr lang="ar-SA" sz="2000"/>
+              <a:t>يُقص الخط بسحبة واحدة ثابتة وضغط متساوٍ من أوله إلى آخره؛ فتكرار القص على الخط نفسه قد يُخرج الشفرة عن مسارها ويترك حافة متعرجة.</a:t>
             </a:r>
           </a:p>
           <a:p>
@@ -12873,7 +13635,7 @@
             </a:r>
             <a:r>
               <a:rPr lang="ar-SA" sz="2000"/>
-              <a:t>أداة مسطحة يُمرَّر طرفها على الخط. تضغط جيدًا، لكن الخط يبعد ١–٢ مم عن المسطرة.</a:t>
+              <a:t>أداة يستخدمها مجلّدو الكتب: قطعة مسطحة من العظم أو البلاستيك بطرف مدبب أملس، نمرّره على الخط بجانب المسطرة. عيبها أن طرفها سميك، فيبعد الخط عن المسطرة ١–٢ مم.</a:t>
             </a:r>
           </a:p>
           <a:p>
@@ -12884,7 +13646,7 @@
             </a:r>
             <a:r>
               <a:rPr lang="ar-SA" sz="2000"/>
-              <a:t>الكرة في رأسه تضغط الخط، وفيه العيب نفسه.</a:t>
+              <a:t>في رأسه كرة معدنية صغيرة تخرج الحبر؛ إذا انتهى الحبر نمرّر رأسه على الخط فتضغط الكرة الورق دون أن تكتب. وعيبه عيب عظمة الطي نفسه.</a:t>
             </a:r>
           </a:p>
           <a:p>
@@ -13003,7 +13765,7 @@
             </a:pPr>
             <a:r>
               <a:rPr lang="ar-SA" sz="2000" b="1"/>
-              <a:t>الصلة بالإنتاج الصناعي:</a:t>
+              <a:t>الصلة بالإنتاج الصناعي: قالب القص والتكسير (Die-cut)</a:t>
             </a:r>
           </a:p>
           <a:p>
@@ -13011,12 +13773,8 @@
               <a:buNone/>
             </a:pPr>
             <a:r>
-              <a:rPr lang="ar-SA" sz="2000" b="1"/>
-              <a:t>قالب القص والتخديد (Die-cut): </a:t>
-            </a:r>
-            <a:r>
-              <a:rPr lang="ar-SA" sz="2000"/>
-              <a:t>في المصانع لا تُقص العبوات يدويًا، بل بقالب: لوح خشبي مثبّت عليه شفرات حادة في أماكن القص، ومساطر معدنية غير حادة في أماكن الطي. يُكبس القالب على الورق مرة واحدة فيقص ويجهّز خطوط الطي في اللحظة نفسها.</a:t>
+              <a:rPr lang="ar-SA" sz="2000"/>
+              <a:t>في المصانع لا تُقص آلاف العبوات باليد، بل بقالب يقص العبوة ويجهّز خطوط طيّها في ضغطة واحدة.</a:t>
             </a:r>
           </a:p>
           <a:p>
@@ -13025,33 +13783,11 @@
             </a:pPr>
             <a:r>
               <a:rPr lang="ar-SA" sz="2000" b="1"/>
-              <a:t>الدايلاين (Die-line): </a:t>
-            </a:r>
-            <a:r>
-              <a:rPr lang="ar-SA" sz="2000"/>
-              <a:t>هو الرسم المسطّح للعبوة الذي يُصنع القالب على أساسه، ويُرسم فيه نوعان من الخطوط:</a:t>
-            </a:r>
-          </a:p>
-          <a:p>
-            <a:pPr/>
-            <a:r>
-              <a:rPr lang="ar-SA" sz="2000" b="1"/>
-              <a:t>خط القص: </a:t>
-            </a:r>
-            <a:r>
-              <a:rPr lang="ar-SA" sz="2000"/>
-              <a:t>خط متصل، يُقص عنده الورق.</a:t>
-            </a:r>
-          </a:p>
-          <a:p>
-            <a:pPr/>
-            <a:r>
-              <a:rPr lang="ar-SA" sz="2000" b="1"/>
-              <a:t>خط الطي: </a:t>
-            </a:r>
-            <a:r>
-              <a:rPr lang="ar-SA" sz="2000"/>
-              <a:t>خط متقطع، يُضغط ويُطوى ولا يُقص.</a:t>
+              <a:t>القص: </a:t>
+            </a:r>
+            <a:r>
+              <a:rPr lang="ar-SA" sz="2000"/>
+              <a:t>فصل العبوة عن الورق الزائد بشفرة حادة.</a:t>
             </a:r>
           </a:p>
           <a:p>
@@ -13059,8 +13795,60 @@
               <a:buNone/>
             </a:pPr>
             <a:r>
-              <a:rPr lang="ar-SA" sz="2000"/>
-              <a:t>وما نفعله يدويًا بالمشرط وظهر الشفرة هو تقليد لعمل هذا القالب.</a:t>
+              <a:rPr lang="ar-SA" sz="2000" b="1"/>
+              <a:t>التكسير (Creasing): </a:t>
+            </a:r>
+            <a:r>
+              <a:rPr lang="ar-SA" sz="2000"/>
+              <a:t>ضغط خط الطي في الورق دون قطعه، حتى يُطوى بسهولة. وهو ما نفعله يدويًا بظهر الشفرة.</a:t>
+            </a:r>
+          </a:p>
+          <a:p>
+            <a:pPr marL="0" indent="0">
+              <a:buNone/>
+            </a:pPr>
+            <a:r>
+              <a:rPr lang="ar-SA" sz="2000" b="1"/>
+              <a:t>كيف يعمل القالب؟</a:t>
+            </a:r>
+          </a:p>
+          <a:p>
+            <a:pPr marL="0" indent="0">
+              <a:buNone/>
+            </a:pPr>
+            <a:r>
+              <a:rPr lang="ar-SA" sz="2000" b="1"/>
+              <a:t>١. </a:t>
+            </a:r>
+            <a:r>
+              <a:rPr lang="ar-SA" sz="2000"/>
+              <a:t>يرسم المصمم الدايلاين (Die-line)، وهو رسم العبوة مفرودة: خط متصل للقص، وخط متقطع للطي.</a:t>
+            </a:r>
+          </a:p>
+          <a:p>
+            <a:pPr marL="0" indent="0">
+              <a:buNone/>
+            </a:pPr>
+            <a:r>
+              <a:rPr lang="ar-SA" sz="2000" b="1"/>
+              <a:t>٢. </a:t>
+            </a:r>
+            <a:r>
+              <a:rPr lang="ar-SA" sz="2000"/>
+              <a:t>يُصنع القالب: لوح خشبي تُثبَّت فيه شفرات حادة مكان خطوط القص، ومساطر معدنية غير حادة مكان خطوط الطي.</a:t>
+            </a:r>
+          </a:p>
+          <a:p>
+            <a:pPr marL="0" indent="0">
+              <a:buNone/>
+            </a:pPr>
+            <a:r>
+              <a:rPr lang="ar-SA" sz="2000" b="1"/>
+              <a:t>٣. </a:t>
+            </a:r>
+            <a:r>
+              <a:rPr lang="ar-SA" sz="2000"/>
+              <a:t>يُكبس القالب على الورق، فتخرج العبوة مقصوصة وخطوطها جاهزة للطي.</a:t>
             </a:r>
           </a:p>
         </p:txBody>
@@ -13108,7 +13896,7 @@
           <p:nvPr/>
         </p:nvPicPr>
         <p:blipFill>
-          <a:blip r:embed="rId2"/>
+          <a:blip r:embed="rId3"/>
           <a:stretch>
             <a:fillRect/>
           </a:stretch>

</xml_diff>